<commit_message>
Update course materials with research, labs, and validation guidance
</commit_message>
<xml_diff>
--- a/output/presentations/01-introduction.pptx
+++ b/output/presentations/01-introduction.pptx
@@ -2,22 +2,24 @@
 <file path=ppt/presentation.xml><?xml version="1.0" encoding="utf-8"?>
 <p:presentation xmlns:p="http://schemas.openxmlformats.org/presentationml/2006/main">
   <p:sldMasterIdLst>
-    <p:sldMasterId xmlns:r="http://schemas.openxmlformats.org/officeDocument/2006/relationships" id="2147483648" r:id="R75d3ab90428e4486"/>
+    <p:sldMasterId xmlns:r="http://schemas.openxmlformats.org/officeDocument/2006/relationships" id="2147483648" r:id="Ra96de5c804c34823"/>
   </p:sldMasterIdLst>
   <p:notesMasterIdLst>
-    <p:notesMasterId xmlns:r="http://schemas.openxmlformats.org/officeDocument/2006/relationships" r:id="R971489de992b471b"/>
+    <p:notesMasterId xmlns:r="http://schemas.openxmlformats.org/officeDocument/2006/relationships" r:id="R367161026abd4269"/>
   </p:notesMasterIdLst>
   <p:sldIdLst>
-    <p:sldId xmlns:r="http://schemas.openxmlformats.org/officeDocument/2006/relationships" id="256" r:id="Rf6a3304ec2484e99"/>
-    <p:sldId xmlns:r="http://schemas.openxmlformats.org/officeDocument/2006/relationships" id="257" r:id="R583ac9cce1514f72"/>
-    <p:sldId xmlns:r="http://schemas.openxmlformats.org/officeDocument/2006/relationships" id="258" r:id="R0dfbd5e732744d18"/>
-    <p:sldId xmlns:r="http://schemas.openxmlformats.org/officeDocument/2006/relationships" id="259" r:id="R8e9a994e20934c15"/>
-    <p:sldId xmlns:r="http://schemas.openxmlformats.org/officeDocument/2006/relationships" id="260" r:id="R1a06107fb3d0442f"/>
-    <p:sldId xmlns:r="http://schemas.openxmlformats.org/officeDocument/2006/relationships" id="261" r:id="Rdc23304d070f4ee0"/>
-    <p:sldId xmlns:r="http://schemas.openxmlformats.org/officeDocument/2006/relationships" id="262" r:id="R1074b7c174f34c2f"/>
-    <p:sldId xmlns:r="http://schemas.openxmlformats.org/officeDocument/2006/relationships" id="263" r:id="R5ae5a22f819d4e0c"/>
-    <p:sldId xmlns:r="http://schemas.openxmlformats.org/officeDocument/2006/relationships" id="264" r:id="Rad2b36f98f5d48bc"/>
-    <p:sldId xmlns:r="http://schemas.openxmlformats.org/officeDocument/2006/relationships" id="265" r:id="Rfd56fc99bed04899"/>
+    <p:sldId xmlns:r="http://schemas.openxmlformats.org/officeDocument/2006/relationships" id="256" r:id="R3fb3164ba94c437e"/>
+    <p:sldId xmlns:r="http://schemas.openxmlformats.org/officeDocument/2006/relationships" id="257" r:id="R8c843bfb65cd4b98"/>
+    <p:sldId xmlns:r="http://schemas.openxmlformats.org/officeDocument/2006/relationships" id="258" r:id="Rf5a504d40fb74a13"/>
+    <p:sldId xmlns:r="http://schemas.openxmlformats.org/officeDocument/2006/relationships" id="259" r:id="R280bac3c075f4ff6"/>
+    <p:sldId xmlns:r="http://schemas.openxmlformats.org/officeDocument/2006/relationships" id="260" r:id="R8da2c49cb6974a25"/>
+    <p:sldId xmlns:r="http://schemas.openxmlformats.org/officeDocument/2006/relationships" id="261" r:id="R0a7142ffebfb474a"/>
+    <p:sldId xmlns:r="http://schemas.openxmlformats.org/officeDocument/2006/relationships" id="262" r:id="Rb057ca3d45e74e46"/>
+    <p:sldId xmlns:r="http://schemas.openxmlformats.org/officeDocument/2006/relationships" id="263" r:id="R3a8087ea9c894e01"/>
+    <p:sldId xmlns:r="http://schemas.openxmlformats.org/officeDocument/2006/relationships" id="264" r:id="R88321377a92847c8"/>
+    <p:sldId xmlns:r="http://schemas.openxmlformats.org/officeDocument/2006/relationships" id="265" r:id="Reaa20ffe23864f68"/>
+    <p:sldId xmlns:r="http://schemas.openxmlformats.org/officeDocument/2006/relationships" id="266" r:id="Rb97c7a0a971243ac"/>
+    <p:sldId xmlns:r="http://schemas.openxmlformats.org/officeDocument/2006/relationships" id="267" r:id="Rc5b73afed50b40d8"/>
   </p:sldIdLst>
   <p:sldSz cx="12192000" cy="6858000"/>
   <p:notesSz cx="6858000" cy="9144000"/>
@@ -461,12 +463,52 @@
           </a:p>
           <a:p xmlns:a="http://schemas.openxmlformats.org/drawingml/2006/main">
             <a:r>
+              <a:t>Edition: 2026-09-09</a:t>
+            </a:r>
+          </a:p>
+          <a:p xmlns:a="http://schemas.openxmlformats.org/drawingml/2006/main">
+            <a:r>
+              <a:t/>
+            </a:r>
+          </a:p>
+          <a:p xmlns:a="http://schemas.openxmlformats.org/drawingml/2006/main">
+            <a:r>
               <a:t>[Sources]</a:t>
             </a:r>
           </a:p>
           <a:p xmlns:a="http://schemas.openxmlformats.org/drawingml/2006/main">
             <a:r>
-              <a:t>- Supplied source presentation: 01-introduction.pdf</a:t>
+              <a:t>- Original source presentation: 01-introduction.pdf</a:t>
+            </a:r>
+          </a:p>
+          <a:p xmlns:a="http://schemas.openxmlformats.org/drawingml/2006/main">
+            <a:r>
+              <a:t/>
+            </a:r>
+          </a:p>
+          <a:p xmlns:a="http://schemas.openxmlformats.org/drawingml/2006/main">
+            <a:r>
+              <a:t/>
+            </a:r>
+          </a:p>
+          <a:p xmlns:a="http://schemas.openxmlformats.org/drawingml/2006/main">
+            <a:r>
+              <a:t>[Assessed practice]</a:t>
+            </a:r>
+          </a:p>
+          <a:p xmlns:a="http://schemas.openxmlformats.org/drawingml/2006/main">
+            <a:r>
+              <a:t>Choose a catalog lookup or arithmetic task. Write six cases, including empty input and an unknown item. Define a pass condition and a call limit. Explain what dynamic decision, if any, needs a model.</a:t>
+            </a:r>
+          </a:p>
+          <a:p xmlns:a="http://schemas.openxmlformats.org/drawingml/2006/main">
+            <a:r>
+              <a:t>Acceptance: Submit the cases and an architecture choice before running a model. Credit follows the evidence, including a decision to keep a fixed workflow.</a:t>
+            </a:r>
+          </a:p>
+          <a:p xmlns:a="http://schemas.openxmlformats.org/drawingml/2006/main">
+            <a:r>
+              <a:t>Lab: labs/05_gemini_bounded_tools.ipynb</a:t>
             </a:r>
           </a:p>
         </p:txBody>
@@ -536,6 +578,131 @@
           <a:lstStyle xmlns:a="http://schemas.openxmlformats.org/drawingml/2006/main"/>
           <a:p xmlns:a="http://schemas.openxmlformats.org/drawingml/2006/main">
             <a:r>
+              <a:t>Use as retrieval practice. Ask for an answer that defines, compares, traces, and evaluates.</a:t>
+            </a:r>
+          </a:p>
+          <a:p xmlns:a="http://schemas.openxmlformats.org/drawingml/2006/main">
+            <a:r>
+              <a:t/>
+            </a:r>
+          </a:p>
+          <a:p xmlns:a="http://schemas.openxmlformats.org/drawingml/2006/main">
+            <a:r>
+              <a:t>Edition: 2026-09-09</a:t>
+            </a:r>
+          </a:p>
+          <a:p xmlns:a="http://schemas.openxmlformats.org/drawingml/2006/main">
+            <a:r>
+              <a:t/>
+            </a:r>
+          </a:p>
+          <a:p xmlns:a="http://schemas.openxmlformats.org/drawingml/2006/main">
+            <a:r>
+              <a:t>[Sources]</a:t>
+            </a:r>
+          </a:p>
+          <a:p xmlns:a="http://schemas.openxmlformats.org/drawingml/2006/main">
+            <a:r>
+              <a:t>- Original source presentation: 01-introduction.pdf</a:t>
+            </a:r>
+          </a:p>
+          <a:p xmlns:a="http://schemas.openxmlformats.org/drawingml/2006/main">
+            <a:r>
+              <a:t/>
+            </a:r>
+          </a:p>
+          <a:p xmlns:a="http://schemas.openxmlformats.org/drawingml/2006/main">
+            <a:r>
+              <a:t/>
+            </a:r>
+          </a:p>
+          <a:p xmlns:a="http://schemas.openxmlformats.org/drawingml/2006/main">
+            <a:r>
+              <a:t>[Assessed practice]</a:t>
+            </a:r>
+          </a:p>
+          <a:p xmlns:a="http://schemas.openxmlformats.org/drawingml/2006/main">
+            <a:r>
+              <a:t>Choose a catalog lookup or arithmetic task. Write six cases, including empty input and an unknown item. Define a pass condition and a call limit. Explain what dynamic decision, if any, needs a model.</a:t>
+            </a:r>
+          </a:p>
+          <a:p xmlns:a="http://schemas.openxmlformats.org/drawingml/2006/main">
+            <a:r>
+              <a:t>Acceptance: Submit the cases and an architecture choice before running a model. Credit follows the evidence, including a decision to keep a fixed workflow.</a:t>
+            </a:r>
+          </a:p>
+          <a:p xmlns:a="http://schemas.openxmlformats.org/drawingml/2006/main">
+            <a:r>
+              <a:t>Lab: labs/05_gemini_bounded_tools.ipynb</a:t>
+            </a:r>
+          </a:p>
+        </p:txBody>
+      </p:sp>
+      <p:sp>
+        <p:nvSpPr>
+          <p:cNvPr id="4" name="Slide Number Placeholder 3"/>
+          <p:cNvSpPr>
+            <a:spLocks xmlns:a="http://schemas.openxmlformats.org/drawingml/2006/main" noGrp="1"/>
+          </p:cNvSpPr>
+          <p:nvPr>
+            <p:ph type="sldNum" idx="5"/>
+          </p:nvPr>
+        </p:nvSpPr>
+        <p:spPr/>
+        <p:txBody>
+          <a:bodyPr xmlns:a="http://schemas.openxmlformats.org/drawingml/2006/main"/>
+          <a:lstStyle xmlns:a="http://schemas.openxmlformats.org/drawingml/2006/main"/>
+          <a:p xmlns:a="http://schemas.openxmlformats.org/drawingml/2006/main"/>
+        </p:txBody>
+      </p:sp>
+    </p:spTree>
+  </p:cSld>
+  <p:clrMapOvr>
+    <a:masterClrMapping xmlns:a="http://schemas.openxmlformats.org/drawingml/2006/main"/>
+  </p:clrMapOvr>
+</p:notes>
+</file>
+
+<file path=ppt/notesSlides/notesSlide11.xml><?xml version="1.0" encoding="utf-8"?>
+<p:notes xmlns:p="http://schemas.openxmlformats.org/presentationml/2006/main">
+  <p:cSld>
+    <p:spTree>
+      <p:nvGrpSpPr>
+        <p:cNvPr id="1" name=""/>
+        <p:cNvGrpSpPr/>
+        <p:nvPr/>
+      </p:nvGrpSpPr>
+      <p:grpSpPr>
+        <a:xfrm xmlns:a="http://schemas.openxmlformats.org/drawingml/2006/main"/>
+      </p:grpSpPr>
+      <p:sp>
+        <p:nvSpPr>
+          <p:cNvPr id="2" name="Slide Image Placeholder 1"/>
+          <p:cNvSpPr>
+            <a:spLocks xmlns:a="http://schemas.openxmlformats.org/drawingml/2006/main" noGrp="1"/>
+          </p:cNvSpPr>
+          <p:nvPr>
+            <p:ph type="sldImg" idx="0"/>
+          </p:nvPr>
+        </p:nvSpPr>
+        <p:spPr/>
+      </p:sp>
+      <p:sp>
+        <p:nvSpPr>
+          <p:cNvPr id="3" name="Notes Placeholder 2"/>
+          <p:cNvSpPr>
+            <a:spLocks xmlns:a="http://schemas.openxmlformats.org/drawingml/2006/main" noGrp="1"/>
+          </p:cNvSpPr>
+          <p:nvPr>
+            <p:ph type="body" idx="1"/>
+          </p:nvPr>
+        </p:nvSpPr>
+        <p:spPr/>
+        <p:txBody>
+          <a:bodyPr xmlns:a="http://schemas.openxmlformats.org/drawingml/2006/main"/>
+          <a:lstStyle xmlns:a="http://schemas.openxmlformats.org/drawingml/2006/main"/>
+          <a:p xmlns:a="http://schemas.openxmlformats.org/drawingml/2006/main">
+            <a:r>
               <a:t>Close by restating the four durable ideas and linking forward to the next chapter.</a:t>
             </a:r>
           </a:p>
@@ -546,12 +713,177 @@
           </a:p>
           <a:p xmlns:a="http://schemas.openxmlformats.org/drawingml/2006/main">
             <a:r>
+              <a:t>Edition: 2026-09-09</a:t>
+            </a:r>
+          </a:p>
+          <a:p xmlns:a="http://schemas.openxmlformats.org/drawingml/2006/main">
+            <a:r>
+              <a:t/>
+            </a:r>
+          </a:p>
+          <a:p xmlns:a="http://schemas.openxmlformats.org/drawingml/2006/main">
+            <a:r>
               <a:t>[Sources]</a:t>
             </a:r>
           </a:p>
           <a:p xmlns:a="http://schemas.openxmlformats.org/drawingml/2006/main">
             <a:r>
-              <a:t>- Supplied source presentation: 01-introduction.pdf</a:t>
+              <a:t>- Original source presentation: 01-introduction.pdf</a:t>
+            </a:r>
+          </a:p>
+          <a:p xmlns:a="http://schemas.openxmlformats.org/drawingml/2006/main">
+            <a:r>
+              <a:t/>
+            </a:r>
+          </a:p>
+          <a:p xmlns:a="http://schemas.openxmlformats.org/drawingml/2006/main">
+            <a:r>
+              <a:t/>
+            </a:r>
+          </a:p>
+          <a:p xmlns:a="http://schemas.openxmlformats.org/drawingml/2006/main">
+            <a:r>
+              <a:t>[Assessed practice]</a:t>
+            </a:r>
+          </a:p>
+          <a:p xmlns:a="http://schemas.openxmlformats.org/drawingml/2006/main">
+            <a:r>
+              <a:t>Choose a catalog lookup or arithmetic task. Write six cases, including empty input and an unknown item. Define a pass condition and a call limit. Explain what dynamic decision, if any, needs a model.</a:t>
+            </a:r>
+          </a:p>
+          <a:p xmlns:a="http://schemas.openxmlformats.org/drawingml/2006/main">
+            <a:r>
+              <a:t>Acceptance: Submit the cases and an architecture choice before running a model. Credit follows the evidence, including a decision to keep a fixed workflow.</a:t>
+            </a:r>
+          </a:p>
+          <a:p xmlns:a="http://schemas.openxmlformats.org/drawingml/2006/main">
+            <a:r>
+              <a:t>Lab: labs/05_gemini_bounded_tools.ipynb</a:t>
+            </a:r>
+          </a:p>
+        </p:txBody>
+      </p:sp>
+      <p:sp>
+        <p:nvSpPr>
+          <p:cNvPr id="4" name="Slide Number Placeholder 3"/>
+          <p:cNvSpPr>
+            <a:spLocks xmlns:a="http://schemas.openxmlformats.org/drawingml/2006/main" noGrp="1"/>
+          </p:cNvSpPr>
+          <p:nvPr>
+            <p:ph type="sldNum" idx="5"/>
+          </p:nvPr>
+        </p:nvSpPr>
+        <p:spPr/>
+        <p:txBody>
+          <a:bodyPr xmlns:a="http://schemas.openxmlformats.org/drawingml/2006/main"/>
+          <a:lstStyle xmlns:a="http://schemas.openxmlformats.org/drawingml/2006/main"/>
+          <a:p xmlns:a="http://schemas.openxmlformats.org/drawingml/2006/main"/>
+        </p:txBody>
+      </p:sp>
+    </p:spTree>
+  </p:cSld>
+  <p:clrMapOvr>
+    <a:masterClrMapping xmlns:a="http://schemas.openxmlformats.org/drawingml/2006/main"/>
+  </p:clrMapOvr>
+</p:notes>
+</file>
+
+<file path=ppt/notesSlides/notesSlide12.xml><?xml version="1.0" encoding="utf-8"?>
+<p:notes xmlns:p="http://schemas.openxmlformats.org/presentationml/2006/main">
+  <p:cSld>
+    <p:spTree>
+      <p:nvGrpSpPr>
+        <p:cNvPr id="1" name=""/>
+        <p:cNvGrpSpPr/>
+        <p:nvPr/>
+      </p:nvGrpSpPr>
+      <p:grpSpPr>
+        <a:xfrm xmlns:a="http://schemas.openxmlformats.org/drawingml/2006/main"/>
+      </p:grpSpPr>
+      <p:sp>
+        <p:nvSpPr>
+          <p:cNvPr id="2" name="Slide Image Placeholder 1"/>
+          <p:cNvSpPr>
+            <a:spLocks xmlns:a="http://schemas.openxmlformats.org/drawingml/2006/main" noGrp="1"/>
+          </p:cNvSpPr>
+          <p:nvPr>
+            <p:ph type="sldImg" idx="0"/>
+          </p:nvPr>
+        </p:nvSpPr>
+        <p:spPr/>
+      </p:sp>
+      <p:sp>
+        <p:nvSpPr>
+          <p:cNvPr id="3" name="Notes Placeholder 2"/>
+          <p:cNvSpPr>
+            <a:spLocks xmlns:a="http://schemas.openxmlformats.org/drawingml/2006/main" noGrp="1"/>
+          </p:cNvSpPr>
+          <p:nvPr>
+            <p:ph type="body" idx="1"/>
+          </p:nvPr>
+        </p:nvSpPr>
+        <p:spPr/>
+        <p:txBody>
+          <a:bodyPr xmlns:a="http://schemas.openxmlformats.org/drawingml/2006/main"/>
+          <a:lstStyle xmlns:a="http://schemas.openxmlformats.org/drawingml/2006/main"/>
+          <a:p xmlns:a="http://schemas.openxmlformats.org/drawingml/2006/main">
+            <a:r>
+              <a:t>Assess the submitted evidence with the stated acceptance check. Reading links and limitations follow.</a:t>
+            </a:r>
+          </a:p>
+          <a:p xmlns:a="http://schemas.openxmlformats.org/drawingml/2006/main">
+            <a:r>
+              <a:t/>
+            </a:r>
+          </a:p>
+          <a:p xmlns:a="http://schemas.openxmlformats.org/drawingml/2006/main">
+            <a:r>
+              <a:t>Edition: 2026-09-09</a:t>
+            </a:r>
+          </a:p>
+          <a:p xmlns:a="http://schemas.openxmlformats.org/drawingml/2006/main">
+            <a:r>
+              <a:t/>
+            </a:r>
+          </a:p>
+          <a:p xmlns:a="http://schemas.openxmlformats.org/drawingml/2006/main">
+            <a:r>
+              <a:t>[Sources]</a:t>
+            </a:r>
+          </a:p>
+          <a:p xmlns:a="http://schemas.openxmlformats.org/drawingml/2006/main">
+            <a:r>
+              <a:t>- Original source presentation: 01-introduction.pdf</a:t>
+            </a:r>
+          </a:p>
+          <a:p xmlns:a="http://schemas.openxmlformats.org/drawingml/2006/main">
+            <a:r>
+              <a:t/>
+            </a:r>
+          </a:p>
+          <a:p xmlns:a="http://schemas.openxmlformats.org/drawingml/2006/main">
+            <a:r>
+              <a:t/>
+            </a:r>
+          </a:p>
+          <a:p xmlns:a="http://schemas.openxmlformats.org/drawingml/2006/main">
+            <a:r>
+              <a:t>[Assessed practice]</a:t>
+            </a:r>
+          </a:p>
+          <a:p xmlns:a="http://schemas.openxmlformats.org/drawingml/2006/main">
+            <a:r>
+              <a:t>Choose a catalog lookup or arithmetic task. Write six cases, including empty input and an unknown item. Define a pass condition and a call limit. Explain what dynamic decision, if any, needs a model.</a:t>
+            </a:r>
+          </a:p>
+          <a:p xmlns:a="http://schemas.openxmlformats.org/drawingml/2006/main">
+            <a:r>
+              <a:t>Acceptance: Submit the cases and an architecture choice before running a model. Credit follows the evidence, including a decision to keep a fixed workflow.</a:t>
+            </a:r>
+          </a:p>
+          <a:p xmlns:a="http://schemas.openxmlformats.org/drawingml/2006/main">
+            <a:r>
+              <a:t>Lab: labs/05_gemini_bounded_tools.ipynb</a:t>
             </a:r>
           </a:p>
         </p:txBody>
@@ -631,12 +963,52 @@
           </a:p>
           <a:p xmlns:a="http://schemas.openxmlformats.org/drawingml/2006/main">
             <a:r>
+              <a:t>Edition: 2026-09-09</a:t>
+            </a:r>
+          </a:p>
+          <a:p xmlns:a="http://schemas.openxmlformats.org/drawingml/2006/main">
+            <a:r>
+              <a:t/>
+            </a:r>
+          </a:p>
+          <a:p xmlns:a="http://schemas.openxmlformats.org/drawingml/2006/main">
+            <a:r>
               <a:t>[Sources]</a:t>
             </a:r>
           </a:p>
           <a:p xmlns:a="http://schemas.openxmlformats.org/drawingml/2006/main">
             <a:r>
-              <a:t>- Supplied source presentation: 01-introduction.pdf</a:t>
+              <a:t>- Original source presentation: 01-introduction.pdf</a:t>
+            </a:r>
+          </a:p>
+          <a:p xmlns:a="http://schemas.openxmlformats.org/drawingml/2006/main">
+            <a:r>
+              <a:t/>
+            </a:r>
+          </a:p>
+          <a:p xmlns:a="http://schemas.openxmlformats.org/drawingml/2006/main">
+            <a:r>
+              <a:t/>
+            </a:r>
+          </a:p>
+          <a:p xmlns:a="http://schemas.openxmlformats.org/drawingml/2006/main">
+            <a:r>
+              <a:t>[Assessed practice]</a:t>
+            </a:r>
+          </a:p>
+          <a:p xmlns:a="http://schemas.openxmlformats.org/drawingml/2006/main">
+            <a:r>
+              <a:t>Choose a catalog lookup or arithmetic task. Write six cases, including empty input and an unknown item. Define a pass condition and a call limit. Explain what dynamic decision, if any, needs a model.</a:t>
+            </a:r>
+          </a:p>
+          <a:p xmlns:a="http://schemas.openxmlformats.org/drawingml/2006/main">
+            <a:r>
+              <a:t>Acceptance: Submit the cases and an architecture choice before running a model. Credit follows the evidence, including a decision to keep a fixed workflow.</a:t>
+            </a:r>
+          </a:p>
+          <a:p xmlns:a="http://schemas.openxmlformats.org/drawingml/2006/main">
+            <a:r>
+              <a:t>Lab: labs/05_gemini_bounded_tools.ipynb</a:t>
             </a:r>
           </a:p>
         </p:txBody>
@@ -716,12 +1088,52 @@
           </a:p>
           <a:p xmlns:a="http://schemas.openxmlformats.org/drawingml/2006/main">
             <a:r>
+              <a:t>Edition: 2026-09-09</a:t>
+            </a:r>
+          </a:p>
+          <a:p xmlns:a="http://schemas.openxmlformats.org/drawingml/2006/main">
+            <a:r>
+              <a:t/>
+            </a:r>
+          </a:p>
+          <a:p xmlns:a="http://schemas.openxmlformats.org/drawingml/2006/main">
+            <a:r>
               <a:t>[Sources]</a:t>
             </a:r>
           </a:p>
           <a:p xmlns:a="http://schemas.openxmlformats.org/drawingml/2006/main">
             <a:r>
-              <a:t>- Supplied source presentation: 01-introduction.pdf</a:t>
+              <a:t>- Original source presentation: 01-introduction.pdf</a:t>
+            </a:r>
+          </a:p>
+          <a:p xmlns:a="http://schemas.openxmlformats.org/drawingml/2006/main">
+            <a:r>
+              <a:t/>
+            </a:r>
+          </a:p>
+          <a:p xmlns:a="http://schemas.openxmlformats.org/drawingml/2006/main">
+            <a:r>
+              <a:t/>
+            </a:r>
+          </a:p>
+          <a:p xmlns:a="http://schemas.openxmlformats.org/drawingml/2006/main">
+            <a:r>
+              <a:t>[Assessed practice]</a:t>
+            </a:r>
+          </a:p>
+          <a:p xmlns:a="http://schemas.openxmlformats.org/drawingml/2006/main">
+            <a:r>
+              <a:t>Choose a catalog lookup or arithmetic task. Write six cases, including empty input and an unknown item. Define a pass condition and a call limit. Explain what dynamic decision, if any, needs a model.</a:t>
+            </a:r>
+          </a:p>
+          <a:p xmlns:a="http://schemas.openxmlformats.org/drawingml/2006/main">
+            <a:r>
+              <a:t>Acceptance: Submit the cases and an architecture choice before running a model. Credit follows the evidence, including a decision to keep a fixed workflow.</a:t>
+            </a:r>
+          </a:p>
+          <a:p xmlns:a="http://schemas.openxmlformats.org/drawingml/2006/main">
+            <a:r>
+              <a:t>Lab: labs/05_gemini_bounded_tools.ipynb</a:t>
             </a:r>
           </a:p>
         </p:txBody>
@@ -801,12 +1213,52 @@
           </a:p>
           <a:p xmlns:a="http://schemas.openxmlformats.org/drawingml/2006/main">
             <a:r>
+              <a:t>Edition: 2026-09-09</a:t>
+            </a:r>
+          </a:p>
+          <a:p xmlns:a="http://schemas.openxmlformats.org/drawingml/2006/main">
+            <a:r>
+              <a:t/>
+            </a:r>
+          </a:p>
+          <a:p xmlns:a="http://schemas.openxmlformats.org/drawingml/2006/main">
+            <a:r>
               <a:t>[Sources]</a:t>
             </a:r>
           </a:p>
           <a:p xmlns:a="http://schemas.openxmlformats.org/drawingml/2006/main">
             <a:r>
-              <a:t>- Supplied source presentation: 01-introduction.pdf</a:t>
+              <a:t>- Original source presentation: 01-introduction.pdf</a:t>
+            </a:r>
+          </a:p>
+          <a:p xmlns:a="http://schemas.openxmlformats.org/drawingml/2006/main">
+            <a:r>
+              <a:t/>
+            </a:r>
+          </a:p>
+          <a:p xmlns:a="http://schemas.openxmlformats.org/drawingml/2006/main">
+            <a:r>
+              <a:t/>
+            </a:r>
+          </a:p>
+          <a:p xmlns:a="http://schemas.openxmlformats.org/drawingml/2006/main">
+            <a:r>
+              <a:t>[Assessed practice]</a:t>
+            </a:r>
+          </a:p>
+          <a:p xmlns:a="http://schemas.openxmlformats.org/drawingml/2006/main">
+            <a:r>
+              <a:t>Choose a catalog lookup or arithmetic task. Write six cases, including empty input and an unknown item. Define a pass condition and a call limit. Explain what dynamic decision, if any, needs a model.</a:t>
+            </a:r>
+          </a:p>
+          <a:p xmlns:a="http://schemas.openxmlformats.org/drawingml/2006/main">
+            <a:r>
+              <a:t>Acceptance: Submit the cases and an architecture choice before running a model. Credit follows the evidence, including a decision to keep a fixed workflow.</a:t>
+            </a:r>
+          </a:p>
+          <a:p xmlns:a="http://schemas.openxmlformats.org/drawingml/2006/main">
+            <a:r>
+              <a:t>Lab: labs/05_gemini_bounded_tools.ipynb</a:t>
             </a:r>
           </a:p>
         </p:txBody>
@@ -886,12 +1338,52 @@
           </a:p>
           <a:p xmlns:a="http://schemas.openxmlformats.org/drawingml/2006/main">
             <a:r>
+              <a:t>Edition: 2026-09-09</a:t>
+            </a:r>
+          </a:p>
+          <a:p xmlns:a="http://schemas.openxmlformats.org/drawingml/2006/main">
+            <a:r>
+              <a:t/>
+            </a:r>
+          </a:p>
+          <a:p xmlns:a="http://schemas.openxmlformats.org/drawingml/2006/main">
+            <a:r>
               <a:t>[Sources]</a:t>
             </a:r>
           </a:p>
           <a:p xmlns:a="http://schemas.openxmlformats.org/drawingml/2006/main">
             <a:r>
-              <a:t>- Supplied source presentation: 01-introduction.pdf</a:t>
+              <a:t>- Original source presentation: 01-introduction.pdf</a:t>
+            </a:r>
+          </a:p>
+          <a:p xmlns:a="http://schemas.openxmlformats.org/drawingml/2006/main">
+            <a:r>
+              <a:t/>
+            </a:r>
+          </a:p>
+          <a:p xmlns:a="http://schemas.openxmlformats.org/drawingml/2006/main">
+            <a:r>
+              <a:t/>
+            </a:r>
+          </a:p>
+          <a:p xmlns:a="http://schemas.openxmlformats.org/drawingml/2006/main">
+            <a:r>
+              <a:t>[Assessed practice]</a:t>
+            </a:r>
+          </a:p>
+          <a:p xmlns:a="http://schemas.openxmlformats.org/drawingml/2006/main">
+            <a:r>
+              <a:t>Choose a catalog lookup or arithmetic task. Write six cases, including empty input and an unknown item. Define a pass condition and a call limit. Explain what dynamic decision, if any, needs a model.</a:t>
+            </a:r>
+          </a:p>
+          <a:p xmlns:a="http://schemas.openxmlformats.org/drawingml/2006/main">
+            <a:r>
+              <a:t>Acceptance: Submit the cases and an architecture choice before running a model. Credit follows the evidence, including a decision to keep a fixed workflow.</a:t>
+            </a:r>
+          </a:p>
+          <a:p xmlns:a="http://schemas.openxmlformats.org/drawingml/2006/main">
+            <a:r>
+              <a:t>Lab: labs/05_gemini_bounded_tools.ipynb</a:t>
             </a:r>
           </a:p>
         </p:txBody>
@@ -971,12 +1463,52 @@
           </a:p>
           <a:p xmlns:a="http://schemas.openxmlformats.org/drawingml/2006/main">
             <a:r>
+              <a:t>Edition: 2026-09-09</a:t>
+            </a:r>
+          </a:p>
+          <a:p xmlns:a="http://schemas.openxmlformats.org/drawingml/2006/main">
+            <a:r>
+              <a:t/>
+            </a:r>
+          </a:p>
+          <a:p xmlns:a="http://schemas.openxmlformats.org/drawingml/2006/main">
+            <a:r>
               <a:t>[Sources]</a:t>
             </a:r>
           </a:p>
           <a:p xmlns:a="http://schemas.openxmlformats.org/drawingml/2006/main">
             <a:r>
-              <a:t>- Supplied source presentation: 01-introduction.pdf</a:t>
+              <a:t>- Original source presentation: 01-introduction.pdf</a:t>
+            </a:r>
+          </a:p>
+          <a:p xmlns:a="http://schemas.openxmlformats.org/drawingml/2006/main">
+            <a:r>
+              <a:t/>
+            </a:r>
+          </a:p>
+          <a:p xmlns:a="http://schemas.openxmlformats.org/drawingml/2006/main">
+            <a:r>
+              <a:t/>
+            </a:r>
+          </a:p>
+          <a:p xmlns:a="http://schemas.openxmlformats.org/drawingml/2006/main">
+            <a:r>
+              <a:t>[Assessed practice]</a:t>
+            </a:r>
+          </a:p>
+          <a:p xmlns:a="http://schemas.openxmlformats.org/drawingml/2006/main">
+            <a:r>
+              <a:t>Choose a catalog lookup or arithmetic task. Write six cases, including empty input and an unknown item. Define a pass condition and a call limit. Explain what dynamic decision, if any, needs a model.</a:t>
+            </a:r>
+          </a:p>
+          <a:p xmlns:a="http://schemas.openxmlformats.org/drawingml/2006/main">
+            <a:r>
+              <a:t>Acceptance: Submit the cases and an architecture choice before running a model. Credit follows the evidence, including a decision to keep a fixed workflow.</a:t>
+            </a:r>
+          </a:p>
+          <a:p xmlns:a="http://schemas.openxmlformats.org/drawingml/2006/main">
+            <a:r>
+              <a:t>Lab: labs/05_gemini_bounded_tools.ipynb</a:t>
             </a:r>
           </a:p>
         </p:txBody>
@@ -1056,12 +1588,52 @@
           </a:p>
           <a:p xmlns:a="http://schemas.openxmlformats.org/drawingml/2006/main">
             <a:r>
+              <a:t>Edition: 2026-09-09</a:t>
+            </a:r>
+          </a:p>
+          <a:p xmlns:a="http://schemas.openxmlformats.org/drawingml/2006/main">
+            <a:r>
+              <a:t/>
+            </a:r>
+          </a:p>
+          <a:p xmlns:a="http://schemas.openxmlformats.org/drawingml/2006/main">
+            <a:r>
               <a:t>[Sources]</a:t>
             </a:r>
           </a:p>
           <a:p xmlns:a="http://schemas.openxmlformats.org/drawingml/2006/main">
             <a:r>
-              <a:t>- Supplied source presentation: 01-introduction.pdf</a:t>
+              <a:t>- Original source presentation: 01-introduction.pdf</a:t>
+            </a:r>
+          </a:p>
+          <a:p xmlns:a="http://schemas.openxmlformats.org/drawingml/2006/main">
+            <a:r>
+              <a:t/>
+            </a:r>
+          </a:p>
+          <a:p xmlns:a="http://schemas.openxmlformats.org/drawingml/2006/main">
+            <a:r>
+              <a:t/>
+            </a:r>
+          </a:p>
+          <a:p xmlns:a="http://schemas.openxmlformats.org/drawingml/2006/main">
+            <a:r>
+              <a:t>[Assessed practice]</a:t>
+            </a:r>
+          </a:p>
+          <a:p xmlns:a="http://schemas.openxmlformats.org/drawingml/2006/main">
+            <a:r>
+              <a:t>Choose a catalog lookup or arithmetic task. Write six cases, including empty input and an unknown item. Define a pass condition and a call limit. Explain what dynamic decision, if any, needs a model.</a:t>
+            </a:r>
+          </a:p>
+          <a:p xmlns:a="http://schemas.openxmlformats.org/drawingml/2006/main">
+            <a:r>
+              <a:t>Acceptance: Submit the cases and an architecture choice before running a model. Credit follows the evidence, including a decision to keep a fixed workflow.</a:t>
+            </a:r>
+          </a:p>
+          <a:p xmlns:a="http://schemas.openxmlformats.org/drawingml/2006/main">
+            <a:r>
+              <a:t>Lab: labs/05_gemini_bounded_tools.ipynb</a:t>
             </a:r>
           </a:p>
         </p:txBody>
@@ -1141,12 +1713,52 @@
           </a:p>
           <a:p xmlns:a="http://schemas.openxmlformats.org/drawingml/2006/main">
             <a:r>
+              <a:t>Edition: 2026-09-09</a:t>
+            </a:r>
+          </a:p>
+          <a:p xmlns:a="http://schemas.openxmlformats.org/drawingml/2006/main">
+            <a:r>
+              <a:t/>
+            </a:r>
+          </a:p>
+          <a:p xmlns:a="http://schemas.openxmlformats.org/drawingml/2006/main">
+            <a:r>
               <a:t>[Sources]</a:t>
             </a:r>
           </a:p>
           <a:p xmlns:a="http://schemas.openxmlformats.org/drawingml/2006/main">
             <a:r>
-              <a:t>- Supplied source presentation: 01-introduction.pdf</a:t>
+              <a:t>- Original source presentation: 01-introduction.pdf</a:t>
+            </a:r>
+          </a:p>
+          <a:p xmlns:a="http://schemas.openxmlformats.org/drawingml/2006/main">
+            <a:r>
+              <a:t/>
+            </a:r>
+          </a:p>
+          <a:p xmlns:a="http://schemas.openxmlformats.org/drawingml/2006/main">
+            <a:r>
+              <a:t/>
+            </a:r>
+          </a:p>
+          <a:p xmlns:a="http://schemas.openxmlformats.org/drawingml/2006/main">
+            <a:r>
+              <a:t>[Assessed practice]</a:t>
+            </a:r>
+          </a:p>
+          <a:p xmlns:a="http://schemas.openxmlformats.org/drawingml/2006/main">
+            <a:r>
+              <a:t>Choose a catalog lookup or arithmetic task. Write six cases, including empty input and an unknown item. Define a pass condition and a call limit. Explain what dynamic decision, if any, needs a model.</a:t>
+            </a:r>
+          </a:p>
+          <a:p xmlns:a="http://schemas.openxmlformats.org/drawingml/2006/main">
+            <a:r>
+              <a:t>Acceptance: Submit the cases and an architecture choice before running a model. Credit follows the evidence, including a decision to keep a fixed workflow.</a:t>
+            </a:r>
+          </a:p>
+          <a:p xmlns:a="http://schemas.openxmlformats.org/drawingml/2006/main">
+            <a:r>
+              <a:t>Lab: labs/05_gemini_bounded_tools.ipynb</a:t>
             </a:r>
           </a:p>
         </p:txBody>
@@ -1216,7 +1828,7 @@
           <a:lstStyle xmlns:a="http://schemas.openxmlformats.org/drawingml/2006/main"/>
           <a:p xmlns:a="http://schemas.openxmlformats.org/drawingml/2006/main">
             <a:r>
-              <a:t>Use as retrieval practice. Ask for an answer that defines, compares, traces, and evaluates.</a:t>
+              <a:t>Explain the claim first, then use the numbered points as evidence and design consequences.</a:t>
             </a:r>
           </a:p>
           <a:p xmlns:a="http://schemas.openxmlformats.org/drawingml/2006/main">
@@ -1226,12 +1838,52 @@
           </a:p>
           <a:p xmlns:a="http://schemas.openxmlformats.org/drawingml/2006/main">
             <a:r>
+              <a:t>Edition: 2026-09-09</a:t>
+            </a:r>
+          </a:p>
+          <a:p xmlns:a="http://schemas.openxmlformats.org/drawingml/2006/main">
+            <a:r>
+              <a:t/>
+            </a:r>
+          </a:p>
+          <a:p xmlns:a="http://schemas.openxmlformats.org/drawingml/2006/main">
+            <a:r>
               <a:t>[Sources]</a:t>
             </a:r>
           </a:p>
           <a:p xmlns:a="http://schemas.openxmlformats.org/drawingml/2006/main">
             <a:r>
-              <a:t>- Supplied source presentation: 01-introduction.pdf</a:t>
+              <a:t>- Original source presentation: 01-introduction.pdf</a:t>
+            </a:r>
+          </a:p>
+          <a:p xmlns:a="http://schemas.openxmlformats.org/drawingml/2006/main">
+            <a:r>
+              <a:t/>
+            </a:r>
+          </a:p>
+          <a:p xmlns:a="http://schemas.openxmlformats.org/drawingml/2006/main">
+            <a:r>
+              <a:t/>
+            </a:r>
+          </a:p>
+          <a:p xmlns:a="http://schemas.openxmlformats.org/drawingml/2006/main">
+            <a:r>
+              <a:t>[Assessed practice]</a:t>
+            </a:r>
+          </a:p>
+          <a:p xmlns:a="http://schemas.openxmlformats.org/drawingml/2006/main">
+            <a:r>
+              <a:t>Choose a catalog lookup or arithmetic task. Write six cases, including empty input and an unknown item. Define a pass condition and a call limit. Explain what dynamic decision, if any, needs a model.</a:t>
+            </a:r>
+          </a:p>
+          <a:p xmlns:a="http://schemas.openxmlformats.org/drawingml/2006/main">
+            <a:r>
+              <a:t>Acceptance: Submit the cases and an architecture choice before running a model. Credit follows the evidence, including a decision to keep a fixed workflow.</a:t>
+            </a:r>
+          </a:p>
+          <a:p xmlns:a="http://schemas.openxmlformats.org/drawingml/2006/main">
+            <a:r>
+              <a:t>Lab: labs/05_gemini_bounded_tools.ipynb</a:t>
             </a:r>
           </a:p>
         </p:txBody>
@@ -1299,7 +1951,7 @@
   </p:cSld>
   <p:clrMap bg1="lt1" tx1="dk1" bg2="lt2" tx2="dk2" accent1="accent1" accent2="accent2" accent3="accent3" accent4="accent4" accent5="accent5" accent6="accent6" hlink="hlink" folHlink="folHlink"/>
   <p:sldLayoutIdLst>
-    <p:sldLayoutId xmlns:r="http://schemas.openxmlformats.org/officeDocument/2006/relationships" id="2147483649" r:id="R38a1136c79134500"/>
+    <p:sldLayoutId xmlns:r="http://schemas.openxmlformats.org/officeDocument/2006/relationships" id="2147483649" r:id="R7f1e869b1c9845dc"/>
   </p:sldLayoutIdLst>
   <p:txStyles>
     <p:titleStyle>
@@ -1850,7 +2502,7 @@
           <p:cNvPr id="8" name="title-accent">
             <a:extLst xmlns:a="http://schemas.openxmlformats.org/drawingml/2006/main">
               <a:ext uri="{FF2B5EF4-FFF2-40B4-BE49-F238E27FC236}">
-                <a16:creationId xmlns:a16="http://schemas.microsoft.com/office/drawing/2014/main" id="{2540DDA7-0850-4006-856F-7FDC00E909B0}"/>
+                <a16:creationId xmlns:a16="http://schemas.microsoft.com/office/drawing/2014/main" id="{FDE712B7-98F0-47EF-9A04-4F707C3BB280}"/>
               </a:ext>
             </a:extLst>
           </p:cNvPr>
@@ -1883,7 +2535,7 @@
           <p:cNvPr id="2" name="course-title">
             <a:extLst xmlns:a="http://schemas.openxmlformats.org/drawingml/2006/main">
               <a:ext uri="{FF2B5EF4-FFF2-40B4-BE49-F238E27FC236}">
-                <a16:creationId xmlns:a16="http://schemas.microsoft.com/office/drawing/2014/main" id="{1656617E-C188-4B98-8D0A-26BF2EA71756}"/>
+                <a16:creationId xmlns:a16="http://schemas.microsoft.com/office/drawing/2014/main" id="{C6D5D8ED-01D6-4FC2-8683-93BC8DAD76D0}"/>
               </a:ext>
             </a:extLst>
           </p:cNvPr>
@@ -1941,7 +2593,7 @@
           <p:cNvPr id="3" name="chapter-number">
             <a:extLst xmlns:a="http://schemas.openxmlformats.org/drawingml/2006/main">
               <a:ext uri="{FF2B5EF4-FFF2-40B4-BE49-F238E27FC236}">
-                <a16:creationId xmlns:a16="http://schemas.microsoft.com/office/drawing/2014/main" id="{CA38835F-EF95-42D4-A9A0-DB5586637956}"/>
+                <a16:creationId xmlns:a16="http://schemas.microsoft.com/office/drawing/2014/main" id="{DECEAF0D-E204-4D64-A9A1-6CFBBF571440}"/>
               </a:ext>
             </a:extLst>
           </p:cNvPr>
@@ -1999,7 +2651,7 @@
           <p:cNvPr id="4" name="deck-title">
             <a:extLst xmlns:a="http://schemas.openxmlformats.org/drawingml/2006/main">
               <a:ext uri="{FF2B5EF4-FFF2-40B4-BE49-F238E27FC236}">
-                <a16:creationId xmlns:a16="http://schemas.microsoft.com/office/drawing/2014/main" id="{CA42DB0C-ED51-4E68-97F6-7382FAD78544}"/>
+                <a16:creationId xmlns:a16="http://schemas.microsoft.com/office/drawing/2014/main" id="{B87267A4-BB1D-45D4-801D-29BA74C99A2F}"/>
               </a:ext>
             </a:extLst>
           </p:cNvPr>
@@ -2057,7 +2709,7 @@
           <p:cNvPr id="5" name="deck-thesis">
             <a:extLst xmlns:a="http://schemas.openxmlformats.org/drawingml/2006/main">
               <a:ext uri="{FF2B5EF4-FFF2-40B4-BE49-F238E27FC236}">
-                <a16:creationId xmlns:a16="http://schemas.microsoft.com/office/drawing/2014/main" id="{34D09455-83F7-4A30-A91F-04FCB75F649B}"/>
+                <a16:creationId xmlns:a16="http://schemas.microsoft.com/office/drawing/2014/main" id="{50FBDC0F-A6B8-480F-813B-BA3E7E5CB841}"/>
               </a:ext>
             </a:extLst>
           </p:cNvPr>
@@ -2115,7 +2767,7 @@
           <p:cNvPr id="6" name="title-marker">
             <a:extLst xmlns:a="http://schemas.openxmlformats.org/drawingml/2006/main">
               <a:ext uri="{FF2B5EF4-FFF2-40B4-BE49-F238E27FC236}">
-                <a16:creationId xmlns:a16="http://schemas.microsoft.com/office/drawing/2014/main" id="{B6BC9F12-A562-4853-A4A8-39FAFD6151BF}"/>
+                <a16:creationId xmlns:a16="http://schemas.microsoft.com/office/drawing/2014/main" id="{E20BFF32-B3BF-4A1A-8F65-D937045D7A77}"/>
               </a:ext>
             </a:extLst>
           </p:cNvPr>
@@ -2148,7 +2800,7 @@
           <p:cNvPr id="7" name="title-marker-text">
             <a:extLst xmlns:a="http://schemas.openxmlformats.org/drawingml/2006/main">
               <a:ext uri="{FF2B5EF4-FFF2-40B4-BE49-F238E27FC236}">
-                <a16:creationId xmlns:a16="http://schemas.microsoft.com/office/drawing/2014/main" id="{E65082A9-38B1-4F60-BB66-D70F94460A42}"/>
+                <a16:creationId xmlns:a16="http://schemas.microsoft.com/office/drawing/2014/main" id="{A68E46C1-0AF4-4C6F-8F17-CC13E4AD38EB}"/>
               </a:ext>
             </a:extLst>
           </p:cNvPr>
@@ -2227,7 +2879,7 @@
     </p:spTree>
     <p:extLst>
       <p:ext uri="{BB962C8B-B14F-4D97-AF65-F5344CB8AC3E}">
-        <p14:creationId xmlns:p14="http://schemas.microsoft.com/office/powerpoint/2010/main" val="299658575"/>
+        <p14:creationId xmlns:p14="http://schemas.microsoft.com/office/powerpoint/2010/main" val="1280713"/>
       </p:ext>
     </p:extLst>
   </p:cSld>
@@ -2235,6 +2887,996 @@
 </file>
 
 <file path=ppt/slides/slide10.xml><?xml version="1.0" encoding="utf-8"?>
+<p:sld xmlns:p="http://schemas.openxmlformats.org/presentationml/2006/main">
+  <p:cSld>
+    <p:bg>
+      <p:bgPr>
+        <a:solidFill xmlns:a="http://schemas.openxmlformats.org/drawingml/2006/main">
+          <a:srgbClr val="FFFFFF"/>
+        </a:solidFill>
+      </p:bgPr>
+    </p:bg>
+    <p:spTree>
+      <p:nvGrpSpPr>
+        <p:cNvPr id="1" name=""/>
+        <p:cNvGrpSpPr/>
+        <p:nvPr/>
+      </p:nvGrpSpPr>
+      <p:grpSpPr>
+        <a:xfrm xmlns:a="http://schemas.openxmlformats.org/drawingml/2006/main"/>
+      </p:grpSpPr>
+      <p:sp>
+        <p:nvSpPr>
+          <p:cNvPr id="18" name="accent-line">
+            <a:extLst xmlns:a="http://schemas.openxmlformats.org/drawingml/2006/main">
+              <a:ext uri="{FF2B5EF4-FFF2-40B4-BE49-F238E27FC236}">
+                <a16:creationId xmlns:a16="http://schemas.microsoft.com/office/drawing/2014/main" id="{C8A32405-19B1-4525-B22B-C97AD64F3DB9}"/>
+              </a:ext>
+            </a:extLst>
+          </p:cNvPr>
+          <p:cNvSpPr>
+            <a:spLocks xmlns:a="http://schemas.openxmlformats.org/drawingml/2006/main" noGrp="1"/>
+          </p:cNvSpPr>
+          <p:nvPr/>
+        </p:nvSpPr>
+        <p:spPr>
+          <a:xfrm xmlns:a="http://schemas.openxmlformats.org/drawingml/2006/main">
+            <a:off x="390525" y="304800"/>
+            <a:ext cx="11410950" cy="66675"/>
+          </a:xfrm>
+          <a:prstGeom xmlns:a="http://schemas.openxmlformats.org/drawingml/2006/main" prst="rect">
+            <a:avLst/>
+          </a:prstGeom>
+          <a:solidFill xmlns:a="http://schemas.openxmlformats.org/drawingml/2006/main">
+            <a:srgbClr val="B9F15B"/>
+          </a:solidFill>
+          <a:ln xmlns:a="http://schemas.openxmlformats.org/drawingml/2006/main" w="0">
+            <a:solidFill>
+              <a:srgbClr val="B9F15B"/>
+            </a:solidFill>
+            <a:prstDash val="solid"/>
+          </a:ln>
+        </p:spPr>
+      </p:sp>
+      <p:sp>
+        <p:nvSpPr>
+          <p:cNvPr id="2" name="chapter-label">
+            <a:extLst xmlns:a="http://schemas.openxmlformats.org/drawingml/2006/main">
+              <a:ext uri="{FF2B5EF4-FFF2-40B4-BE49-F238E27FC236}">
+                <a16:creationId xmlns:a16="http://schemas.microsoft.com/office/drawing/2014/main" id="{985B5F21-2514-4B8C-AF61-B80934CA7789}"/>
+              </a:ext>
+            </a:extLst>
+          </p:cNvPr>
+          <p:cNvSpPr>
+            <a:spLocks xmlns:a="http://schemas.openxmlformats.org/drawingml/2006/main" noGrp="1"/>
+          </p:cNvSpPr>
+          <p:nvPr/>
+        </p:nvSpPr>
+        <p:spPr>
+          <a:xfrm xmlns:a="http://schemas.openxmlformats.org/drawingml/2006/main">
+            <a:off x="390525" y="466725"/>
+            <a:ext cx="4953000" cy="323850"/>
+          </a:xfrm>
+          <a:prstGeom xmlns:a="http://schemas.openxmlformats.org/drawingml/2006/main" prst="rect">
+            <a:avLst/>
+          </a:prstGeom>
+          <a:noFill xmlns:a="http://schemas.openxmlformats.org/drawingml/2006/main"/>
+          <a:ln xmlns:a="http://schemas.openxmlformats.org/drawingml/2006/main" w="0">
+            <a:noFill/>
+            <a:prstDash val="solid"/>
+          </a:ln>
+        </p:spPr>
+        <p:txBody>
+          <a:bodyPr xmlns:a="http://schemas.openxmlformats.org/drawingml/2006/main" anchor="t">
+            <a:noAutofit/>
+          </a:bodyPr>
+          <a:lstStyle xmlns:a="http://schemas.openxmlformats.org/drawingml/2006/main"/>
+          <a:p xmlns:a="http://schemas.openxmlformats.org/drawingml/2006/main">
+            <a:pPr algn="l">
+              <a:defRPr sz="1275" b="1">
+                <a:solidFill>
+                  <a:srgbClr val="5B5B57"/>
+                </a:solidFill>
+                <a:latin typeface="Helvetica Neue"/>
+                <a:ea typeface="Helvetica Neue"/>
+                <a:cs typeface="Helvetica Neue"/>
+              </a:defRPr>
+            </a:pPr>
+            <a:r>
+              <a:rPr sz="1275" b="1">
+                <a:solidFill>
+                  <a:srgbClr val="5B5B57"/>
+                </a:solidFill>
+                <a:latin typeface="Helvetica Neue"/>
+                <a:ea typeface="Helvetica Neue"/>
+                <a:cs typeface="Helvetica Neue"/>
+              </a:rPr>
+              <a:t>EXAM CHECK  /  01</a:t>
+            </a:r>
+          </a:p>
+        </p:txBody>
+      </p:sp>
+      <p:sp>
+        <p:nvSpPr>
+          <p:cNvPr id="3" name="slide-number">
+            <a:extLst xmlns:a="http://schemas.openxmlformats.org/drawingml/2006/main">
+              <a:ext uri="{FF2B5EF4-FFF2-40B4-BE49-F238E27FC236}">
+                <a16:creationId xmlns:a16="http://schemas.microsoft.com/office/drawing/2014/main" id="{2C32B1E9-FFBC-4619-BB96-D2BE1FE55B42}"/>
+              </a:ext>
+            </a:extLst>
+          </p:cNvPr>
+          <p:cNvSpPr>
+            <a:spLocks xmlns:a="http://schemas.openxmlformats.org/drawingml/2006/main" noGrp="1"/>
+          </p:cNvSpPr>
+          <p:nvPr/>
+        </p:nvSpPr>
+        <p:spPr>
+          <a:xfrm xmlns:a="http://schemas.openxmlformats.org/drawingml/2006/main">
+            <a:off x="11049000" y="6286500"/>
+            <a:ext cx="742950" cy="266700"/>
+          </a:xfrm>
+          <a:prstGeom xmlns:a="http://schemas.openxmlformats.org/drawingml/2006/main" prst="rect">
+            <a:avLst/>
+          </a:prstGeom>
+          <a:noFill xmlns:a="http://schemas.openxmlformats.org/drawingml/2006/main"/>
+          <a:ln xmlns:a="http://schemas.openxmlformats.org/drawingml/2006/main" w="0">
+            <a:noFill/>
+            <a:prstDash val="solid"/>
+          </a:ln>
+        </p:spPr>
+        <p:txBody>
+          <a:bodyPr xmlns:a="http://schemas.openxmlformats.org/drawingml/2006/main" anchor="t">
+            <a:noAutofit/>
+          </a:bodyPr>
+          <a:lstStyle xmlns:a="http://schemas.openxmlformats.org/drawingml/2006/main"/>
+          <a:p xmlns:a="http://schemas.openxmlformats.org/drawingml/2006/main">
+            <a:pPr algn="r">
+              <a:defRPr sz="1200" b="0">
+                <a:solidFill>
+                  <a:srgbClr val="5B5B57"/>
+                </a:solidFill>
+                <a:latin typeface="Helvetica Neue"/>
+                <a:ea typeface="Helvetica Neue"/>
+                <a:cs typeface="Helvetica Neue"/>
+              </a:defRPr>
+            </a:pPr>
+            <a:r>
+              <a:rPr sz="1200" b="0">
+                <a:solidFill>
+                  <a:srgbClr val="5B5B57"/>
+                </a:solidFill>
+                <a:latin typeface="Helvetica Neue"/>
+                <a:ea typeface="Helvetica Neue"/>
+                <a:cs typeface="Helvetica Neue"/>
+              </a:rPr>
+              <a:t>10</a:t>
+            </a:r>
+          </a:p>
+        </p:txBody>
+      </p:sp>
+      <p:sp>
+        <p:nvSpPr>
+          <p:cNvPr id="4" name="chapter-footer">
+            <a:extLst xmlns:a="http://schemas.openxmlformats.org/drawingml/2006/main">
+              <a:ext uri="{FF2B5EF4-FFF2-40B4-BE49-F238E27FC236}">
+                <a16:creationId xmlns:a16="http://schemas.microsoft.com/office/drawing/2014/main" id="{0F9F1768-3493-4F4C-96E7-C38F269E60D4}"/>
+              </a:ext>
+            </a:extLst>
+          </p:cNvPr>
+          <p:cNvSpPr>
+            <a:spLocks xmlns:a="http://schemas.openxmlformats.org/drawingml/2006/main" noGrp="1"/>
+          </p:cNvSpPr>
+          <p:nvPr/>
+        </p:nvSpPr>
+        <p:spPr>
+          <a:xfrm xmlns:a="http://schemas.openxmlformats.org/drawingml/2006/main">
+            <a:off x="390525" y="6286500"/>
+            <a:ext cx="8191500" cy="266700"/>
+          </a:xfrm>
+          <a:prstGeom xmlns:a="http://schemas.openxmlformats.org/drawingml/2006/main" prst="rect">
+            <a:avLst/>
+          </a:prstGeom>
+          <a:noFill xmlns:a="http://schemas.openxmlformats.org/drawingml/2006/main"/>
+          <a:ln xmlns:a="http://schemas.openxmlformats.org/drawingml/2006/main" w="0">
+            <a:noFill/>
+            <a:prstDash val="solid"/>
+          </a:ln>
+        </p:spPr>
+        <p:txBody>
+          <a:bodyPr xmlns:a="http://schemas.openxmlformats.org/drawingml/2006/main" anchor="t">
+            <a:noAutofit/>
+          </a:bodyPr>
+          <a:lstStyle xmlns:a="http://schemas.openxmlformats.org/drawingml/2006/main"/>
+          <a:p xmlns:a="http://schemas.openxmlformats.org/drawingml/2006/main">
+            <a:pPr algn="l">
+              <a:defRPr sz="1125" b="0">
+                <a:solidFill>
+                  <a:srgbClr val="5B5B57"/>
+                </a:solidFill>
+                <a:latin typeface="Helvetica Neue"/>
+                <a:ea typeface="Helvetica Neue"/>
+                <a:cs typeface="Helvetica Neue"/>
+              </a:defRPr>
+            </a:pPr>
+            <a:r>
+              <a:rPr sz="1125" b="0">
+                <a:solidFill>
+                  <a:srgbClr val="5B5B57"/>
+                </a:solidFill>
+                <a:latin typeface="Helvetica Neue"/>
+                <a:ea typeface="Helvetica Neue"/>
+                <a:cs typeface="Helvetica Neue"/>
+              </a:rPr>
+              <a:t>From Language Models to Agents</a:t>
+            </a:r>
+          </a:p>
+        </p:txBody>
+      </p:sp>
+      <p:sp>
+        <p:nvSpPr>
+          <p:cNvPr id="5" name="exam-title">
+            <a:extLst xmlns:a="http://schemas.openxmlformats.org/drawingml/2006/main">
+              <a:ext uri="{FF2B5EF4-FFF2-40B4-BE49-F238E27FC236}">
+                <a16:creationId xmlns:a16="http://schemas.microsoft.com/office/drawing/2014/main" id="{EC191E53-F537-439C-90EE-BD2854034959}"/>
+              </a:ext>
+            </a:extLst>
+          </p:cNvPr>
+          <p:cNvSpPr>
+            <a:spLocks xmlns:a="http://schemas.openxmlformats.org/drawingml/2006/main" noGrp="1"/>
+          </p:cNvSpPr>
+          <p:nvPr/>
+        </p:nvSpPr>
+        <p:spPr>
+          <a:xfrm xmlns:a="http://schemas.openxmlformats.org/drawingml/2006/main">
+            <a:off x="390525" y="981075"/>
+            <a:ext cx="10668000" cy="781050"/>
+          </a:xfrm>
+          <a:prstGeom xmlns:a="http://schemas.openxmlformats.org/drawingml/2006/main" prst="rect">
+            <a:avLst/>
+          </a:prstGeom>
+          <a:noFill xmlns:a="http://schemas.openxmlformats.org/drawingml/2006/main"/>
+          <a:ln xmlns:a="http://schemas.openxmlformats.org/drawingml/2006/main" w="0">
+            <a:noFill/>
+            <a:prstDash val="solid"/>
+          </a:ln>
+        </p:spPr>
+        <p:txBody>
+          <a:bodyPr xmlns:a="http://schemas.openxmlformats.org/drawingml/2006/main" anchor="t">
+            <a:noAutofit/>
+          </a:bodyPr>
+          <a:lstStyle xmlns:a="http://schemas.openxmlformats.org/drawingml/2006/main"/>
+          <a:p xmlns:a="http://schemas.openxmlformats.org/drawingml/2006/main">
+            <a:pPr algn="l">
+              <a:defRPr sz="3150" b="1">
+                <a:solidFill>
+                  <a:srgbClr val="111111"/>
+                </a:solidFill>
+                <a:latin typeface="Helvetica Neue"/>
+                <a:ea typeface="Helvetica Neue"/>
+                <a:cs typeface="Helvetica Neue"/>
+              </a:defRPr>
+            </a:pPr>
+            <a:r>
+              <a:rPr sz="3150" b="1">
+                <a:solidFill>
+                  <a:srgbClr val="111111"/>
+                </a:solidFill>
+                <a:latin typeface="Helvetica Neue"/>
+                <a:ea typeface="Helvetica Neue"/>
+                <a:cs typeface="Helvetica Neue"/>
+              </a:rPr>
+              <a:t>Can you answer these without notes?</a:t>
+            </a:r>
+          </a:p>
+        </p:txBody>
+      </p:sp>
+      <p:sp>
+        <p:nvSpPr>
+          <p:cNvPr id="6" name="exam-number-1">
+            <a:extLst xmlns:a="http://schemas.openxmlformats.org/drawingml/2006/main">
+              <a:ext uri="{FF2B5EF4-FFF2-40B4-BE49-F238E27FC236}">
+                <a16:creationId xmlns:a16="http://schemas.microsoft.com/office/drawing/2014/main" id="{83D46B02-483A-4CBA-8126-11166D322CD8}"/>
+              </a:ext>
+            </a:extLst>
+          </p:cNvPr>
+          <p:cNvSpPr>
+            <a:spLocks xmlns:a="http://schemas.openxmlformats.org/drawingml/2006/main" noGrp="1"/>
+          </p:cNvSpPr>
+          <p:nvPr/>
+        </p:nvSpPr>
+        <p:spPr>
+          <a:xfrm xmlns:a="http://schemas.openxmlformats.org/drawingml/2006/main">
+            <a:off x="390525" y="2238375"/>
+            <a:ext cx="590550" cy="400050"/>
+          </a:xfrm>
+          <a:prstGeom xmlns:a="http://schemas.openxmlformats.org/drawingml/2006/main" prst="rect">
+            <a:avLst/>
+          </a:prstGeom>
+          <a:noFill xmlns:a="http://schemas.openxmlformats.org/drawingml/2006/main"/>
+          <a:ln xmlns:a="http://schemas.openxmlformats.org/drawingml/2006/main" w="0">
+            <a:noFill/>
+            <a:prstDash val="solid"/>
+          </a:ln>
+        </p:spPr>
+        <p:txBody>
+          <a:bodyPr xmlns:a="http://schemas.openxmlformats.org/drawingml/2006/main" anchor="t">
+            <a:noAutofit/>
+          </a:bodyPr>
+          <a:lstStyle xmlns:a="http://schemas.openxmlformats.org/drawingml/2006/main"/>
+          <a:p xmlns:a="http://schemas.openxmlformats.org/drawingml/2006/main">
+            <a:pPr algn="l">
+              <a:defRPr sz="1725" b="1">
+                <a:solidFill>
+                  <a:srgbClr val="B9F15B"/>
+                </a:solidFill>
+                <a:latin typeface="Helvetica Neue"/>
+                <a:ea typeface="Helvetica Neue"/>
+                <a:cs typeface="Helvetica Neue"/>
+              </a:defRPr>
+            </a:pPr>
+            <a:r>
+              <a:rPr sz="1725" b="1">
+                <a:solidFill>
+                  <a:srgbClr val="B9F15B"/>
+                </a:solidFill>
+                <a:latin typeface="Helvetica Neue"/>
+                <a:ea typeface="Helvetica Neue"/>
+                <a:cs typeface="Helvetica Neue"/>
+              </a:rPr>
+              <a:t>01</a:t>
+            </a:r>
+          </a:p>
+        </p:txBody>
+      </p:sp>
+      <p:sp>
+        <p:nvSpPr>
+          <p:cNvPr id="7" name="exam-question-1">
+            <a:extLst xmlns:a="http://schemas.openxmlformats.org/drawingml/2006/main">
+              <a:ext uri="{FF2B5EF4-FFF2-40B4-BE49-F238E27FC236}">
+                <a16:creationId xmlns:a16="http://schemas.microsoft.com/office/drawing/2014/main" id="{16040E7B-51F3-467A-8768-E259E6ED2923}"/>
+              </a:ext>
+            </a:extLst>
+          </p:cNvPr>
+          <p:cNvSpPr>
+            <a:spLocks xmlns:a="http://schemas.openxmlformats.org/drawingml/2006/main" noGrp="1"/>
+          </p:cNvSpPr>
+          <p:nvPr/>
+        </p:nvSpPr>
+        <p:spPr>
+          <a:xfrm xmlns:a="http://schemas.openxmlformats.org/drawingml/2006/main">
+            <a:off x="1076325" y="2238375"/>
+            <a:ext cx="4762500" cy="895350"/>
+          </a:xfrm>
+          <a:prstGeom xmlns:a="http://schemas.openxmlformats.org/drawingml/2006/main" prst="rect">
+            <a:avLst/>
+          </a:prstGeom>
+          <a:noFill xmlns:a="http://schemas.openxmlformats.org/drawingml/2006/main"/>
+          <a:ln xmlns:a="http://schemas.openxmlformats.org/drawingml/2006/main" w="0">
+            <a:noFill/>
+            <a:prstDash val="solid"/>
+          </a:ln>
+        </p:spPr>
+        <p:txBody>
+          <a:bodyPr xmlns:a="http://schemas.openxmlformats.org/drawingml/2006/main" anchor="t">
+            <a:normAutofit fontScale="100000"/>
+          </a:bodyPr>
+          <a:lstStyle xmlns:a="http://schemas.openxmlformats.org/drawingml/2006/main"/>
+          <a:p xmlns:a="http://schemas.openxmlformats.org/drawingml/2006/main">
+            <a:pPr algn="l">
+              <a:defRPr sz="1575" b="1">
+                <a:solidFill>
+                  <a:srgbClr val="111111"/>
+                </a:solidFill>
+                <a:latin typeface="Helvetica Neue"/>
+                <a:ea typeface="Helvetica Neue"/>
+                <a:cs typeface="Helvetica Neue"/>
+              </a:defRPr>
+            </a:pPr>
+            <a:r>
+              <a:rPr sz="1575" b="1">
+                <a:solidFill>
+                  <a:srgbClr val="111111"/>
+                </a:solidFill>
+                <a:latin typeface="Helvetica Neue"/>
+                <a:ea typeface="Helvetica Neue"/>
+                <a:cs typeface="Helvetica Neue"/>
+              </a:rPr>
+              <a:t>Give the classical definition of an agent and reframe it for an LLM system.</a:t>
+            </a:r>
+          </a:p>
+        </p:txBody>
+      </p:sp>
+      <p:sp>
+        <p:nvSpPr>
+          <p:cNvPr id="8" name="exam-number-2">
+            <a:extLst xmlns:a="http://schemas.openxmlformats.org/drawingml/2006/main">
+              <a:ext uri="{FF2B5EF4-FFF2-40B4-BE49-F238E27FC236}">
+                <a16:creationId xmlns:a16="http://schemas.microsoft.com/office/drawing/2014/main" id="{7AB760A6-F610-4C16-83C8-F9C23F126EDE}"/>
+              </a:ext>
+            </a:extLst>
+          </p:cNvPr>
+          <p:cNvSpPr>
+            <a:spLocks xmlns:a="http://schemas.openxmlformats.org/drawingml/2006/main" noGrp="1"/>
+          </p:cNvSpPr>
+          <p:nvPr/>
+        </p:nvSpPr>
+        <p:spPr>
+          <a:xfrm xmlns:a="http://schemas.openxmlformats.org/drawingml/2006/main">
+            <a:off x="6191250" y="2238375"/>
+            <a:ext cx="590550" cy="400050"/>
+          </a:xfrm>
+          <a:prstGeom xmlns:a="http://schemas.openxmlformats.org/drawingml/2006/main" prst="rect">
+            <a:avLst/>
+          </a:prstGeom>
+          <a:noFill xmlns:a="http://schemas.openxmlformats.org/drawingml/2006/main"/>
+          <a:ln xmlns:a="http://schemas.openxmlformats.org/drawingml/2006/main" w="0">
+            <a:noFill/>
+            <a:prstDash val="solid"/>
+          </a:ln>
+        </p:spPr>
+        <p:txBody>
+          <a:bodyPr xmlns:a="http://schemas.openxmlformats.org/drawingml/2006/main" anchor="t">
+            <a:noAutofit/>
+          </a:bodyPr>
+          <a:lstStyle xmlns:a="http://schemas.openxmlformats.org/drawingml/2006/main"/>
+          <a:p xmlns:a="http://schemas.openxmlformats.org/drawingml/2006/main">
+            <a:pPr algn="l">
+              <a:defRPr sz="1725" b="1">
+                <a:solidFill>
+                  <a:srgbClr val="B9F15B"/>
+                </a:solidFill>
+                <a:latin typeface="Helvetica Neue"/>
+                <a:ea typeface="Helvetica Neue"/>
+                <a:cs typeface="Helvetica Neue"/>
+              </a:defRPr>
+            </a:pPr>
+            <a:r>
+              <a:rPr sz="1725" b="1">
+                <a:solidFill>
+                  <a:srgbClr val="B9F15B"/>
+                </a:solidFill>
+                <a:latin typeface="Helvetica Neue"/>
+                <a:ea typeface="Helvetica Neue"/>
+                <a:cs typeface="Helvetica Neue"/>
+              </a:rPr>
+              <a:t>02</a:t>
+            </a:r>
+          </a:p>
+        </p:txBody>
+      </p:sp>
+      <p:sp>
+        <p:nvSpPr>
+          <p:cNvPr id="9" name="exam-question-2">
+            <a:extLst xmlns:a="http://schemas.openxmlformats.org/drawingml/2006/main">
+              <a:ext uri="{FF2B5EF4-FFF2-40B4-BE49-F238E27FC236}">
+                <a16:creationId xmlns:a16="http://schemas.microsoft.com/office/drawing/2014/main" id="{85552C38-F542-4D56-B2F5-A0545128A245}"/>
+              </a:ext>
+            </a:extLst>
+          </p:cNvPr>
+          <p:cNvSpPr>
+            <a:spLocks xmlns:a="http://schemas.openxmlformats.org/drawingml/2006/main" noGrp="1"/>
+          </p:cNvSpPr>
+          <p:nvPr/>
+        </p:nvSpPr>
+        <p:spPr>
+          <a:xfrm xmlns:a="http://schemas.openxmlformats.org/drawingml/2006/main">
+            <a:off x="6877050" y="2238375"/>
+            <a:ext cx="4762500" cy="895350"/>
+          </a:xfrm>
+          <a:prstGeom xmlns:a="http://schemas.openxmlformats.org/drawingml/2006/main" prst="rect">
+            <a:avLst/>
+          </a:prstGeom>
+          <a:noFill xmlns:a="http://schemas.openxmlformats.org/drawingml/2006/main"/>
+          <a:ln xmlns:a="http://schemas.openxmlformats.org/drawingml/2006/main" w="0">
+            <a:noFill/>
+            <a:prstDash val="solid"/>
+          </a:ln>
+        </p:spPr>
+        <p:txBody>
+          <a:bodyPr xmlns:a="http://schemas.openxmlformats.org/drawingml/2006/main" anchor="t">
+            <a:normAutofit fontScale="100000"/>
+          </a:bodyPr>
+          <a:lstStyle xmlns:a="http://schemas.openxmlformats.org/drawingml/2006/main"/>
+          <a:p xmlns:a="http://schemas.openxmlformats.org/drawingml/2006/main">
+            <a:pPr algn="l">
+              <a:defRPr sz="1575" b="1">
+                <a:solidFill>
+                  <a:srgbClr val="111111"/>
+                </a:solidFill>
+                <a:latin typeface="Helvetica Neue"/>
+                <a:ea typeface="Helvetica Neue"/>
+                <a:cs typeface="Helvetica Neue"/>
+              </a:defRPr>
+            </a:pPr>
+            <a:r>
+              <a:rPr sz="1575" b="1">
+                <a:solidFill>
+                  <a:srgbClr val="111111"/>
+                </a:solidFill>
+                <a:latin typeface="Helvetica Neue"/>
+                <a:ea typeface="Helvetica Neue"/>
+                <a:cs typeface="Helvetica Neue"/>
+              </a:rPr>
+              <a:t>Why is an agent a composition rather than a new model paradigm?</a:t>
+            </a:r>
+          </a:p>
+        </p:txBody>
+      </p:sp>
+      <p:sp>
+        <p:nvSpPr>
+          <p:cNvPr id="10" name="exam-number-3">
+            <a:extLst xmlns:a="http://schemas.openxmlformats.org/drawingml/2006/main">
+              <a:ext uri="{FF2B5EF4-FFF2-40B4-BE49-F238E27FC236}">
+                <a16:creationId xmlns:a16="http://schemas.microsoft.com/office/drawing/2014/main" id="{2ACC8C37-6B9E-499B-B765-AA8A13EA314A}"/>
+              </a:ext>
+            </a:extLst>
+          </p:cNvPr>
+          <p:cNvSpPr>
+            <a:spLocks xmlns:a="http://schemas.openxmlformats.org/drawingml/2006/main" noGrp="1"/>
+          </p:cNvSpPr>
+          <p:nvPr/>
+        </p:nvSpPr>
+        <p:spPr>
+          <a:xfrm xmlns:a="http://schemas.openxmlformats.org/drawingml/2006/main">
+            <a:off x="390525" y="3495675"/>
+            <a:ext cx="590550" cy="400050"/>
+          </a:xfrm>
+          <a:prstGeom xmlns:a="http://schemas.openxmlformats.org/drawingml/2006/main" prst="rect">
+            <a:avLst/>
+          </a:prstGeom>
+          <a:noFill xmlns:a="http://schemas.openxmlformats.org/drawingml/2006/main"/>
+          <a:ln xmlns:a="http://schemas.openxmlformats.org/drawingml/2006/main" w="0">
+            <a:noFill/>
+            <a:prstDash val="solid"/>
+          </a:ln>
+        </p:spPr>
+        <p:txBody>
+          <a:bodyPr xmlns:a="http://schemas.openxmlformats.org/drawingml/2006/main" anchor="t">
+            <a:noAutofit/>
+          </a:bodyPr>
+          <a:lstStyle xmlns:a="http://schemas.openxmlformats.org/drawingml/2006/main"/>
+          <a:p xmlns:a="http://schemas.openxmlformats.org/drawingml/2006/main">
+            <a:pPr algn="l">
+              <a:defRPr sz="1725" b="1">
+                <a:solidFill>
+                  <a:srgbClr val="B9F15B"/>
+                </a:solidFill>
+                <a:latin typeface="Helvetica Neue"/>
+                <a:ea typeface="Helvetica Neue"/>
+                <a:cs typeface="Helvetica Neue"/>
+              </a:defRPr>
+            </a:pPr>
+            <a:r>
+              <a:rPr sz="1725" b="1">
+                <a:solidFill>
+                  <a:srgbClr val="B9F15B"/>
+                </a:solidFill>
+                <a:latin typeface="Helvetica Neue"/>
+                <a:ea typeface="Helvetica Neue"/>
+                <a:cs typeface="Helvetica Neue"/>
+              </a:rPr>
+              <a:t>03</a:t>
+            </a:r>
+          </a:p>
+        </p:txBody>
+      </p:sp>
+      <p:sp>
+        <p:nvSpPr>
+          <p:cNvPr id="11" name="exam-question-3">
+            <a:extLst xmlns:a="http://schemas.openxmlformats.org/drawingml/2006/main">
+              <a:ext uri="{FF2B5EF4-FFF2-40B4-BE49-F238E27FC236}">
+                <a16:creationId xmlns:a16="http://schemas.microsoft.com/office/drawing/2014/main" id="{E5FEAA19-2B17-49A1-B529-17952D47F8B3}"/>
+              </a:ext>
+            </a:extLst>
+          </p:cNvPr>
+          <p:cNvSpPr>
+            <a:spLocks xmlns:a="http://schemas.openxmlformats.org/drawingml/2006/main" noGrp="1"/>
+          </p:cNvSpPr>
+          <p:nvPr/>
+        </p:nvSpPr>
+        <p:spPr>
+          <a:xfrm xmlns:a="http://schemas.openxmlformats.org/drawingml/2006/main">
+            <a:off x="1076325" y="3495675"/>
+            <a:ext cx="4762500" cy="895350"/>
+          </a:xfrm>
+          <a:prstGeom xmlns:a="http://schemas.openxmlformats.org/drawingml/2006/main" prst="rect">
+            <a:avLst/>
+          </a:prstGeom>
+          <a:noFill xmlns:a="http://schemas.openxmlformats.org/drawingml/2006/main"/>
+          <a:ln xmlns:a="http://schemas.openxmlformats.org/drawingml/2006/main" w="0">
+            <a:noFill/>
+            <a:prstDash val="solid"/>
+          </a:ln>
+        </p:spPr>
+        <p:txBody>
+          <a:bodyPr xmlns:a="http://schemas.openxmlformats.org/drawingml/2006/main" anchor="t">
+            <a:normAutofit fontScale="100000"/>
+          </a:bodyPr>
+          <a:lstStyle xmlns:a="http://schemas.openxmlformats.org/drawingml/2006/main"/>
+          <a:p xmlns:a="http://schemas.openxmlformats.org/drawingml/2006/main">
+            <a:pPr algn="l">
+              <a:defRPr sz="1575" b="1">
+                <a:solidFill>
+                  <a:srgbClr val="111111"/>
+                </a:solidFill>
+                <a:latin typeface="Helvetica Neue"/>
+                <a:ea typeface="Helvetica Neue"/>
+                <a:cs typeface="Helvetica Neue"/>
+              </a:defRPr>
+            </a:pPr>
+            <a:r>
+              <a:rPr sz="1575" b="1">
+                <a:solidFill>
+                  <a:srgbClr val="111111"/>
+                </a:solidFill>
+                <a:latin typeface="Helvetica Neue"/>
+                <a:ea typeface="Helvetica Neue"/>
+                <a:cs typeface="Helvetica Neue"/>
+              </a:rPr>
+              <a:t>Compare chatbot, workflow, and agent by control flow and tool use.</a:t>
+            </a:r>
+          </a:p>
+        </p:txBody>
+      </p:sp>
+      <p:sp>
+        <p:nvSpPr>
+          <p:cNvPr id="12" name="exam-number-4">
+            <a:extLst xmlns:a="http://schemas.openxmlformats.org/drawingml/2006/main">
+              <a:ext uri="{FF2B5EF4-FFF2-40B4-BE49-F238E27FC236}">
+                <a16:creationId xmlns:a16="http://schemas.microsoft.com/office/drawing/2014/main" id="{ED6CA76F-C76A-405B-9933-4A0E2D208899}"/>
+              </a:ext>
+            </a:extLst>
+          </p:cNvPr>
+          <p:cNvSpPr>
+            <a:spLocks xmlns:a="http://schemas.openxmlformats.org/drawingml/2006/main" noGrp="1"/>
+          </p:cNvSpPr>
+          <p:nvPr/>
+        </p:nvSpPr>
+        <p:spPr>
+          <a:xfrm xmlns:a="http://schemas.openxmlformats.org/drawingml/2006/main">
+            <a:off x="6191250" y="3495675"/>
+            <a:ext cx="590550" cy="400050"/>
+          </a:xfrm>
+          <a:prstGeom xmlns:a="http://schemas.openxmlformats.org/drawingml/2006/main" prst="rect">
+            <a:avLst/>
+          </a:prstGeom>
+          <a:noFill xmlns:a="http://schemas.openxmlformats.org/drawingml/2006/main"/>
+          <a:ln xmlns:a="http://schemas.openxmlformats.org/drawingml/2006/main" w="0">
+            <a:noFill/>
+            <a:prstDash val="solid"/>
+          </a:ln>
+        </p:spPr>
+        <p:txBody>
+          <a:bodyPr xmlns:a="http://schemas.openxmlformats.org/drawingml/2006/main" anchor="t">
+            <a:noAutofit/>
+          </a:bodyPr>
+          <a:lstStyle xmlns:a="http://schemas.openxmlformats.org/drawingml/2006/main"/>
+          <a:p xmlns:a="http://schemas.openxmlformats.org/drawingml/2006/main">
+            <a:pPr algn="l">
+              <a:defRPr sz="1725" b="1">
+                <a:solidFill>
+                  <a:srgbClr val="B9F15B"/>
+                </a:solidFill>
+                <a:latin typeface="Helvetica Neue"/>
+                <a:ea typeface="Helvetica Neue"/>
+                <a:cs typeface="Helvetica Neue"/>
+              </a:defRPr>
+            </a:pPr>
+            <a:r>
+              <a:rPr sz="1725" b="1">
+                <a:solidFill>
+                  <a:srgbClr val="B9F15B"/>
+                </a:solidFill>
+                <a:latin typeface="Helvetica Neue"/>
+                <a:ea typeface="Helvetica Neue"/>
+                <a:cs typeface="Helvetica Neue"/>
+              </a:rPr>
+              <a:t>04</a:t>
+            </a:r>
+          </a:p>
+        </p:txBody>
+      </p:sp>
+      <p:sp>
+        <p:nvSpPr>
+          <p:cNvPr id="13" name="exam-question-4">
+            <a:extLst xmlns:a="http://schemas.openxmlformats.org/drawingml/2006/main">
+              <a:ext uri="{FF2B5EF4-FFF2-40B4-BE49-F238E27FC236}">
+                <a16:creationId xmlns:a16="http://schemas.microsoft.com/office/drawing/2014/main" id="{B70F211F-CE91-44CC-A3BB-E0A15E7A2DFF}"/>
+              </a:ext>
+            </a:extLst>
+          </p:cNvPr>
+          <p:cNvSpPr>
+            <a:spLocks xmlns:a="http://schemas.openxmlformats.org/drawingml/2006/main" noGrp="1"/>
+          </p:cNvSpPr>
+          <p:nvPr/>
+        </p:nvSpPr>
+        <p:spPr>
+          <a:xfrm xmlns:a="http://schemas.openxmlformats.org/drawingml/2006/main">
+            <a:off x="6877050" y="3495675"/>
+            <a:ext cx="4762500" cy="895350"/>
+          </a:xfrm>
+          <a:prstGeom xmlns:a="http://schemas.openxmlformats.org/drawingml/2006/main" prst="rect">
+            <a:avLst/>
+          </a:prstGeom>
+          <a:noFill xmlns:a="http://schemas.openxmlformats.org/drawingml/2006/main"/>
+          <a:ln xmlns:a="http://schemas.openxmlformats.org/drawingml/2006/main" w="0">
+            <a:noFill/>
+            <a:prstDash val="solid"/>
+          </a:ln>
+        </p:spPr>
+        <p:txBody>
+          <a:bodyPr xmlns:a="http://schemas.openxmlformats.org/drawingml/2006/main" anchor="t">
+            <a:normAutofit fontScale="100000"/>
+          </a:bodyPr>
+          <a:lstStyle xmlns:a="http://schemas.openxmlformats.org/drawingml/2006/main"/>
+          <a:p xmlns:a="http://schemas.openxmlformats.org/drawingml/2006/main">
+            <a:pPr algn="l">
+              <a:defRPr sz="1575" b="1">
+                <a:solidFill>
+                  <a:srgbClr val="111111"/>
+                </a:solidFill>
+                <a:latin typeface="Helvetica Neue"/>
+                <a:ea typeface="Helvetica Neue"/>
+                <a:cs typeface="Helvetica Neue"/>
+              </a:defRPr>
+            </a:pPr>
+            <a:r>
+              <a:rPr sz="1575" b="1">
+                <a:solidFill>
+                  <a:srgbClr val="111111"/>
+                </a:solidFill>
+                <a:latin typeface="Helvetica Neue"/>
+                <a:ea typeface="Helvetica Neue"/>
+                <a:cs typeface="Helvetica Neue"/>
+              </a:rPr>
+              <a:t>Name the four agent components and the responsibility of each.</a:t>
+            </a:r>
+          </a:p>
+        </p:txBody>
+      </p:sp>
+      <p:sp>
+        <p:nvSpPr>
+          <p:cNvPr id="14" name="exam-number-5">
+            <a:extLst xmlns:a="http://schemas.openxmlformats.org/drawingml/2006/main">
+              <a:ext uri="{FF2B5EF4-FFF2-40B4-BE49-F238E27FC236}">
+                <a16:creationId xmlns:a16="http://schemas.microsoft.com/office/drawing/2014/main" id="{FD74DE14-CE36-41AA-96CD-99E6E4E56D40}"/>
+              </a:ext>
+            </a:extLst>
+          </p:cNvPr>
+          <p:cNvSpPr>
+            <a:spLocks xmlns:a="http://schemas.openxmlformats.org/drawingml/2006/main" noGrp="1"/>
+          </p:cNvSpPr>
+          <p:nvPr/>
+        </p:nvSpPr>
+        <p:spPr>
+          <a:xfrm xmlns:a="http://schemas.openxmlformats.org/drawingml/2006/main">
+            <a:off x="390525" y="4752975"/>
+            <a:ext cx="590550" cy="400050"/>
+          </a:xfrm>
+          <a:prstGeom xmlns:a="http://schemas.openxmlformats.org/drawingml/2006/main" prst="rect">
+            <a:avLst/>
+          </a:prstGeom>
+          <a:noFill xmlns:a="http://schemas.openxmlformats.org/drawingml/2006/main"/>
+          <a:ln xmlns:a="http://schemas.openxmlformats.org/drawingml/2006/main" w="0">
+            <a:noFill/>
+            <a:prstDash val="solid"/>
+          </a:ln>
+        </p:spPr>
+        <p:txBody>
+          <a:bodyPr xmlns:a="http://schemas.openxmlformats.org/drawingml/2006/main" anchor="t">
+            <a:noAutofit/>
+          </a:bodyPr>
+          <a:lstStyle xmlns:a="http://schemas.openxmlformats.org/drawingml/2006/main"/>
+          <a:p xmlns:a="http://schemas.openxmlformats.org/drawingml/2006/main">
+            <a:pPr algn="l">
+              <a:defRPr sz="1725" b="1">
+                <a:solidFill>
+                  <a:srgbClr val="B9F15B"/>
+                </a:solidFill>
+                <a:latin typeface="Helvetica Neue"/>
+                <a:ea typeface="Helvetica Neue"/>
+                <a:cs typeface="Helvetica Neue"/>
+              </a:defRPr>
+            </a:pPr>
+            <a:r>
+              <a:rPr sz="1725" b="1">
+                <a:solidFill>
+                  <a:srgbClr val="B9F15B"/>
+                </a:solidFill>
+                <a:latin typeface="Helvetica Neue"/>
+                <a:ea typeface="Helvetica Neue"/>
+                <a:cs typeface="Helvetica Neue"/>
+              </a:rPr>
+              <a:t>05</a:t>
+            </a:r>
+          </a:p>
+        </p:txBody>
+      </p:sp>
+      <p:sp>
+        <p:nvSpPr>
+          <p:cNvPr id="15" name="exam-question-5">
+            <a:extLst xmlns:a="http://schemas.openxmlformats.org/drawingml/2006/main">
+              <a:ext uri="{FF2B5EF4-FFF2-40B4-BE49-F238E27FC236}">
+                <a16:creationId xmlns:a16="http://schemas.microsoft.com/office/drawing/2014/main" id="{D72EF7AA-3B3E-46E6-901A-3B5662307CA2}"/>
+              </a:ext>
+            </a:extLst>
+          </p:cNvPr>
+          <p:cNvSpPr>
+            <a:spLocks xmlns:a="http://schemas.openxmlformats.org/drawingml/2006/main" noGrp="1"/>
+          </p:cNvSpPr>
+          <p:nvPr/>
+        </p:nvSpPr>
+        <p:spPr>
+          <a:xfrm xmlns:a="http://schemas.openxmlformats.org/drawingml/2006/main">
+            <a:off x="1076325" y="4752975"/>
+            <a:ext cx="4762500" cy="895350"/>
+          </a:xfrm>
+          <a:prstGeom xmlns:a="http://schemas.openxmlformats.org/drawingml/2006/main" prst="rect">
+            <a:avLst/>
+          </a:prstGeom>
+          <a:noFill xmlns:a="http://schemas.openxmlformats.org/drawingml/2006/main"/>
+          <a:ln xmlns:a="http://schemas.openxmlformats.org/drawingml/2006/main" w="0">
+            <a:noFill/>
+            <a:prstDash val="solid"/>
+          </a:ln>
+        </p:spPr>
+        <p:txBody>
+          <a:bodyPr xmlns:a="http://schemas.openxmlformats.org/drawingml/2006/main" anchor="t">
+            <a:normAutofit fontScale="100000"/>
+          </a:bodyPr>
+          <a:lstStyle xmlns:a="http://schemas.openxmlformats.org/drawingml/2006/main"/>
+          <a:p xmlns:a="http://schemas.openxmlformats.org/drawingml/2006/main">
+            <a:pPr algn="l">
+              <a:defRPr sz="1575" b="1">
+                <a:solidFill>
+                  <a:srgbClr val="111111"/>
+                </a:solidFill>
+                <a:latin typeface="Helvetica Neue"/>
+                <a:ea typeface="Helvetica Neue"/>
+                <a:cs typeface="Helvetica Neue"/>
+              </a:defRPr>
+            </a:pPr>
+            <a:r>
+              <a:rPr sz="1575" b="1">
+                <a:solidFill>
+                  <a:srgbClr val="111111"/>
+                </a:solidFill>
+                <a:latin typeface="Helvetica Neue"/>
+                <a:ea typeface="Helvetica Neue"/>
+                <a:cs typeface="Helvetica Neue"/>
+              </a:rPr>
+              <a:t>Why are typical LLM-agent environments difficult?</a:t>
+            </a:r>
+          </a:p>
+        </p:txBody>
+      </p:sp>
+      <p:sp>
+        <p:nvSpPr>
+          <p:cNvPr id="16" name="exam-number-6">
+            <a:extLst xmlns:a="http://schemas.openxmlformats.org/drawingml/2006/main">
+              <a:ext uri="{FF2B5EF4-FFF2-40B4-BE49-F238E27FC236}">
+                <a16:creationId xmlns:a16="http://schemas.microsoft.com/office/drawing/2014/main" id="{7C16618B-ECC2-407A-8683-0B7EDEEF7121}"/>
+              </a:ext>
+            </a:extLst>
+          </p:cNvPr>
+          <p:cNvSpPr>
+            <a:spLocks xmlns:a="http://schemas.openxmlformats.org/drawingml/2006/main" noGrp="1"/>
+          </p:cNvSpPr>
+          <p:nvPr/>
+        </p:nvSpPr>
+        <p:spPr>
+          <a:xfrm xmlns:a="http://schemas.openxmlformats.org/drawingml/2006/main">
+            <a:off x="6191250" y="4752975"/>
+            <a:ext cx="590550" cy="400050"/>
+          </a:xfrm>
+          <a:prstGeom xmlns:a="http://schemas.openxmlformats.org/drawingml/2006/main" prst="rect">
+            <a:avLst/>
+          </a:prstGeom>
+          <a:noFill xmlns:a="http://schemas.openxmlformats.org/drawingml/2006/main"/>
+          <a:ln xmlns:a="http://schemas.openxmlformats.org/drawingml/2006/main" w="0">
+            <a:noFill/>
+            <a:prstDash val="solid"/>
+          </a:ln>
+        </p:spPr>
+        <p:txBody>
+          <a:bodyPr xmlns:a="http://schemas.openxmlformats.org/drawingml/2006/main" anchor="t">
+            <a:noAutofit/>
+          </a:bodyPr>
+          <a:lstStyle xmlns:a="http://schemas.openxmlformats.org/drawingml/2006/main"/>
+          <a:p xmlns:a="http://schemas.openxmlformats.org/drawingml/2006/main">
+            <a:pPr algn="l">
+              <a:defRPr sz="1725" b="1">
+                <a:solidFill>
+                  <a:srgbClr val="B9F15B"/>
+                </a:solidFill>
+                <a:latin typeface="Helvetica Neue"/>
+                <a:ea typeface="Helvetica Neue"/>
+                <a:cs typeface="Helvetica Neue"/>
+              </a:defRPr>
+            </a:pPr>
+            <a:r>
+              <a:rPr sz="1725" b="1">
+                <a:solidFill>
+                  <a:srgbClr val="B9F15B"/>
+                </a:solidFill>
+                <a:latin typeface="Helvetica Neue"/>
+                <a:ea typeface="Helvetica Neue"/>
+                <a:cs typeface="Helvetica Neue"/>
+              </a:rPr>
+              <a:t>06</a:t>
+            </a:r>
+          </a:p>
+        </p:txBody>
+      </p:sp>
+      <p:sp>
+        <p:nvSpPr>
+          <p:cNvPr id="17" name="exam-question-6">
+            <a:extLst xmlns:a="http://schemas.openxmlformats.org/drawingml/2006/main">
+              <a:ext uri="{FF2B5EF4-FFF2-40B4-BE49-F238E27FC236}">
+                <a16:creationId xmlns:a16="http://schemas.microsoft.com/office/drawing/2014/main" id="{4632CB83-2EC8-40D0-8E42-A9EC9AE2B8CE}"/>
+              </a:ext>
+            </a:extLst>
+          </p:cNvPr>
+          <p:cNvSpPr>
+            <a:spLocks xmlns:a="http://schemas.openxmlformats.org/drawingml/2006/main" noGrp="1"/>
+          </p:cNvSpPr>
+          <p:nvPr/>
+        </p:nvSpPr>
+        <p:spPr>
+          <a:xfrm xmlns:a="http://schemas.openxmlformats.org/drawingml/2006/main">
+            <a:off x="6877050" y="4752975"/>
+            <a:ext cx="4762500" cy="895350"/>
+          </a:xfrm>
+          <a:prstGeom xmlns:a="http://schemas.openxmlformats.org/drawingml/2006/main" prst="rect">
+            <a:avLst/>
+          </a:prstGeom>
+          <a:noFill xmlns:a="http://schemas.openxmlformats.org/drawingml/2006/main"/>
+          <a:ln xmlns:a="http://schemas.openxmlformats.org/drawingml/2006/main" w="0">
+            <a:noFill/>
+            <a:prstDash val="solid"/>
+          </a:ln>
+        </p:spPr>
+        <p:txBody>
+          <a:bodyPr xmlns:a="http://schemas.openxmlformats.org/drawingml/2006/main" anchor="t">
+            <a:normAutofit fontScale="100000"/>
+          </a:bodyPr>
+          <a:lstStyle xmlns:a="http://schemas.openxmlformats.org/drawingml/2006/main"/>
+          <a:p xmlns:a="http://schemas.openxmlformats.org/drawingml/2006/main">
+            <a:pPr algn="l">
+              <a:defRPr sz="1575" b="1">
+                <a:solidFill>
+                  <a:srgbClr val="111111"/>
+                </a:solidFill>
+                <a:latin typeface="Helvetica Neue"/>
+                <a:ea typeface="Helvetica Neue"/>
+                <a:cs typeface="Helvetica Neue"/>
+              </a:defRPr>
+            </a:pPr>
+            <a:r>
+              <a:rPr sz="1575" b="1">
+                <a:solidFill>
+                  <a:srgbClr val="111111"/>
+                </a:solidFill>
+                <a:latin typeface="Helvetica Neue"/>
+                <a:ea typeface="Helvetica Neue"/>
+                <a:cs typeface="Helvetica Neue"/>
+              </a:rPr>
+              <a:t>How would you test whether a fixed workflow is sufficient for a task?</a:t>
+            </a:r>
+          </a:p>
+        </p:txBody>
+      </p:sp>
+    </p:spTree>
+    <p:extLst>
+      <p:ext uri="{BB962C8B-B14F-4D97-AF65-F5344CB8AC3E}">
+        <p14:creationId xmlns:p14="http://schemas.microsoft.com/office/powerpoint/2010/main" val="1510253474"/>
+      </p:ext>
+    </p:extLst>
+  </p:cSld>
+</p:sld>
+</file>
+
+<file path=ppt/slides/slide11.xml><?xml version="1.0" encoding="utf-8"?>
 <p:sld xmlns:p="http://schemas.openxmlformats.org/presentationml/2006/main">
   <p:cSld>
     <p:bg>
@@ -2258,7 +3900,7 @@
           <p:cNvPr id="14" name="accent-line">
             <a:extLst xmlns:a="http://schemas.openxmlformats.org/drawingml/2006/main">
               <a:ext uri="{FF2B5EF4-FFF2-40B4-BE49-F238E27FC236}">
-                <a16:creationId xmlns:a16="http://schemas.microsoft.com/office/drawing/2014/main" id="{3B25849C-8A06-4BDC-9D08-52BEAECE0F38}"/>
+                <a16:creationId xmlns:a16="http://schemas.microsoft.com/office/drawing/2014/main" id="{5ABB4ED4-41AD-45EE-AACE-2DF7C41871AC}"/>
               </a:ext>
             </a:extLst>
           </p:cNvPr>
@@ -2291,7 +3933,7 @@
           <p:cNvPr id="2" name="chapter-label">
             <a:extLst xmlns:a="http://schemas.openxmlformats.org/drawingml/2006/main">
               <a:ext uri="{FF2B5EF4-FFF2-40B4-BE49-F238E27FC236}">
-                <a16:creationId xmlns:a16="http://schemas.microsoft.com/office/drawing/2014/main" id="{54621A7B-9543-4638-B3AD-5AEEBB682FB8}"/>
+                <a16:creationId xmlns:a16="http://schemas.microsoft.com/office/drawing/2014/main" id="{C5D91C7C-24A5-437D-A9F3-6E38B07953B8}"/>
               </a:ext>
             </a:extLst>
           </p:cNvPr>
@@ -2349,7 +3991,7 @@
           <p:cNvPr id="3" name="slide-number">
             <a:extLst xmlns:a="http://schemas.openxmlformats.org/drawingml/2006/main">
               <a:ext uri="{FF2B5EF4-FFF2-40B4-BE49-F238E27FC236}">
-                <a16:creationId xmlns:a16="http://schemas.microsoft.com/office/drawing/2014/main" id="{9B0DBDF5-8B52-4331-ABD7-52EA5904CA88}"/>
+                <a16:creationId xmlns:a16="http://schemas.microsoft.com/office/drawing/2014/main" id="{B8DA77DD-AC4D-4D0F-8267-CCBDF42DDB5E}"/>
               </a:ext>
             </a:extLst>
           </p:cNvPr>
@@ -2397,7 +4039,7 @@
                 <a:ea typeface="Helvetica Neue"/>
                 <a:cs typeface="Helvetica Neue"/>
               </a:rPr>
-              <a:t>10</a:t>
+              <a:t>11</a:t>
             </a:r>
           </a:p>
         </p:txBody>
@@ -2407,7 +4049,7 @@
           <p:cNvPr id="4" name="chapter-footer">
             <a:extLst xmlns:a="http://schemas.openxmlformats.org/drawingml/2006/main">
               <a:ext uri="{FF2B5EF4-FFF2-40B4-BE49-F238E27FC236}">
-                <a16:creationId xmlns:a16="http://schemas.microsoft.com/office/drawing/2014/main" id="{73F925FE-B410-4ADE-92B5-97BCE1DBB573}"/>
+                <a16:creationId xmlns:a16="http://schemas.microsoft.com/office/drawing/2014/main" id="{ECD988E6-225D-488C-8112-0A1950A940E6}"/>
               </a:ext>
             </a:extLst>
           </p:cNvPr>
@@ -2465,7 +4107,7 @@
           <p:cNvPr id="5" name="closing-title">
             <a:extLst xmlns:a="http://schemas.openxmlformats.org/drawingml/2006/main">
               <a:ext uri="{FF2B5EF4-FFF2-40B4-BE49-F238E27FC236}">
-                <a16:creationId xmlns:a16="http://schemas.microsoft.com/office/drawing/2014/main" id="{8CFEC99D-4555-4168-9BDA-7A73F19D3243}"/>
+                <a16:creationId xmlns:a16="http://schemas.microsoft.com/office/drawing/2014/main" id="{75B162D0-B3F6-4545-8BFD-CBB11795B2AC}"/>
               </a:ext>
             </a:extLst>
           </p:cNvPr>
@@ -2523,7 +4165,7 @@
           <p:cNvPr id="6" name="takeaway-number-1">
             <a:extLst xmlns:a="http://schemas.openxmlformats.org/drawingml/2006/main">
               <a:ext uri="{FF2B5EF4-FFF2-40B4-BE49-F238E27FC236}">
-                <a16:creationId xmlns:a16="http://schemas.microsoft.com/office/drawing/2014/main" id="{ED058F33-97A3-47CA-AB50-D438EBDD5142}"/>
+                <a16:creationId xmlns:a16="http://schemas.microsoft.com/office/drawing/2014/main" id="{3FF33CEE-F266-46DB-ABD1-7E174B9F7377}"/>
               </a:ext>
             </a:extLst>
           </p:cNvPr>
@@ -2581,7 +4223,7 @@
           <p:cNvPr id="7" name="takeaway-1">
             <a:extLst xmlns:a="http://schemas.openxmlformats.org/drawingml/2006/main">
               <a:ext uri="{FF2B5EF4-FFF2-40B4-BE49-F238E27FC236}">
-                <a16:creationId xmlns:a16="http://schemas.microsoft.com/office/drawing/2014/main" id="{7551CFC0-2F97-4DB7-BCE2-B40C345E6E38}"/>
+                <a16:creationId xmlns:a16="http://schemas.microsoft.com/office/drawing/2014/main" id="{05D72CC9-33E6-445E-96F1-C95171CBFE8B}"/>
               </a:ext>
             </a:extLst>
           </p:cNvPr>
@@ -2639,7 +4281,7 @@
           <p:cNvPr id="8" name="takeaway-number-2">
             <a:extLst xmlns:a="http://schemas.openxmlformats.org/drawingml/2006/main">
               <a:ext uri="{FF2B5EF4-FFF2-40B4-BE49-F238E27FC236}">
-                <a16:creationId xmlns:a16="http://schemas.microsoft.com/office/drawing/2014/main" id="{84EE5CAD-5800-411E-8FC8-EB15A199751E}"/>
+                <a16:creationId xmlns:a16="http://schemas.microsoft.com/office/drawing/2014/main" id="{F3E8DCFD-EB41-4A87-8193-97EAA3F15BB7}"/>
               </a:ext>
             </a:extLst>
           </p:cNvPr>
@@ -2697,7 +4339,7 @@
           <p:cNvPr id="9" name="takeaway-2">
             <a:extLst xmlns:a="http://schemas.openxmlformats.org/drawingml/2006/main">
               <a:ext uri="{FF2B5EF4-FFF2-40B4-BE49-F238E27FC236}">
-                <a16:creationId xmlns:a16="http://schemas.microsoft.com/office/drawing/2014/main" id="{E90D5358-EDD7-4B4B-9BC1-C0A2920F3319}"/>
+                <a16:creationId xmlns:a16="http://schemas.microsoft.com/office/drawing/2014/main" id="{351C1108-1680-43E4-83D1-151A6F7ADC24}"/>
               </a:ext>
             </a:extLst>
           </p:cNvPr>
@@ -2755,7 +4397,7 @@
           <p:cNvPr id="10" name="takeaway-number-3">
             <a:extLst xmlns:a="http://schemas.openxmlformats.org/drawingml/2006/main">
               <a:ext uri="{FF2B5EF4-FFF2-40B4-BE49-F238E27FC236}">
-                <a16:creationId xmlns:a16="http://schemas.microsoft.com/office/drawing/2014/main" id="{41A4D38B-3CD6-4230-9B5F-FE5D7F804A6B}"/>
+                <a16:creationId xmlns:a16="http://schemas.microsoft.com/office/drawing/2014/main" id="{51D87D46-CBE7-4BC7-9AF1-BAF294DA73CC}"/>
               </a:ext>
             </a:extLst>
           </p:cNvPr>
@@ -2813,7 +4455,7 @@
           <p:cNvPr id="11" name="takeaway-3">
             <a:extLst xmlns:a="http://schemas.openxmlformats.org/drawingml/2006/main">
               <a:ext uri="{FF2B5EF4-FFF2-40B4-BE49-F238E27FC236}">
-                <a16:creationId xmlns:a16="http://schemas.microsoft.com/office/drawing/2014/main" id="{2D230207-CD43-4335-94D6-47F874823016}"/>
+                <a16:creationId xmlns:a16="http://schemas.microsoft.com/office/drawing/2014/main" id="{8C982EC1-4E3D-421F-9337-FBC2B0B53B3B}"/>
               </a:ext>
             </a:extLst>
           </p:cNvPr>
@@ -2871,7 +4513,7 @@
           <p:cNvPr id="12" name="takeaway-number-4">
             <a:extLst xmlns:a="http://schemas.openxmlformats.org/drawingml/2006/main">
               <a:ext uri="{FF2B5EF4-FFF2-40B4-BE49-F238E27FC236}">
-                <a16:creationId xmlns:a16="http://schemas.microsoft.com/office/drawing/2014/main" id="{C8528898-9381-400F-B7D5-CCC93430E5F3}"/>
+                <a16:creationId xmlns:a16="http://schemas.microsoft.com/office/drawing/2014/main" id="{7ABF4157-81B2-4E0D-947E-CBE914B29265}"/>
               </a:ext>
             </a:extLst>
           </p:cNvPr>
@@ -2929,7 +4571,7 @@
           <p:cNvPr id="13" name="takeaway-4">
             <a:extLst xmlns:a="http://schemas.openxmlformats.org/drawingml/2006/main">
               <a:ext uri="{FF2B5EF4-FFF2-40B4-BE49-F238E27FC236}">
-                <a16:creationId xmlns:a16="http://schemas.microsoft.com/office/drawing/2014/main" id="{C357806B-09E7-47A7-81EE-A7817208A5BC}"/>
+                <a16:creationId xmlns:a16="http://schemas.microsoft.com/office/drawing/2014/main" id="{3CDBF9D3-8CA0-43A5-A143-D1CD85AF798E}"/>
               </a:ext>
             </a:extLst>
           </p:cNvPr>
@@ -2985,7 +4627,533 @@
     </p:spTree>
     <p:extLst>
       <p:ext uri="{BB962C8B-B14F-4D97-AF65-F5344CB8AC3E}">
-        <p14:creationId xmlns:p14="http://schemas.microsoft.com/office/powerpoint/2010/main" val="1638005353"/>
+        <p14:creationId xmlns:p14="http://schemas.microsoft.com/office/powerpoint/2010/main" val="1335709066"/>
+      </p:ext>
+    </p:extLst>
+  </p:cSld>
+</p:sld>
+</file>
+
+<file path=ppt/slides/slide12.xml><?xml version="1.0" encoding="utf-8"?>
+<p:sld xmlns:p="http://schemas.openxmlformats.org/presentationml/2006/main">
+  <p:cSld>
+    <p:bg>
+      <p:bgPr>
+        <a:solidFill xmlns:a="http://schemas.openxmlformats.org/drawingml/2006/main">
+          <a:srgbClr val="FFFFFF"/>
+        </a:solidFill>
+      </p:bgPr>
+    </p:bg>
+    <p:spTree>
+      <p:nvGrpSpPr>
+        <p:cNvPr id="1" name=""/>
+        <p:cNvGrpSpPr/>
+        <p:nvPr/>
+      </p:nvGrpSpPr>
+      <p:grpSpPr>
+        <a:xfrm xmlns:a="http://schemas.openxmlformats.org/drawingml/2006/main"/>
+      </p:grpSpPr>
+      <p:sp>
+        <p:nvSpPr>
+          <p:cNvPr id="10" name="accent-line">
+            <a:extLst xmlns:a="http://schemas.openxmlformats.org/drawingml/2006/main">
+              <a:ext uri="{FF2B5EF4-FFF2-40B4-BE49-F238E27FC236}">
+                <a16:creationId xmlns:a16="http://schemas.microsoft.com/office/drawing/2014/main" id="{F9DA4B89-6147-4EE9-88C0-91D7AC9291B5}"/>
+              </a:ext>
+            </a:extLst>
+          </p:cNvPr>
+          <p:cNvSpPr>
+            <a:spLocks xmlns:a="http://schemas.openxmlformats.org/drawingml/2006/main" noGrp="1"/>
+          </p:cNvSpPr>
+          <p:nvPr/>
+        </p:nvSpPr>
+        <p:spPr>
+          <a:xfrm xmlns:a="http://schemas.openxmlformats.org/drawingml/2006/main">
+            <a:off x="390525" y="304800"/>
+            <a:ext cx="11410950" cy="66675"/>
+          </a:xfrm>
+          <a:prstGeom xmlns:a="http://schemas.openxmlformats.org/drawingml/2006/main" prst="rect">
+            <a:avLst/>
+          </a:prstGeom>
+          <a:solidFill xmlns:a="http://schemas.openxmlformats.org/drawingml/2006/main">
+            <a:srgbClr val="B9F15B"/>
+          </a:solidFill>
+          <a:ln xmlns:a="http://schemas.openxmlformats.org/drawingml/2006/main" w="0">
+            <a:solidFill>
+              <a:srgbClr val="B9F15B"/>
+            </a:solidFill>
+            <a:prstDash val="solid"/>
+          </a:ln>
+        </p:spPr>
+      </p:sp>
+      <p:sp>
+        <p:nvSpPr>
+          <p:cNvPr id="2" name="chapter-label">
+            <a:extLst xmlns:a="http://schemas.openxmlformats.org/drawingml/2006/main">
+              <a:ext uri="{FF2B5EF4-FFF2-40B4-BE49-F238E27FC236}">
+                <a16:creationId xmlns:a16="http://schemas.microsoft.com/office/drawing/2014/main" id="{FD628A3A-D6A4-475C-8F36-6D45EBE093EB}"/>
+              </a:ext>
+            </a:extLst>
+          </p:cNvPr>
+          <p:cNvSpPr>
+            <a:spLocks xmlns:a="http://schemas.openxmlformats.org/drawingml/2006/main" noGrp="1"/>
+          </p:cNvSpPr>
+          <p:nvPr/>
+        </p:nvSpPr>
+        <p:spPr>
+          <a:xfrm xmlns:a="http://schemas.openxmlformats.org/drawingml/2006/main">
+            <a:off x="390525" y="466725"/>
+            <a:ext cx="4953000" cy="323850"/>
+          </a:xfrm>
+          <a:prstGeom xmlns:a="http://schemas.openxmlformats.org/drawingml/2006/main" prst="rect">
+            <a:avLst/>
+          </a:prstGeom>
+          <a:noFill xmlns:a="http://schemas.openxmlformats.org/drawingml/2006/main"/>
+          <a:ln xmlns:a="http://schemas.openxmlformats.org/drawingml/2006/main" w="0">
+            <a:noFill/>
+            <a:prstDash val="solid"/>
+          </a:ln>
+        </p:spPr>
+        <p:txBody>
+          <a:bodyPr xmlns:a="http://schemas.openxmlformats.org/drawingml/2006/main" anchor="t">
+            <a:noAutofit/>
+          </a:bodyPr>
+          <a:lstStyle xmlns:a="http://schemas.openxmlformats.org/drawingml/2006/main"/>
+          <a:p xmlns:a="http://schemas.openxmlformats.org/drawingml/2006/main">
+            <a:pPr algn="l">
+              <a:defRPr sz="1275" b="1">
+                <a:solidFill>
+                  <a:srgbClr val="5B5B57"/>
+                </a:solidFill>
+                <a:latin typeface="Helvetica Neue"/>
+                <a:ea typeface="Helvetica Neue"/>
+                <a:cs typeface="Helvetica Neue"/>
+              </a:defRPr>
+            </a:pPr>
+            <a:r>
+              <a:rPr sz="1275" b="1">
+                <a:solidFill>
+                  <a:srgbClr val="5B5B57"/>
+                </a:solidFill>
+                <a:latin typeface="Helvetica Neue"/>
+                <a:ea typeface="Helvetica Neue"/>
+                <a:cs typeface="Helvetica Neue"/>
+              </a:rPr>
+              <a:t>PRACTICE AND READING  /  01</a:t>
+            </a:r>
+          </a:p>
+        </p:txBody>
+      </p:sp>
+      <p:sp>
+        <p:nvSpPr>
+          <p:cNvPr id="3" name="slide-number">
+            <a:extLst xmlns:a="http://schemas.openxmlformats.org/drawingml/2006/main">
+              <a:ext uri="{FF2B5EF4-FFF2-40B4-BE49-F238E27FC236}">
+                <a16:creationId xmlns:a16="http://schemas.microsoft.com/office/drawing/2014/main" id="{7009712B-C9EF-4B76-8C86-BA15198F5B98}"/>
+              </a:ext>
+            </a:extLst>
+          </p:cNvPr>
+          <p:cNvSpPr>
+            <a:spLocks xmlns:a="http://schemas.openxmlformats.org/drawingml/2006/main" noGrp="1"/>
+          </p:cNvSpPr>
+          <p:nvPr/>
+        </p:nvSpPr>
+        <p:spPr>
+          <a:xfrm xmlns:a="http://schemas.openxmlformats.org/drawingml/2006/main">
+            <a:off x="11049000" y="6286500"/>
+            <a:ext cx="742950" cy="266700"/>
+          </a:xfrm>
+          <a:prstGeom xmlns:a="http://schemas.openxmlformats.org/drawingml/2006/main" prst="rect">
+            <a:avLst/>
+          </a:prstGeom>
+          <a:noFill xmlns:a="http://schemas.openxmlformats.org/drawingml/2006/main"/>
+          <a:ln xmlns:a="http://schemas.openxmlformats.org/drawingml/2006/main" w="0">
+            <a:noFill/>
+            <a:prstDash val="solid"/>
+          </a:ln>
+        </p:spPr>
+        <p:txBody>
+          <a:bodyPr xmlns:a="http://schemas.openxmlformats.org/drawingml/2006/main" anchor="t">
+            <a:noAutofit/>
+          </a:bodyPr>
+          <a:lstStyle xmlns:a="http://schemas.openxmlformats.org/drawingml/2006/main"/>
+          <a:p xmlns:a="http://schemas.openxmlformats.org/drawingml/2006/main">
+            <a:pPr algn="r">
+              <a:defRPr sz="1200" b="0">
+                <a:solidFill>
+                  <a:srgbClr val="5B5B57"/>
+                </a:solidFill>
+                <a:latin typeface="Helvetica Neue"/>
+                <a:ea typeface="Helvetica Neue"/>
+                <a:cs typeface="Helvetica Neue"/>
+              </a:defRPr>
+            </a:pPr>
+            <a:r>
+              <a:rPr sz="1200" b="0">
+                <a:solidFill>
+                  <a:srgbClr val="5B5B57"/>
+                </a:solidFill>
+                <a:latin typeface="Helvetica Neue"/>
+                <a:ea typeface="Helvetica Neue"/>
+                <a:cs typeface="Helvetica Neue"/>
+              </a:rPr>
+              <a:t>12</a:t>
+            </a:r>
+          </a:p>
+        </p:txBody>
+      </p:sp>
+      <p:sp>
+        <p:nvSpPr>
+          <p:cNvPr id="4" name="chapter-footer">
+            <a:extLst xmlns:a="http://schemas.openxmlformats.org/drawingml/2006/main">
+              <a:ext uri="{FF2B5EF4-FFF2-40B4-BE49-F238E27FC236}">
+                <a16:creationId xmlns:a16="http://schemas.microsoft.com/office/drawing/2014/main" id="{94B195B1-763E-4BCB-908B-BBE9AF32392B}"/>
+              </a:ext>
+            </a:extLst>
+          </p:cNvPr>
+          <p:cNvSpPr>
+            <a:spLocks xmlns:a="http://schemas.openxmlformats.org/drawingml/2006/main" noGrp="1"/>
+          </p:cNvSpPr>
+          <p:nvPr/>
+        </p:nvSpPr>
+        <p:spPr>
+          <a:xfrm xmlns:a="http://schemas.openxmlformats.org/drawingml/2006/main">
+            <a:off x="390525" y="6286500"/>
+            <a:ext cx="8191500" cy="266700"/>
+          </a:xfrm>
+          <a:prstGeom xmlns:a="http://schemas.openxmlformats.org/drawingml/2006/main" prst="rect">
+            <a:avLst/>
+          </a:prstGeom>
+          <a:noFill xmlns:a="http://schemas.openxmlformats.org/drawingml/2006/main"/>
+          <a:ln xmlns:a="http://schemas.openxmlformats.org/drawingml/2006/main" w="0">
+            <a:noFill/>
+            <a:prstDash val="solid"/>
+          </a:ln>
+        </p:spPr>
+        <p:txBody>
+          <a:bodyPr xmlns:a="http://schemas.openxmlformats.org/drawingml/2006/main" anchor="t">
+            <a:noAutofit/>
+          </a:bodyPr>
+          <a:lstStyle xmlns:a="http://schemas.openxmlformats.org/drawingml/2006/main"/>
+          <a:p xmlns:a="http://schemas.openxmlformats.org/drawingml/2006/main">
+            <a:pPr algn="l">
+              <a:defRPr sz="1125" b="0">
+                <a:solidFill>
+                  <a:srgbClr val="5B5B57"/>
+                </a:solidFill>
+                <a:latin typeface="Helvetica Neue"/>
+                <a:ea typeface="Helvetica Neue"/>
+                <a:cs typeface="Helvetica Neue"/>
+              </a:defRPr>
+            </a:pPr>
+            <a:r>
+              <a:rPr sz="1125" b="0">
+                <a:solidFill>
+                  <a:srgbClr val="5B5B57"/>
+                </a:solidFill>
+                <a:latin typeface="Helvetica Neue"/>
+                <a:ea typeface="Helvetica Neue"/>
+                <a:cs typeface="Helvetica Neue"/>
+              </a:rPr>
+              <a:t>From Language Models to Agents</a:t>
+            </a:r>
+          </a:p>
+        </p:txBody>
+      </p:sp>
+      <p:sp>
+        <p:nvSpPr>
+          <p:cNvPr id="5" name="practice-title">
+            <a:extLst xmlns:a="http://schemas.openxmlformats.org/drawingml/2006/main">
+              <a:ext uri="{FF2B5EF4-FFF2-40B4-BE49-F238E27FC236}">
+                <a16:creationId xmlns:a16="http://schemas.microsoft.com/office/drawing/2014/main" id="{AE101221-4CF8-419D-B524-B68B453F68C0}"/>
+              </a:ext>
+            </a:extLst>
+          </p:cNvPr>
+          <p:cNvSpPr>
+            <a:spLocks xmlns:a="http://schemas.openxmlformats.org/drawingml/2006/main" noGrp="1"/>
+          </p:cNvSpPr>
+          <p:nvPr/>
+        </p:nvSpPr>
+        <p:spPr>
+          <a:xfrm xmlns:a="http://schemas.openxmlformats.org/drawingml/2006/main">
+            <a:off x="390525" y="1000125"/>
+            <a:ext cx="11144250" cy="666750"/>
+          </a:xfrm>
+          <a:prstGeom xmlns:a="http://schemas.openxmlformats.org/drawingml/2006/main" prst="rect">
+            <a:avLst/>
+          </a:prstGeom>
+          <a:noFill xmlns:a="http://schemas.openxmlformats.org/drawingml/2006/main"/>
+          <a:ln xmlns:a="http://schemas.openxmlformats.org/drawingml/2006/main" w="0">
+            <a:noFill/>
+            <a:prstDash val="solid"/>
+          </a:ln>
+        </p:spPr>
+        <p:txBody>
+          <a:bodyPr xmlns:a="http://schemas.openxmlformats.org/drawingml/2006/main" anchor="t">
+            <a:normAutofit fontScale="100000"/>
+          </a:bodyPr>
+          <a:lstStyle xmlns:a="http://schemas.openxmlformats.org/drawingml/2006/main"/>
+          <a:p xmlns:a="http://schemas.openxmlformats.org/drawingml/2006/main">
+            <a:pPr algn="l">
+              <a:defRPr sz="3000" b="1">
+                <a:solidFill>
+                  <a:srgbClr val="111111"/>
+                </a:solidFill>
+                <a:latin typeface="Helvetica Neue"/>
+                <a:ea typeface="Helvetica Neue"/>
+                <a:cs typeface="Helvetica Neue"/>
+              </a:defRPr>
+            </a:pPr>
+            <a:r>
+              <a:rPr sz="3000" b="1">
+                <a:solidFill>
+                  <a:srgbClr val="111111"/>
+                </a:solidFill>
+                <a:latin typeface="Helvetica Neue"/>
+                <a:ea typeface="Helvetica Neue"/>
+                <a:cs typeface="Helvetica Neue"/>
+              </a:rPr>
+              <a:t>Evidence to submit</a:t>
+            </a:r>
+          </a:p>
+        </p:txBody>
+      </p:sp>
+      <p:sp>
+        <p:nvSpPr>
+          <p:cNvPr id="6" name="practice-task">
+            <a:extLst xmlns:a="http://schemas.openxmlformats.org/drawingml/2006/main">
+              <a:ext uri="{FF2B5EF4-FFF2-40B4-BE49-F238E27FC236}">
+                <a16:creationId xmlns:a16="http://schemas.microsoft.com/office/drawing/2014/main" id="{35AAAEA3-7D49-4B1E-A930-128048D12D1B}"/>
+              </a:ext>
+            </a:extLst>
+          </p:cNvPr>
+          <p:cNvSpPr>
+            <a:spLocks xmlns:a="http://schemas.openxmlformats.org/drawingml/2006/main" noGrp="1"/>
+          </p:cNvSpPr>
+          <p:nvPr/>
+        </p:nvSpPr>
+        <p:spPr>
+          <a:xfrm xmlns:a="http://schemas.openxmlformats.org/drawingml/2006/main">
+            <a:off x="390525" y="2000250"/>
+            <a:ext cx="10953750" cy="1238250"/>
+          </a:xfrm>
+          <a:prstGeom xmlns:a="http://schemas.openxmlformats.org/drawingml/2006/main" prst="rect">
+            <a:avLst/>
+          </a:prstGeom>
+          <a:noFill xmlns:a="http://schemas.openxmlformats.org/drawingml/2006/main"/>
+          <a:ln xmlns:a="http://schemas.openxmlformats.org/drawingml/2006/main" w="0">
+            <a:noFill/>
+            <a:prstDash val="solid"/>
+          </a:ln>
+        </p:spPr>
+        <p:txBody>
+          <a:bodyPr xmlns:a="http://schemas.openxmlformats.org/drawingml/2006/main" anchor="t">
+            <a:normAutofit fontScale="100000"/>
+          </a:bodyPr>
+          <a:lstStyle xmlns:a="http://schemas.openxmlformats.org/drawingml/2006/main"/>
+          <a:p xmlns:a="http://schemas.openxmlformats.org/drawingml/2006/main">
+            <a:pPr algn="l">
+              <a:defRPr sz="1950" b="0">
+                <a:solidFill>
+                  <a:srgbClr val="111111"/>
+                </a:solidFill>
+                <a:latin typeface="Helvetica Neue"/>
+                <a:ea typeface="Helvetica Neue"/>
+                <a:cs typeface="Helvetica Neue"/>
+              </a:defRPr>
+            </a:pPr>
+            <a:r>
+              <a:rPr sz="1950" b="0">
+                <a:solidFill>
+                  <a:srgbClr val="111111"/>
+                </a:solidFill>
+                <a:latin typeface="Helvetica Neue"/>
+                <a:ea typeface="Helvetica Neue"/>
+                <a:cs typeface="Helvetica Neue"/>
+              </a:rPr>
+              <a:t>Choose a catalog lookup or arithmetic task. Write six cases, including empty input and an unknown item. Define a pass condition and a call limit. Explain what dynamic decision, if any, needs a model.</a:t>
+            </a:r>
+          </a:p>
+        </p:txBody>
+      </p:sp>
+      <p:sp>
+        <p:nvSpPr>
+          <p:cNvPr id="7" name="practice-check">
+            <a:extLst xmlns:a="http://schemas.openxmlformats.org/drawingml/2006/main">
+              <a:ext uri="{FF2B5EF4-FFF2-40B4-BE49-F238E27FC236}">
+                <a16:creationId xmlns:a16="http://schemas.microsoft.com/office/drawing/2014/main" id="{71AFF106-D2CD-4754-B031-5FD822BA8AC3}"/>
+              </a:ext>
+            </a:extLst>
+          </p:cNvPr>
+          <p:cNvSpPr>
+            <a:spLocks xmlns:a="http://schemas.openxmlformats.org/drawingml/2006/main" noGrp="1"/>
+          </p:cNvSpPr>
+          <p:nvPr/>
+        </p:nvSpPr>
+        <p:spPr>
+          <a:xfrm xmlns:a="http://schemas.openxmlformats.org/drawingml/2006/main">
+            <a:off x="390525" y="3381375"/>
+            <a:ext cx="10953750" cy="1095375"/>
+          </a:xfrm>
+          <a:prstGeom xmlns:a="http://schemas.openxmlformats.org/drawingml/2006/main" prst="rect">
+            <a:avLst/>
+          </a:prstGeom>
+          <a:noFill xmlns:a="http://schemas.openxmlformats.org/drawingml/2006/main"/>
+          <a:ln xmlns:a="http://schemas.openxmlformats.org/drawingml/2006/main" w="0">
+            <a:noFill/>
+            <a:prstDash val="solid"/>
+          </a:ln>
+        </p:spPr>
+        <p:txBody>
+          <a:bodyPr xmlns:a="http://schemas.openxmlformats.org/drawingml/2006/main" anchor="t">
+            <a:normAutofit fontScale="100000"/>
+          </a:bodyPr>
+          <a:lstStyle xmlns:a="http://schemas.openxmlformats.org/drawingml/2006/main"/>
+          <a:p xmlns:a="http://schemas.openxmlformats.org/drawingml/2006/main">
+            <a:pPr algn="l">
+              <a:defRPr sz="1800" b="0">
+                <a:solidFill>
+                  <a:srgbClr val="5B5B57"/>
+                </a:solidFill>
+                <a:latin typeface="Helvetica Neue"/>
+                <a:ea typeface="Helvetica Neue"/>
+                <a:cs typeface="Helvetica Neue"/>
+              </a:defRPr>
+            </a:pPr>
+            <a:r>
+              <a:rPr sz="1800" b="0">
+                <a:solidFill>
+                  <a:srgbClr val="5B5B57"/>
+                </a:solidFill>
+                <a:latin typeface="Helvetica Neue"/>
+                <a:ea typeface="Helvetica Neue"/>
+                <a:cs typeface="Helvetica Neue"/>
+              </a:rPr>
+              <a:t>Submit the cases and an architecture choice before running a model. Credit follows the evidence, including a decision to keep a fixed workflow.</a:t>
+            </a:r>
+          </a:p>
+        </p:txBody>
+      </p:sp>
+      <p:sp>
+        <p:nvSpPr>
+          <p:cNvPr id="8" name="practice-readings">
+            <a:extLst xmlns:a="http://schemas.openxmlformats.org/drawingml/2006/main">
+              <a:ext uri="{FF2B5EF4-FFF2-40B4-BE49-F238E27FC236}">
+                <a16:creationId xmlns:a16="http://schemas.microsoft.com/office/drawing/2014/main" id="{1246CB2B-9D02-40AA-BDC7-5DA1F275EBCF}"/>
+              </a:ext>
+            </a:extLst>
+          </p:cNvPr>
+          <p:cNvSpPr>
+            <a:spLocks xmlns:a="http://schemas.openxmlformats.org/drawingml/2006/main" noGrp="1"/>
+          </p:cNvSpPr>
+          <p:nvPr/>
+        </p:nvSpPr>
+        <p:spPr>
+          <a:xfrm xmlns:a="http://schemas.openxmlformats.org/drawingml/2006/main">
+            <a:off x="390525" y="4667250"/>
+            <a:ext cx="10953750" cy="1000125"/>
+          </a:xfrm>
+          <a:prstGeom xmlns:a="http://schemas.openxmlformats.org/drawingml/2006/main" prst="rect">
+            <a:avLst/>
+          </a:prstGeom>
+          <a:noFill xmlns:a="http://schemas.openxmlformats.org/drawingml/2006/main"/>
+          <a:ln xmlns:a="http://schemas.openxmlformats.org/drawingml/2006/main" w="0">
+            <a:noFill/>
+            <a:prstDash val="solid"/>
+          </a:ln>
+        </p:spPr>
+        <p:txBody>
+          <a:bodyPr xmlns:a="http://schemas.openxmlformats.org/drawingml/2006/main" anchor="t">
+            <a:normAutofit fontScale="100000"/>
+          </a:bodyPr>
+          <a:lstStyle xmlns:a="http://schemas.openxmlformats.org/drawingml/2006/main"/>
+          <a:p xmlns:a="http://schemas.openxmlformats.org/drawingml/2006/main">
+            <a:pPr algn="l">
+              <a:defRPr sz="1425" b="0">
+                <a:solidFill>
+                  <a:srgbClr val="111111"/>
+                </a:solidFill>
+                <a:latin typeface="Helvetica Neue"/>
+                <a:ea typeface="Helvetica Neue"/>
+                <a:cs typeface="Helvetica Neue"/>
+              </a:defRPr>
+            </a:pPr>
+            <a:r>
+              <a:rPr sz="1425" b="0">
+                <a:solidFill>
+                  <a:srgbClr val="111111"/>
+                </a:solidFill>
+                <a:latin typeface="Helvetica Neue"/>
+                <a:ea typeface="Helvetica Neue"/>
+                <a:cs typeface="Helvetica Neue"/>
+              </a:rPr>
+              <a:t>Reading: classroom baseline and acceptance tests</a:t>
+            </a:r>
+          </a:p>
+        </p:txBody>
+      </p:sp>
+      <p:sp>
+        <p:nvSpPr>
+          <p:cNvPr id="9" name="practice-lab">
+            <a:extLst xmlns:a="http://schemas.openxmlformats.org/drawingml/2006/main">
+              <a:ext uri="{FF2B5EF4-FFF2-40B4-BE49-F238E27FC236}">
+                <a16:creationId xmlns:a16="http://schemas.microsoft.com/office/drawing/2014/main" id="{5D9BC56A-3CA6-4226-BD39-1707098343E5}"/>
+              </a:ext>
+            </a:extLst>
+          </p:cNvPr>
+          <p:cNvSpPr>
+            <a:spLocks xmlns:a="http://schemas.openxmlformats.org/drawingml/2006/main" noGrp="1"/>
+          </p:cNvSpPr>
+          <p:nvPr/>
+        </p:nvSpPr>
+        <p:spPr>
+          <a:xfrm xmlns:a="http://schemas.openxmlformats.org/drawingml/2006/main">
+            <a:off x="390525" y="5857875"/>
+            <a:ext cx="10953750" cy="266700"/>
+          </a:xfrm>
+          <a:prstGeom xmlns:a="http://schemas.openxmlformats.org/drawingml/2006/main" prst="rect">
+            <a:avLst/>
+          </a:prstGeom>
+          <a:noFill xmlns:a="http://schemas.openxmlformats.org/drawingml/2006/main"/>
+          <a:ln xmlns:a="http://schemas.openxmlformats.org/drawingml/2006/main" w="0">
+            <a:noFill/>
+            <a:prstDash val="solid"/>
+          </a:ln>
+        </p:spPr>
+        <p:txBody>
+          <a:bodyPr xmlns:a="http://schemas.openxmlformats.org/drawingml/2006/main" anchor="t">
+            <a:normAutofit fontScale="90196"/>
+          </a:bodyPr>
+          <a:lstStyle xmlns:a="http://schemas.openxmlformats.org/drawingml/2006/main"/>
+          <a:p xmlns:a="http://schemas.openxmlformats.org/drawingml/2006/main">
+            <a:pPr algn="l">
+              <a:defRPr sz="1275" b="0">
+                <a:solidFill>
+                  <a:srgbClr val="5B5B57"/>
+                </a:solidFill>
+                <a:latin typeface="Helvetica Neue"/>
+                <a:ea typeface="Helvetica Neue"/>
+                <a:cs typeface="Helvetica Neue"/>
+              </a:defRPr>
+            </a:pPr>
+            <a:r>
+              <a:rPr sz="1275" b="0">
+                <a:solidFill>
+                  <a:srgbClr val="5B5B57"/>
+                </a:solidFill>
+                <a:latin typeface="Helvetica Neue"/>
+                <a:ea typeface="Helvetica Neue"/>
+                <a:cs typeface="Helvetica Neue"/>
+              </a:rPr>
+              <a:t>labs/05_gemini_bounded_tools.ipynb</a:t>
+            </a:r>
+          </a:p>
+        </p:txBody>
+      </p:sp>
+    </p:spTree>
+    <p:extLst>
+      <p:ext uri="{BB962C8B-B14F-4D97-AF65-F5344CB8AC3E}">
+        <p14:creationId xmlns:p14="http://schemas.microsoft.com/office/powerpoint/2010/main" val="423174681"/>
       </p:ext>
     </p:extLst>
   </p:cSld>
@@ -3016,7 +5184,7 @@
           <p:cNvPr id="14" name="accent-line">
             <a:extLst xmlns:a="http://schemas.openxmlformats.org/drawingml/2006/main">
               <a:ext uri="{FF2B5EF4-FFF2-40B4-BE49-F238E27FC236}">
-                <a16:creationId xmlns:a16="http://schemas.microsoft.com/office/drawing/2014/main" id="{6E833D30-0114-4D66-84FA-FD06E11D2536}"/>
+                <a16:creationId xmlns:a16="http://schemas.microsoft.com/office/drawing/2014/main" id="{8672CCFB-2EDE-49DB-B7FD-CFE1EE227CBF}"/>
               </a:ext>
             </a:extLst>
           </p:cNvPr>
@@ -3049,7 +5217,7 @@
           <p:cNvPr id="2" name="chapter-label">
             <a:extLst xmlns:a="http://schemas.openxmlformats.org/drawingml/2006/main">
               <a:ext uri="{FF2B5EF4-FFF2-40B4-BE49-F238E27FC236}">
-                <a16:creationId xmlns:a16="http://schemas.microsoft.com/office/drawing/2014/main" id="{8A303128-DCF2-4064-A1A1-1EE4443FC024}"/>
+                <a16:creationId xmlns:a16="http://schemas.microsoft.com/office/drawing/2014/main" id="{CE8519CB-1C87-4080-A9F4-1C7BB61139A0}"/>
               </a:ext>
             </a:extLst>
           </p:cNvPr>
@@ -3107,7 +5275,7 @@
           <p:cNvPr id="3" name="slide-number">
             <a:extLst xmlns:a="http://schemas.openxmlformats.org/drawingml/2006/main">
               <a:ext uri="{FF2B5EF4-FFF2-40B4-BE49-F238E27FC236}">
-                <a16:creationId xmlns:a16="http://schemas.microsoft.com/office/drawing/2014/main" id="{2C3AC19C-1D9A-4E7E-8AC6-1574EFCC7367}"/>
+                <a16:creationId xmlns:a16="http://schemas.microsoft.com/office/drawing/2014/main" id="{0081F373-A09D-4B85-8B09-04E06957809D}"/>
               </a:ext>
             </a:extLst>
           </p:cNvPr>
@@ -3165,7 +5333,7 @@
           <p:cNvPr id="4" name="chapter-footer">
             <a:extLst xmlns:a="http://schemas.openxmlformats.org/drawingml/2006/main">
               <a:ext uri="{FF2B5EF4-FFF2-40B4-BE49-F238E27FC236}">
-                <a16:creationId xmlns:a16="http://schemas.microsoft.com/office/drawing/2014/main" id="{E84A5B5A-BC88-48F6-A518-02629BB511DE}"/>
+                <a16:creationId xmlns:a16="http://schemas.microsoft.com/office/drawing/2014/main" id="{BCD55A34-EC44-4D07-9E2B-7A050A48DCF1}"/>
               </a:ext>
             </a:extLst>
           </p:cNvPr>
@@ -3223,7 +5391,7 @@
           <p:cNvPr id="5" name="objectives-title">
             <a:extLst xmlns:a="http://schemas.openxmlformats.org/drawingml/2006/main">
               <a:ext uri="{FF2B5EF4-FFF2-40B4-BE49-F238E27FC236}">
-                <a16:creationId xmlns:a16="http://schemas.microsoft.com/office/drawing/2014/main" id="{2B7A0E77-0DD7-47FD-AF62-6DAB42E7796F}"/>
+                <a16:creationId xmlns:a16="http://schemas.microsoft.com/office/drawing/2014/main" id="{027746E1-E628-48F3-8962-F44E22BE4E0F}"/>
               </a:ext>
             </a:extLst>
           </p:cNvPr>
@@ -3281,7 +5449,7 @@
           <p:cNvPr id="6" name="objective-number-1">
             <a:extLst xmlns:a="http://schemas.openxmlformats.org/drawingml/2006/main">
               <a:ext uri="{FF2B5EF4-FFF2-40B4-BE49-F238E27FC236}">
-                <a16:creationId xmlns:a16="http://schemas.microsoft.com/office/drawing/2014/main" id="{9EECD35F-E27C-472D-A71E-1C1C5BD1D46B}"/>
+                <a16:creationId xmlns:a16="http://schemas.microsoft.com/office/drawing/2014/main" id="{58DD7CD4-3DB6-4D9C-A513-F2E3AB6DF2FE}"/>
               </a:ext>
             </a:extLst>
           </p:cNvPr>
@@ -3339,7 +5507,7 @@
           <p:cNvPr id="7" name="objective-1">
             <a:extLst xmlns:a="http://schemas.openxmlformats.org/drawingml/2006/main">
               <a:ext uri="{FF2B5EF4-FFF2-40B4-BE49-F238E27FC236}">
-                <a16:creationId xmlns:a16="http://schemas.microsoft.com/office/drawing/2014/main" id="{13E7C792-81B6-42F2-A830-6D151AB61FB7}"/>
+                <a16:creationId xmlns:a16="http://schemas.microsoft.com/office/drawing/2014/main" id="{98CD2E3D-7AE3-4C5D-931D-66201289A52F}"/>
               </a:ext>
             </a:extLst>
           </p:cNvPr>
@@ -3397,7 +5565,7 @@
           <p:cNvPr id="8" name="objective-number-2">
             <a:extLst xmlns:a="http://schemas.openxmlformats.org/drawingml/2006/main">
               <a:ext uri="{FF2B5EF4-FFF2-40B4-BE49-F238E27FC236}">
-                <a16:creationId xmlns:a16="http://schemas.microsoft.com/office/drawing/2014/main" id="{F2D0C7E7-A031-4E00-8E8D-9A81BA44E784}"/>
+                <a16:creationId xmlns:a16="http://schemas.microsoft.com/office/drawing/2014/main" id="{866354DB-5FAF-48DE-87E4-A55846CCCEDC}"/>
               </a:ext>
             </a:extLst>
           </p:cNvPr>
@@ -3455,7 +5623,7 @@
           <p:cNvPr id="9" name="objective-2">
             <a:extLst xmlns:a="http://schemas.openxmlformats.org/drawingml/2006/main">
               <a:ext uri="{FF2B5EF4-FFF2-40B4-BE49-F238E27FC236}">
-                <a16:creationId xmlns:a16="http://schemas.microsoft.com/office/drawing/2014/main" id="{8265B2DC-ECFA-497D-8B73-F621651B4771}"/>
+                <a16:creationId xmlns:a16="http://schemas.microsoft.com/office/drawing/2014/main" id="{9A828E24-8D4A-4241-A42C-D4147D9C780E}"/>
               </a:ext>
             </a:extLst>
           </p:cNvPr>
@@ -3513,7 +5681,7 @@
           <p:cNvPr id="10" name="objective-number-3">
             <a:extLst xmlns:a="http://schemas.openxmlformats.org/drawingml/2006/main">
               <a:ext uri="{FF2B5EF4-FFF2-40B4-BE49-F238E27FC236}">
-                <a16:creationId xmlns:a16="http://schemas.microsoft.com/office/drawing/2014/main" id="{1C3F5D7F-22EC-46D4-A085-A829B179E7B8}"/>
+                <a16:creationId xmlns:a16="http://schemas.microsoft.com/office/drawing/2014/main" id="{B6D0E170-197A-4867-ACE9-F6E817D4F5F8}"/>
               </a:ext>
             </a:extLst>
           </p:cNvPr>
@@ -3571,7 +5739,7 @@
           <p:cNvPr id="11" name="objective-3">
             <a:extLst xmlns:a="http://schemas.openxmlformats.org/drawingml/2006/main">
               <a:ext uri="{FF2B5EF4-FFF2-40B4-BE49-F238E27FC236}">
-                <a16:creationId xmlns:a16="http://schemas.microsoft.com/office/drawing/2014/main" id="{D5A09AEA-EAA6-4117-8D2D-A983B107411D}"/>
+                <a16:creationId xmlns:a16="http://schemas.microsoft.com/office/drawing/2014/main" id="{922EF6BA-3C5A-410F-BFBD-41B86C5DD86B}"/>
               </a:ext>
             </a:extLst>
           </p:cNvPr>
@@ -3629,7 +5797,7 @@
           <p:cNvPr id="12" name="objective-number-4">
             <a:extLst xmlns:a="http://schemas.openxmlformats.org/drawingml/2006/main">
               <a:ext uri="{FF2B5EF4-FFF2-40B4-BE49-F238E27FC236}">
-                <a16:creationId xmlns:a16="http://schemas.microsoft.com/office/drawing/2014/main" id="{5DCB4615-EFD3-49C4-B9AB-83838656F8EF}"/>
+                <a16:creationId xmlns:a16="http://schemas.microsoft.com/office/drawing/2014/main" id="{1BE06282-DDCE-4FDD-A34E-86BB1716E2D8}"/>
               </a:ext>
             </a:extLst>
           </p:cNvPr>
@@ -3687,7 +5855,7 @@
           <p:cNvPr id="13" name="objective-4">
             <a:extLst xmlns:a="http://schemas.openxmlformats.org/drawingml/2006/main">
               <a:ext uri="{FF2B5EF4-FFF2-40B4-BE49-F238E27FC236}">
-                <a16:creationId xmlns:a16="http://schemas.microsoft.com/office/drawing/2014/main" id="{0E2DD856-35C1-4831-8C4B-C2EEE1B00EB2}"/>
+                <a16:creationId xmlns:a16="http://schemas.microsoft.com/office/drawing/2014/main" id="{91EE6AEA-BEF5-4FFB-B699-30960268F6D8}"/>
               </a:ext>
             </a:extLst>
           </p:cNvPr>
@@ -3743,7 +5911,7 @@
     </p:spTree>
     <p:extLst>
       <p:ext uri="{BB962C8B-B14F-4D97-AF65-F5344CB8AC3E}">
-        <p14:creationId xmlns:p14="http://schemas.microsoft.com/office/powerpoint/2010/main" val="1405184705"/>
+        <p14:creationId xmlns:p14="http://schemas.microsoft.com/office/powerpoint/2010/main" val="189091175"/>
       </p:ext>
     </p:extLst>
   </p:cSld>
@@ -3774,7 +5942,7 @@
           <p:cNvPr id="9" name="accent-line">
             <a:extLst xmlns:a="http://schemas.openxmlformats.org/drawingml/2006/main">
               <a:ext uri="{FF2B5EF4-FFF2-40B4-BE49-F238E27FC236}">
-                <a16:creationId xmlns:a16="http://schemas.microsoft.com/office/drawing/2014/main" id="{D8996347-51C2-4681-92DF-3C4FB9EABA48}"/>
+                <a16:creationId xmlns:a16="http://schemas.microsoft.com/office/drawing/2014/main" id="{115473D9-71DE-4671-95E7-4582AD247EDA}"/>
               </a:ext>
             </a:extLst>
           </p:cNvPr>
@@ -3807,7 +5975,7 @@
           <p:cNvPr id="2" name="chapter-label">
             <a:extLst xmlns:a="http://schemas.openxmlformats.org/drawingml/2006/main">
               <a:ext uri="{FF2B5EF4-FFF2-40B4-BE49-F238E27FC236}">
-                <a16:creationId xmlns:a16="http://schemas.microsoft.com/office/drawing/2014/main" id="{160B06C6-955F-463B-B970-33459BA65435}"/>
+                <a16:creationId xmlns:a16="http://schemas.microsoft.com/office/drawing/2014/main" id="{CE7C3313-2AD2-403A-A39C-14AC15BC3E22}"/>
               </a:ext>
             </a:extLst>
           </p:cNvPr>
@@ -3865,7 +6033,7 @@
           <p:cNvPr id="3" name="slide-number">
             <a:extLst xmlns:a="http://schemas.openxmlformats.org/drawingml/2006/main">
               <a:ext uri="{FF2B5EF4-FFF2-40B4-BE49-F238E27FC236}">
-                <a16:creationId xmlns:a16="http://schemas.microsoft.com/office/drawing/2014/main" id="{D70C7FF8-682D-482B-8A2E-0EEA93D71ACF}"/>
+                <a16:creationId xmlns:a16="http://schemas.microsoft.com/office/drawing/2014/main" id="{B26DABD6-72FC-4CED-9CAE-C5633BC0B883}"/>
               </a:ext>
             </a:extLst>
           </p:cNvPr>
@@ -3923,7 +6091,7 @@
           <p:cNvPr id="4" name="chapter-footer">
             <a:extLst xmlns:a="http://schemas.openxmlformats.org/drawingml/2006/main">
               <a:ext uri="{FF2B5EF4-FFF2-40B4-BE49-F238E27FC236}">
-                <a16:creationId xmlns:a16="http://schemas.microsoft.com/office/drawing/2014/main" id="{CC0E292E-CDEE-4DB2-8084-6D7184F26A4B}"/>
+                <a16:creationId xmlns:a16="http://schemas.microsoft.com/office/drawing/2014/main" id="{ECC9BECE-45F6-49BF-A12F-B29BFED6DC62}"/>
               </a:ext>
             </a:extLst>
           </p:cNvPr>
@@ -3981,7 +6149,7 @@
           <p:cNvPr id="5" name="section-title">
             <a:extLst xmlns:a="http://schemas.openxmlformats.org/drawingml/2006/main">
               <a:ext uri="{FF2B5EF4-FFF2-40B4-BE49-F238E27FC236}">
-                <a16:creationId xmlns:a16="http://schemas.microsoft.com/office/drawing/2014/main" id="{2180675B-F5A2-415C-AD62-E2C82F3100F1}"/>
+                <a16:creationId xmlns:a16="http://schemas.microsoft.com/office/drawing/2014/main" id="{BEBE8068-9F89-4DBB-96F5-1E437B73B233}"/>
               </a:ext>
             </a:extLst>
           </p:cNvPr>
@@ -4039,7 +6207,7 @@
           <p:cNvPr id="6" name="section-explanation">
             <a:extLst xmlns:a="http://schemas.openxmlformats.org/drawingml/2006/main">
               <a:ext uri="{FF2B5EF4-FFF2-40B4-BE49-F238E27FC236}">
-                <a16:creationId xmlns:a16="http://schemas.microsoft.com/office/drawing/2014/main" id="{D8D148B3-E1B2-44DC-9EAA-32066540E971}"/>
+                <a16:creationId xmlns:a16="http://schemas.microsoft.com/office/drawing/2014/main" id="{8DE2DECE-8E0A-4728-83E8-E8F8767B78F6}"/>
               </a:ext>
             </a:extLst>
           </p:cNvPr>
@@ -4097,7 +6265,7 @@
           <p:cNvPr id="7" name="column-rule">
             <a:extLst xmlns:a="http://schemas.openxmlformats.org/drawingml/2006/main">
               <a:ext uri="{FF2B5EF4-FFF2-40B4-BE49-F238E27FC236}">
-                <a16:creationId xmlns:a16="http://schemas.microsoft.com/office/drawing/2014/main" id="{D71EEABD-7A59-4A7C-B7E6-75F64E00515C}"/>
+                <a16:creationId xmlns:a16="http://schemas.microsoft.com/office/drawing/2014/main" id="{0D2E2194-B73A-4AE6-8C6F-D7E7DB182F45}"/>
               </a:ext>
             </a:extLst>
           </p:cNvPr>
@@ -4130,7 +6298,7 @@
           <p:cNvPr id="8" name="section-points">
             <a:extLst xmlns:a="http://schemas.openxmlformats.org/drawingml/2006/main">
               <a:ext uri="{FF2B5EF4-FFF2-40B4-BE49-F238E27FC236}">
-                <a16:creationId xmlns:a16="http://schemas.microsoft.com/office/drawing/2014/main" id="{CC6D84C2-5A62-4C38-8BC0-9454AA71ED91}"/>
+                <a16:creationId xmlns:a16="http://schemas.microsoft.com/office/drawing/2014/main" id="{65ABC375-5196-4FF7-97B1-EBE5F3EC97FA}"/>
               </a:ext>
             </a:extLst>
           </p:cNvPr>
@@ -4242,7 +6410,7 @@
     </p:spTree>
     <p:extLst>
       <p:ext uri="{BB962C8B-B14F-4D97-AF65-F5344CB8AC3E}">
-        <p14:creationId xmlns:p14="http://schemas.microsoft.com/office/powerpoint/2010/main" val="2008891498"/>
+        <p14:creationId xmlns:p14="http://schemas.microsoft.com/office/powerpoint/2010/main" val="1266347391"/>
       </p:ext>
     </p:extLst>
   </p:cSld>
@@ -4273,7 +6441,7 @@
           <p:cNvPr id="13" name="accent-line">
             <a:extLst xmlns:a="http://schemas.openxmlformats.org/drawingml/2006/main">
               <a:ext uri="{FF2B5EF4-FFF2-40B4-BE49-F238E27FC236}">
-                <a16:creationId xmlns:a16="http://schemas.microsoft.com/office/drawing/2014/main" id="{77C02E24-2590-4DF3-B33B-7AEFB9DBE2E1}"/>
+                <a16:creationId xmlns:a16="http://schemas.microsoft.com/office/drawing/2014/main" id="{4CC9F207-599F-4003-B0CA-FE520E1D3555}"/>
               </a:ext>
             </a:extLst>
           </p:cNvPr>
@@ -4306,7 +6474,7 @@
           <p:cNvPr id="2" name="chapter-label">
             <a:extLst xmlns:a="http://schemas.openxmlformats.org/drawingml/2006/main">
               <a:ext uri="{FF2B5EF4-FFF2-40B4-BE49-F238E27FC236}">
-                <a16:creationId xmlns:a16="http://schemas.microsoft.com/office/drawing/2014/main" id="{81A6B6C4-2AA0-4A75-9422-37C8F38495A6}"/>
+                <a16:creationId xmlns:a16="http://schemas.microsoft.com/office/drawing/2014/main" id="{121EF838-8F3E-44E9-A01C-FB18608D5119}"/>
               </a:ext>
             </a:extLst>
           </p:cNvPr>
@@ -4364,7 +6532,7 @@
           <p:cNvPr id="3" name="slide-number">
             <a:extLst xmlns:a="http://schemas.openxmlformats.org/drawingml/2006/main">
               <a:ext uri="{FF2B5EF4-FFF2-40B4-BE49-F238E27FC236}">
-                <a16:creationId xmlns:a16="http://schemas.microsoft.com/office/drawing/2014/main" id="{7F5D9735-3A8F-4991-80E8-380E039799DA}"/>
+                <a16:creationId xmlns:a16="http://schemas.microsoft.com/office/drawing/2014/main" id="{5421C022-C74C-4F51-8DC7-DBD05199FA3F}"/>
               </a:ext>
             </a:extLst>
           </p:cNvPr>
@@ -4422,7 +6590,7 @@
           <p:cNvPr id="4" name="chapter-footer">
             <a:extLst xmlns:a="http://schemas.openxmlformats.org/drawingml/2006/main">
               <a:ext uri="{FF2B5EF4-FFF2-40B4-BE49-F238E27FC236}">
-                <a16:creationId xmlns:a16="http://schemas.microsoft.com/office/drawing/2014/main" id="{220937F9-18A4-4ED8-9185-AFCD25640063}"/>
+                <a16:creationId xmlns:a16="http://schemas.microsoft.com/office/drawing/2014/main" id="{0ECE4AAA-5CCA-456F-8B4D-3EA0A464726D}"/>
               </a:ext>
             </a:extLst>
           </p:cNvPr>
@@ -4480,7 +6648,7 @@
           <p:cNvPr id="5" name="section-title">
             <a:extLst xmlns:a="http://schemas.openxmlformats.org/drawingml/2006/main">
               <a:ext uri="{FF2B5EF4-FFF2-40B4-BE49-F238E27FC236}">
-                <a16:creationId xmlns:a16="http://schemas.microsoft.com/office/drawing/2014/main" id="{88D0AD94-393E-459D-AB81-5196F8E2D40B}"/>
+                <a16:creationId xmlns:a16="http://schemas.microsoft.com/office/drawing/2014/main" id="{773DAE01-35B8-4CD7-B88F-D95B930B5800}"/>
               </a:ext>
             </a:extLst>
           </p:cNvPr>
@@ -4538,7 +6706,7 @@
           <p:cNvPr id="6" name="section-explanation">
             <a:extLst xmlns:a="http://schemas.openxmlformats.org/drawingml/2006/main">
               <a:ext uri="{FF2B5EF4-FFF2-40B4-BE49-F238E27FC236}">
-                <a16:creationId xmlns:a16="http://schemas.microsoft.com/office/drawing/2014/main" id="{29001317-1176-4D42-8959-2EDC95D3634B}"/>
+                <a16:creationId xmlns:a16="http://schemas.microsoft.com/office/drawing/2014/main" id="{1F160EE9-7CDE-4187-9032-7D67DC52BF09}"/>
               </a:ext>
             </a:extLst>
           </p:cNvPr>
@@ -4596,7 +6764,7 @@
           <p:cNvPr id="7" name="point-band-1">
             <a:extLst xmlns:a="http://schemas.openxmlformats.org/drawingml/2006/main">
               <a:ext uri="{FF2B5EF4-FFF2-40B4-BE49-F238E27FC236}">
-                <a16:creationId xmlns:a16="http://schemas.microsoft.com/office/drawing/2014/main" id="{ED903AC3-C951-4EAF-AABC-A5B954565C43}"/>
+                <a16:creationId xmlns:a16="http://schemas.microsoft.com/office/drawing/2014/main" id="{C1ECCE2F-5139-4ED4-9FC2-17E4815A92D0}"/>
               </a:ext>
             </a:extLst>
           </p:cNvPr>
@@ -4629,7 +6797,7 @@
           <p:cNvPr id="8" name="point-1">
             <a:extLst xmlns:a="http://schemas.openxmlformats.org/drawingml/2006/main">
               <a:ext uri="{FF2B5EF4-FFF2-40B4-BE49-F238E27FC236}">
-                <a16:creationId xmlns:a16="http://schemas.microsoft.com/office/drawing/2014/main" id="{B60320D0-777C-4450-A6DB-C626C7688598}"/>
+                <a16:creationId xmlns:a16="http://schemas.microsoft.com/office/drawing/2014/main" id="{F1A3937A-649F-412F-B00E-A851411ED341}"/>
               </a:ext>
             </a:extLst>
           </p:cNvPr>
@@ -4687,7 +6855,7 @@
           <p:cNvPr id="9" name="point-band-2">
             <a:extLst xmlns:a="http://schemas.openxmlformats.org/drawingml/2006/main">
               <a:ext uri="{FF2B5EF4-FFF2-40B4-BE49-F238E27FC236}">
-                <a16:creationId xmlns:a16="http://schemas.microsoft.com/office/drawing/2014/main" id="{C97D9954-E157-4322-B740-7571E8DBA3A4}"/>
+                <a16:creationId xmlns:a16="http://schemas.microsoft.com/office/drawing/2014/main" id="{0DAB9EBF-7E5C-44FF-93E4-099B3FCA77D9}"/>
               </a:ext>
             </a:extLst>
           </p:cNvPr>
@@ -4720,7 +6888,7 @@
           <p:cNvPr id="10" name="point-2">
             <a:extLst xmlns:a="http://schemas.openxmlformats.org/drawingml/2006/main">
               <a:ext uri="{FF2B5EF4-FFF2-40B4-BE49-F238E27FC236}">
-                <a16:creationId xmlns:a16="http://schemas.microsoft.com/office/drawing/2014/main" id="{82F0EBDC-FACC-4AC1-98A3-E731CEFBD91E}"/>
+                <a16:creationId xmlns:a16="http://schemas.microsoft.com/office/drawing/2014/main" id="{EA41464C-6EDB-4376-98B4-14469CD1FD37}"/>
               </a:ext>
             </a:extLst>
           </p:cNvPr>
@@ -4778,7 +6946,7 @@
           <p:cNvPr id="11" name="point-band-3">
             <a:extLst xmlns:a="http://schemas.openxmlformats.org/drawingml/2006/main">
               <a:ext uri="{FF2B5EF4-FFF2-40B4-BE49-F238E27FC236}">
-                <a16:creationId xmlns:a16="http://schemas.microsoft.com/office/drawing/2014/main" id="{FE387899-0239-4949-9279-761B2415C1A6}"/>
+                <a16:creationId xmlns:a16="http://schemas.microsoft.com/office/drawing/2014/main" id="{0F5FB6F2-0CFD-48E4-901E-C19E3546BAA5}"/>
               </a:ext>
             </a:extLst>
           </p:cNvPr>
@@ -4811,7 +6979,7 @@
           <p:cNvPr id="12" name="point-3">
             <a:extLst xmlns:a="http://schemas.openxmlformats.org/drawingml/2006/main">
               <a:ext uri="{FF2B5EF4-FFF2-40B4-BE49-F238E27FC236}">
-                <a16:creationId xmlns:a16="http://schemas.microsoft.com/office/drawing/2014/main" id="{35434DDC-0EEF-4616-85E2-8CEF74BED38C}"/>
+                <a16:creationId xmlns:a16="http://schemas.microsoft.com/office/drawing/2014/main" id="{829AE7F6-9B46-4FB7-B471-ED0573986879}"/>
               </a:ext>
             </a:extLst>
           </p:cNvPr>
@@ -4867,7 +7035,7 @@
     </p:spTree>
     <p:extLst>
       <p:ext uri="{BB962C8B-B14F-4D97-AF65-F5344CB8AC3E}">
-        <p14:creationId xmlns:p14="http://schemas.microsoft.com/office/powerpoint/2010/main" val="2055741628"/>
+        <p14:creationId xmlns:p14="http://schemas.microsoft.com/office/powerpoint/2010/main" val="555377858"/>
       </p:ext>
     </p:extLst>
   </p:cSld>
@@ -4898,7 +7066,7 @@
           <p:cNvPr id="9" name="accent-line">
             <a:extLst xmlns:a="http://schemas.openxmlformats.org/drawingml/2006/main">
               <a:ext uri="{FF2B5EF4-FFF2-40B4-BE49-F238E27FC236}">
-                <a16:creationId xmlns:a16="http://schemas.microsoft.com/office/drawing/2014/main" id="{4FF53A23-7834-4A60-A2E9-B8298567C2E9}"/>
+                <a16:creationId xmlns:a16="http://schemas.microsoft.com/office/drawing/2014/main" id="{90740C86-A01F-4EF3-8F9E-EE3013C9FEA8}"/>
               </a:ext>
             </a:extLst>
           </p:cNvPr>
@@ -4931,7 +7099,7 @@
           <p:cNvPr id="2" name="chapter-label">
             <a:extLst xmlns:a="http://schemas.openxmlformats.org/drawingml/2006/main">
               <a:ext uri="{FF2B5EF4-FFF2-40B4-BE49-F238E27FC236}">
-                <a16:creationId xmlns:a16="http://schemas.microsoft.com/office/drawing/2014/main" id="{0A396143-4E26-4941-8CA5-60B7EB2C9246}"/>
+                <a16:creationId xmlns:a16="http://schemas.microsoft.com/office/drawing/2014/main" id="{788DD537-AF2B-40FC-8735-6ABD79997B11}"/>
               </a:ext>
             </a:extLst>
           </p:cNvPr>
@@ -4989,7 +7157,7 @@
           <p:cNvPr id="3" name="slide-number">
             <a:extLst xmlns:a="http://schemas.openxmlformats.org/drawingml/2006/main">
               <a:ext uri="{FF2B5EF4-FFF2-40B4-BE49-F238E27FC236}">
-                <a16:creationId xmlns:a16="http://schemas.microsoft.com/office/drawing/2014/main" id="{F6B9DA10-3A84-411F-9F13-5CAE9455F54F}"/>
+                <a16:creationId xmlns:a16="http://schemas.microsoft.com/office/drawing/2014/main" id="{D6E243D1-E8D6-4CB6-A92F-096E2FB3FC08}"/>
               </a:ext>
             </a:extLst>
           </p:cNvPr>
@@ -5047,7 +7215,7 @@
           <p:cNvPr id="4" name="chapter-footer">
             <a:extLst xmlns:a="http://schemas.openxmlformats.org/drawingml/2006/main">
               <a:ext uri="{FF2B5EF4-FFF2-40B4-BE49-F238E27FC236}">
-                <a16:creationId xmlns:a16="http://schemas.microsoft.com/office/drawing/2014/main" id="{07D4921F-BEA3-4A2E-BC3C-A9F0E0418BCC}"/>
+                <a16:creationId xmlns:a16="http://schemas.microsoft.com/office/drawing/2014/main" id="{B3D35FA5-68F1-4ECD-8E3A-EEB3E59E55C1}"/>
               </a:ext>
             </a:extLst>
           </p:cNvPr>
@@ -5105,7 +7273,7 @@
           <p:cNvPr id="5" name="section-title">
             <a:extLst xmlns:a="http://schemas.openxmlformats.org/drawingml/2006/main">
               <a:ext uri="{FF2B5EF4-FFF2-40B4-BE49-F238E27FC236}">
-                <a16:creationId xmlns:a16="http://schemas.microsoft.com/office/drawing/2014/main" id="{A5846AE8-A386-4DBF-BBAB-20A8AA9806E2}"/>
+                <a16:creationId xmlns:a16="http://schemas.microsoft.com/office/drawing/2014/main" id="{0687F012-3AA4-47C2-8E95-92E44BC36348}"/>
               </a:ext>
             </a:extLst>
           </p:cNvPr>
@@ -5163,7 +7331,7 @@
           <p:cNvPr id="6" name="section-explanation">
             <a:extLst xmlns:a="http://schemas.openxmlformats.org/drawingml/2006/main">
               <a:ext uri="{FF2B5EF4-FFF2-40B4-BE49-F238E27FC236}">
-                <a16:creationId xmlns:a16="http://schemas.microsoft.com/office/drawing/2014/main" id="{9787E240-CCDC-4B64-A49C-682968133013}"/>
+                <a16:creationId xmlns:a16="http://schemas.microsoft.com/office/drawing/2014/main" id="{E3402C59-F470-4516-AE09-4FBB3FE340F1}"/>
               </a:ext>
             </a:extLst>
           </p:cNvPr>
@@ -5221,7 +7389,7 @@
           <p:cNvPr id="7" name="column-rule">
             <a:extLst xmlns:a="http://schemas.openxmlformats.org/drawingml/2006/main">
               <a:ext uri="{FF2B5EF4-FFF2-40B4-BE49-F238E27FC236}">
-                <a16:creationId xmlns:a16="http://schemas.microsoft.com/office/drawing/2014/main" id="{FD34D090-CAA7-4AF4-98ED-389AF20A7B4D}"/>
+                <a16:creationId xmlns:a16="http://schemas.microsoft.com/office/drawing/2014/main" id="{5EF06DDA-D625-4B3E-815E-C758C7BE4B3B}"/>
               </a:ext>
             </a:extLst>
           </p:cNvPr>
@@ -5254,7 +7422,7 @@
           <p:cNvPr id="8" name="section-points">
             <a:extLst xmlns:a="http://schemas.openxmlformats.org/drawingml/2006/main">
               <a:ext uri="{FF2B5EF4-FFF2-40B4-BE49-F238E27FC236}">
-                <a16:creationId xmlns:a16="http://schemas.microsoft.com/office/drawing/2014/main" id="{03EE2726-B6DC-477F-844E-0B573F81D12B}"/>
+                <a16:creationId xmlns:a16="http://schemas.microsoft.com/office/drawing/2014/main" id="{5FB76FC2-DC7C-4FAA-A656-56AE92FE5ECF}"/>
               </a:ext>
             </a:extLst>
           </p:cNvPr>
@@ -5394,7 +7562,7 @@
     </p:spTree>
     <p:extLst>
       <p:ext uri="{BB962C8B-B14F-4D97-AF65-F5344CB8AC3E}">
-        <p14:creationId xmlns:p14="http://schemas.microsoft.com/office/powerpoint/2010/main" val="489277471"/>
+        <p14:creationId xmlns:p14="http://schemas.microsoft.com/office/powerpoint/2010/main" val="234726863"/>
       </p:ext>
     </p:extLst>
   </p:cSld>
@@ -5425,7 +7593,7 @@
           <p:cNvPr id="15" name="accent-line">
             <a:extLst xmlns:a="http://schemas.openxmlformats.org/drawingml/2006/main">
               <a:ext uri="{FF2B5EF4-FFF2-40B4-BE49-F238E27FC236}">
-                <a16:creationId xmlns:a16="http://schemas.microsoft.com/office/drawing/2014/main" id="{CC9E5924-84D7-4900-93B8-2DF7497A47AC}"/>
+                <a16:creationId xmlns:a16="http://schemas.microsoft.com/office/drawing/2014/main" id="{24A15110-D7FA-42DC-8AE1-08FCC52C5B04}"/>
               </a:ext>
             </a:extLst>
           </p:cNvPr>
@@ -5458,7 +7626,7 @@
           <p:cNvPr id="2" name="chapter-label">
             <a:extLst xmlns:a="http://schemas.openxmlformats.org/drawingml/2006/main">
               <a:ext uri="{FF2B5EF4-FFF2-40B4-BE49-F238E27FC236}">
-                <a16:creationId xmlns:a16="http://schemas.microsoft.com/office/drawing/2014/main" id="{9D836D92-88CF-4DFE-B2F2-3572EFFE31F9}"/>
+                <a16:creationId xmlns:a16="http://schemas.microsoft.com/office/drawing/2014/main" id="{7D17CC5B-438A-4958-95C6-CA01076C3FDE}"/>
               </a:ext>
             </a:extLst>
           </p:cNvPr>
@@ -5516,7 +7684,7 @@
           <p:cNvPr id="3" name="slide-number">
             <a:extLst xmlns:a="http://schemas.openxmlformats.org/drawingml/2006/main">
               <a:ext uri="{FF2B5EF4-FFF2-40B4-BE49-F238E27FC236}">
-                <a16:creationId xmlns:a16="http://schemas.microsoft.com/office/drawing/2014/main" id="{242AE2A1-FF7F-40BE-81A0-19C27020A05B}"/>
+                <a16:creationId xmlns:a16="http://schemas.microsoft.com/office/drawing/2014/main" id="{89D31DFB-42BC-4A18-88F9-2E11B09F7BD3}"/>
               </a:ext>
             </a:extLst>
           </p:cNvPr>
@@ -5574,7 +7742,7 @@
           <p:cNvPr id="4" name="chapter-footer">
             <a:extLst xmlns:a="http://schemas.openxmlformats.org/drawingml/2006/main">
               <a:ext uri="{FF2B5EF4-FFF2-40B4-BE49-F238E27FC236}">
-                <a16:creationId xmlns:a16="http://schemas.microsoft.com/office/drawing/2014/main" id="{F5CF8C45-CD1F-4B3C-B046-9BD136034D2D}"/>
+                <a16:creationId xmlns:a16="http://schemas.microsoft.com/office/drawing/2014/main" id="{EC6E23C1-0B3F-44D3-B4AD-F680BF176171}"/>
               </a:ext>
             </a:extLst>
           </p:cNvPr>
@@ -5632,7 +7800,7 @@
           <p:cNvPr id="5" name="section-title">
             <a:extLst xmlns:a="http://schemas.openxmlformats.org/drawingml/2006/main">
               <a:ext uri="{FF2B5EF4-FFF2-40B4-BE49-F238E27FC236}">
-                <a16:creationId xmlns:a16="http://schemas.microsoft.com/office/drawing/2014/main" id="{50524100-C382-43AE-8F5A-5C4060923626}"/>
+                <a16:creationId xmlns:a16="http://schemas.microsoft.com/office/drawing/2014/main" id="{D1B81C12-2D35-4E36-B986-81924B8FAFDE}"/>
               </a:ext>
             </a:extLst>
           </p:cNvPr>
@@ -5690,7 +7858,7 @@
           <p:cNvPr id="6" name="section-explanation">
             <a:extLst xmlns:a="http://schemas.openxmlformats.org/drawingml/2006/main">
               <a:ext uri="{FF2B5EF4-FFF2-40B4-BE49-F238E27FC236}">
-                <a16:creationId xmlns:a16="http://schemas.microsoft.com/office/drawing/2014/main" id="{A1887A2B-4902-483B-9C4D-6EA315A12234}"/>
+                <a16:creationId xmlns:a16="http://schemas.microsoft.com/office/drawing/2014/main" id="{649ACF60-2D6E-4DB4-8FA5-01A2FBD7CD3C}"/>
               </a:ext>
             </a:extLst>
           </p:cNvPr>
@@ -5748,7 +7916,7 @@
           <p:cNvPr id="7" name="point-band-1">
             <a:extLst xmlns:a="http://schemas.openxmlformats.org/drawingml/2006/main">
               <a:ext uri="{FF2B5EF4-FFF2-40B4-BE49-F238E27FC236}">
-                <a16:creationId xmlns:a16="http://schemas.microsoft.com/office/drawing/2014/main" id="{753406EE-C6BF-4612-9506-2CFF2A773A34}"/>
+                <a16:creationId xmlns:a16="http://schemas.microsoft.com/office/drawing/2014/main" id="{77F78D4E-2EDD-42CC-9C8B-E93F5915BC08}"/>
               </a:ext>
             </a:extLst>
           </p:cNvPr>
@@ -5781,7 +7949,7 @@
           <p:cNvPr id="8" name="point-1">
             <a:extLst xmlns:a="http://schemas.openxmlformats.org/drawingml/2006/main">
               <a:ext uri="{FF2B5EF4-FFF2-40B4-BE49-F238E27FC236}">
-                <a16:creationId xmlns:a16="http://schemas.microsoft.com/office/drawing/2014/main" id="{66CCF369-74DA-4820-BCDE-031B6B8EEAD3}"/>
+                <a16:creationId xmlns:a16="http://schemas.microsoft.com/office/drawing/2014/main" id="{06CA7C97-BBF9-4A59-BB1B-CFDDEB78D0DE}"/>
               </a:ext>
             </a:extLst>
           </p:cNvPr>
@@ -5839,7 +8007,7 @@
           <p:cNvPr id="9" name="point-band-2">
             <a:extLst xmlns:a="http://schemas.openxmlformats.org/drawingml/2006/main">
               <a:ext uri="{FF2B5EF4-FFF2-40B4-BE49-F238E27FC236}">
-                <a16:creationId xmlns:a16="http://schemas.microsoft.com/office/drawing/2014/main" id="{67083A04-4F98-43F4-96D8-78B7D87958FA}"/>
+                <a16:creationId xmlns:a16="http://schemas.microsoft.com/office/drawing/2014/main" id="{F608C378-E534-4D1C-9901-F438BE62AEE4}"/>
               </a:ext>
             </a:extLst>
           </p:cNvPr>
@@ -5872,7 +8040,7 @@
           <p:cNvPr id="10" name="point-2">
             <a:extLst xmlns:a="http://schemas.openxmlformats.org/drawingml/2006/main">
               <a:ext uri="{FF2B5EF4-FFF2-40B4-BE49-F238E27FC236}">
-                <a16:creationId xmlns:a16="http://schemas.microsoft.com/office/drawing/2014/main" id="{5A38A88B-F861-4AD2-BA73-A0DCFAE19058}"/>
+                <a16:creationId xmlns:a16="http://schemas.microsoft.com/office/drawing/2014/main" id="{3B584728-F03D-4958-8334-DE3A2D166D43}"/>
               </a:ext>
             </a:extLst>
           </p:cNvPr>
@@ -5930,7 +8098,7 @@
           <p:cNvPr id="11" name="point-band-3">
             <a:extLst xmlns:a="http://schemas.openxmlformats.org/drawingml/2006/main">
               <a:ext uri="{FF2B5EF4-FFF2-40B4-BE49-F238E27FC236}">
-                <a16:creationId xmlns:a16="http://schemas.microsoft.com/office/drawing/2014/main" id="{07028D3A-2730-4D0B-8AAB-58E5992896A1}"/>
+                <a16:creationId xmlns:a16="http://schemas.microsoft.com/office/drawing/2014/main" id="{DD77FF7E-F4D5-48C4-B37F-5B8B56CE49B0}"/>
               </a:ext>
             </a:extLst>
           </p:cNvPr>
@@ -5963,7 +8131,7 @@
           <p:cNvPr id="12" name="point-3">
             <a:extLst xmlns:a="http://schemas.openxmlformats.org/drawingml/2006/main">
               <a:ext uri="{FF2B5EF4-FFF2-40B4-BE49-F238E27FC236}">
-                <a16:creationId xmlns:a16="http://schemas.microsoft.com/office/drawing/2014/main" id="{8399EF9F-527D-4A5C-B629-E34AB546F4B6}"/>
+                <a16:creationId xmlns:a16="http://schemas.microsoft.com/office/drawing/2014/main" id="{92ADFE26-6272-4DB9-9343-85595613F1DE}"/>
               </a:ext>
             </a:extLst>
           </p:cNvPr>
@@ -6021,7 +8189,7 @@
           <p:cNvPr id="13" name="point-band-4">
             <a:extLst xmlns:a="http://schemas.openxmlformats.org/drawingml/2006/main">
               <a:ext uri="{FF2B5EF4-FFF2-40B4-BE49-F238E27FC236}">
-                <a16:creationId xmlns:a16="http://schemas.microsoft.com/office/drawing/2014/main" id="{2EBE89E8-72DD-456B-B9AF-E362A4F99BEC}"/>
+                <a16:creationId xmlns:a16="http://schemas.microsoft.com/office/drawing/2014/main" id="{1CC58F50-E197-49BB-9A37-8921E4013A9D}"/>
               </a:ext>
             </a:extLst>
           </p:cNvPr>
@@ -6054,7 +8222,7 @@
           <p:cNvPr id="14" name="point-4">
             <a:extLst xmlns:a="http://schemas.openxmlformats.org/drawingml/2006/main">
               <a:ext uri="{FF2B5EF4-FFF2-40B4-BE49-F238E27FC236}">
-                <a16:creationId xmlns:a16="http://schemas.microsoft.com/office/drawing/2014/main" id="{DE1E5717-6FCA-4A25-A4A5-AC699F16F7BD}"/>
+                <a16:creationId xmlns:a16="http://schemas.microsoft.com/office/drawing/2014/main" id="{0F535658-168A-49A6-8961-E15AF122FEAD}"/>
               </a:ext>
             </a:extLst>
           </p:cNvPr>
@@ -6110,7 +8278,7 @@
     </p:spTree>
     <p:extLst>
       <p:ext uri="{BB962C8B-B14F-4D97-AF65-F5344CB8AC3E}">
-        <p14:creationId xmlns:p14="http://schemas.microsoft.com/office/powerpoint/2010/main" val="747398806"/>
+        <p14:creationId xmlns:p14="http://schemas.microsoft.com/office/powerpoint/2010/main" val="1018888480"/>
       </p:ext>
     </p:extLst>
   </p:cSld>
@@ -6141,7 +8309,7 @@
           <p:cNvPr id="9" name="accent-line">
             <a:extLst xmlns:a="http://schemas.openxmlformats.org/drawingml/2006/main">
               <a:ext uri="{FF2B5EF4-FFF2-40B4-BE49-F238E27FC236}">
-                <a16:creationId xmlns:a16="http://schemas.microsoft.com/office/drawing/2014/main" id="{B591E8B7-14AD-453D-8ED9-8CC1F462F2C9}"/>
+                <a16:creationId xmlns:a16="http://schemas.microsoft.com/office/drawing/2014/main" id="{81EF20E8-018E-458D-9CE5-2AD34573BA6C}"/>
               </a:ext>
             </a:extLst>
           </p:cNvPr>
@@ -6174,7 +8342,7 @@
           <p:cNvPr id="2" name="chapter-label">
             <a:extLst xmlns:a="http://schemas.openxmlformats.org/drawingml/2006/main">
               <a:ext uri="{FF2B5EF4-FFF2-40B4-BE49-F238E27FC236}">
-                <a16:creationId xmlns:a16="http://schemas.microsoft.com/office/drawing/2014/main" id="{E65E0CC0-E84F-479E-A189-4C1B2334FBF5}"/>
+                <a16:creationId xmlns:a16="http://schemas.microsoft.com/office/drawing/2014/main" id="{ACA4E9EA-9A69-463C-87D4-19FCE99ABAA5}"/>
               </a:ext>
             </a:extLst>
           </p:cNvPr>
@@ -6232,7 +8400,7 @@
           <p:cNvPr id="3" name="slide-number">
             <a:extLst xmlns:a="http://schemas.openxmlformats.org/drawingml/2006/main">
               <a:ext uri="{FF2B5EF4-FFF2-40B4-BE49-F238E27FC236}">
-                <a16:creationId xmlns:a16="http://schemas.microsoft.com/office/drawing/2014/main" id="{40C6F3C7-5090-4CD9-A7CB-943B5F969E5A}"/>
+                <a16:creationId xmlns:a16="http://schemas.microsoft.com/office/drawing/2014/main" id="{095612A7-03C4-4E5A-AF06-1C434A40F0B0}"/>
               </a:ext>
             </a:extLst>
           </p:cNvPr>
@@ -6290,7 +8458,7 @@
           <p:cNvPr id="4" name="chapter-footer">
             <a:extLst xmlns:a="http://schemas.openxmlformats.org/drawingml/2006/main">
               <a:ext uri="{FF2B5EF4-FFF2-40B4-BE49-F238E27FC236}">
-                <a16:creationId xmlns:a16="http://schemas.microsoft.com/office/drawing/2014/main" id="{C9F48120-BD32-4ACC-A4AD-22FEAB2ACD82}"/>
+                <a16:creationId xmlns:a16="http://schemas.microsoft.com/office/drawing/2014/main" id="{8502E11E-9889-4CDB-9394-893C1C531965}"/>
               </a:ext>
             </a:extLst>
           </p:cNvPr>
@@ -6348,7 +8516,7 @@
           <p:cNvPr id="5" name="section-title">
             <a:extLst xmlns:a="http://schemas.openxmlformats.org/drawingml/2006/main">
               <a:ext uri="{FF2B5EF4-FFF2-40B4-BE49-F238E27FC236}">
-                <a16:creationId xmlns:a16="http://schemas.microsoft.com/office/drawing/2014/main" id="{A9EC9D73-F587-46DE-8BED-D03BCD8F2242}"/>
+                <a16:creationId xmlns:a16="http://schemas.microsoft.com/office/drawing/2014/main" id="{5F9EC1D4-F8C3-46BE-99F3-DAB0C42FF60C}"/>
               </a:ext>
             </a:extLst>
           </p:cNvPr>
@@ -6406,7 +8574,7 @@
           <p:cNvPr id="6" name="section-explanation">
             <a:extLst xmlns:a="http://schemas.openxmlformats.org/drawingml/2006/main">
               <a:ext uri="{FF2B5EF4-FFF2-40B4-BE49-F238E27FC236}">
-                <a16:creationId xmlns:a16="http://schemas.microsoft.com/office/drawing/2014/main" id="{843F0D15-CEB5-4D0E-A0D1-5760EB9E55B0}"/>
+                <a16:creationId xmlns:a16="http://schemas.microsoft.com/office/drawing/2014/main" id="{D88645B7-EFC4-4032-A847-FA67925C6AB6}"/>
               </a:ext>
             </a:extLst>
           </p:cNvPr>
@@ -6464,7 +8632,7 @@
           <p:cNvPr id="7" name="column-rule">
             <a:extLst xmlns:a="http://schemas.openxmlformats.org/drawingml/2006/main">
               <a:ext uri="{FF2B5EF4-FFF2-40B4-BE49-F238E27FC236}">
-                <a16:creationId xmlns:a16="http://schemas.microsoft.com/office/drawing/2014/main" id="{853D85E9-553B-4E10-8F5D-69DEBFFD3040}"/>
+                <a16:creationId xmlns:a16="http://schemas.microsoft.com/office/drawing/2014/main" id="{CD983365-50AA-4396-9291-D66106F3C254}"/>
               </a:ext>
             </a:extLst>
           </p:cNvPr>
@@ -6497,7 +8665,7 @@
           <p:cNvPr id="8" name="section-points">
             <a:extLst xmlns:a="http://schemas.openxmlformats.org/drawingml/2006/main">
               <a:ext uri="{FF2B5EF4-FFF2-40B4-BE49-F238E27FC236}">
-                <a16:creationId xmlns:a16="http://schemas.microsoft.com/office/drawing/2014/main" id="{8DD4E0C5-20AC-47F8-8385-4B9B373C2DFE}"/>
+                <a16:creationId xmlns:a16="http://schemas.microsoft.com/office/drawing/2014/main" id="{CEDFD974-2EA4-48D3-8E3F-24D67A2F9B1A}"/>
               </a:ext>
             </a:extLst>
           </p:cNvPr>
@@ -6609,7 +8777,7 @@
     </p:spTree>
     <p:extLst>
       <p:ext uri="{BB962C8B-B14F-4D97-AF65-F5344CB8AC3E}">
-        <p14:creationId xmlns:p14="http://schemas.microsoft.com/office/powerpoint/2010/main" val="1260032756"/>
+        <p14:creationId xmlns:p14="http://schemas.microsoft.com/office/powerpoint/2010/main" val="149783411"/>
       </p:ext>
     </p:extLst>
   </p:cSld>
@@ -6640,7 +8808,7 @@
           <p:cNvPr id="13" name="accent-line">
             <a:extLst xmlns:a="http://schemas.openxmlformats.org/drawingml/2006/main">
               <a:ext uri="{FF2B5EF4-FFF2-40B4-BE49-F238E27FC236}">
-                <a16:creationId xmlns:a16="http://schemas.microsoft.com/office/drawing/2014/main" id="{036C316B-CD02-43FA-A758-A7FA11D76359}"/>
+                <a16:creationId xmlns:a16="http://schemas.microsoft.com/office/drawing/2014/main" id="{0A298B57-3241-46D7-9FE8-B2CA1F0976BD}"/>
               </a:ext>
             </a:extLst>
           </p:cNvPr>
@@ -6673,7 +8841,7 @@
           <p:cNvPr id="2" name="chapter-label">
             <a:extLst xmlns:a="http://schemas.openxmlformats.org/drawingml/2006/main">
               <a:ext uri="{FF2B5EF4-FFF2-40B4-BE49-F238E27FC236}">
-                <a16:creationId xmlns:a16="http://schemas.microsoft.com/office/drawing/2014/main" id="{D091AC13-8087-4BEE-A59C-62408FF37CCD}"/>
+                <a16:creationId xmlns:a16="http://schemas.microsoft.com/office/drawing/2014/main" id="{4C2E0BE0-6A6A-42B1-8A21-B062A584506C}"/>
               </a:ext>
             </a:extLst>
           </p:cNvPr>
@@ -6731,7 +8899,7 @@
           <p:cNvPr id="3" name="slide-number">
             <a:extLst xmlns:a="http://schemas.openxmlformats.org/drawingml/2006/main">
               <a:ext uri="{FF2B5EF4-FFF2-40B4-BE49-F238E27FC236}">
-                <a16:creationId xmlns:a16="http://schemas.microsoft.com/office/drawing/2014/main" id="{5FB3A1F3-9597-40B3-8C33-DDBB5D1519EA}"/>
+                <a16:creationId xmlns:a16="http://schemas.microsoft.com/office/drawing/2014/main" id="{311A8CD8-23E2-4A47-B4BE-985D4FBE3EF5}"/>
               </a:ext>
             </a:extLst>
           </p:cNvPr>
@@ -6789,7 +8957,7 @@
           <p:cNvPr id="4" name="chapter-footer">
             <a:extLst xmlns:a="http://schemas.openxmlformats.org/drawingml/2006/main">
               <a:ext uri="{FF2B5EF4-FFF2-40B4-BE49-F238E27FC236}">
-                <a16:creationId xmlns:a16="http://schemas.microsoft.com/office/drawing/2014/main" id="{81911AD4-2277-4DA4-9DDB-13314FFD77CF}"/>
+                <a16:creationId xmlns:a16="http://schemas.microsoft.com/office/drawing/2014/main" id="{E73D3A44-26AE-4BDC-9D57-C6A1734C28BD}"/>
               </a:ext>
             </a:extLst>
           </p:cNvPr>
@@ -6847,7 +9015,7 @@
           <p:cNvPr id="5" name="section-title">
             <a:extLst xmlns:a="http://schemas.openxmlformats.org/drawingml/2006/main">
               <a:ext uri="{FF2B5EF4-FFF2-40B4-BE49-F238E27FC236}">
-                <a16:creationId xmlns:a16="http://schemas.microsoft.com/office/drawing/2014/main" id="{4423A094-69AC-468B-9D54-722A28EBB81A}"/>
+                <a16:creationId xmlns:a16="http://schemas.microsoft.com/office/drawing/2014/main" id="{75D152B2-1220-44CC-AC29-712D75BF00B4}"/>
               </a:ext>
             </a:extLst>
           </p:cNvPr>
@@ -6905,7 +9073,7 @@
           <p:cNvPr id="6" name="section-explanation">
             <a:extLst xmlns:a="http://schemas.openxmlformats.org/drawingml/2006/main">
               <a:ext uri="{FF2B5EF4-FFF2-40B4-BE49-F238E27FC236}">
-                <a16:creationId xmlns:a16="http://schemas.microsoft.com/office/drawing/2014/main" id="{CB17B023-D960-4C9D-81CE-8D5E0D7AD43C}"/>
+                <a16:creationId xmlns:a16="http://schemas.microsoft.com/office/drawing/2014/main" id="{B7FBF999-9157-415C-8909-D96F62894759}"/>
               </a:ext>
             </a:extLst>
           </p:cNvPr>
@@ -6963,7 +9131,7 @@
           <p:cNvPr id="7" name="point-band-1">
             <a:extLst xmlns:a="http://schemas.openxmlformats.org/drawingml/2006/main">
               <a:ext uri="{FF2B5EF4-FFF2-40B4-BE49-F238E27FC236}">
-                <a16:creationId xmlns:a16="http://schemas.microsoft.com/office/drawing/2014/main" id="{36CFC3A0-F47D-46EF-A9E6-C6FA873CEBF8}"/>
+                <a16:creationId xmlns:a16="http://schemas.microsoft.com/office/drawing/2014/main" id="{15A6C5B3-C101-438D-9F27-B883B2C96D68}"/>
               </a:ext>
             </a:extLst>
           </p:cNvPr>
@@ -6996,7 +9164,7 @@
           <p:cNvPr id="8" name="point-1">
             <a:extLst xmlns:a="http://schemas.openxmlformats.org/drawingml/2006/main">
               <a:ext uri="{FF2B5EF4-FFF2-40B4-BE49-F238E27FC236}">
-                <a16:creationId xmlns:a16="http://schemas.microsoft.com/office/drawing/2014/main" id="{551ABCAF-8CAE-4F3C-A613-5B16000131B0}"/>
+                <a16:creationId xmlns:a16="http://schemas.microsoft.com/office/drawing/2014/main" id="{77A5E2BA-3638-4EB5-AB91-B46D131550CF}"/>
               </a:ext>
             </a:extLst>
           </p:cNvPr>
@@ -7054,7 +9222,7 @@
           <p:cNvPr id="9" name="point-band-2">
             <a:extLst xmlns:a="http://schemas.openxmlformats.org/drawingml/2006/main">
               <a:ext uri="{FF2B5EF4-FFF2-40B4-BE49-F238E27FC236}">
-                <a16:creationId xmlns:a16="http://schemas.microsoft.com/office/drawing/2014/main" id="{AC54C0C2-13C0-4C10-B9D9-7F0EC05838E4}"/>
+                <a16:creationId xmlns:a16="http://schemas.microsoft.com/office/drawing/2014/main" id="{E6344858-371B-4B76-8332-70B92A5933CA}"/>
               </a:ext>
             </a:extLst>
           </p:cNvPr>
@@ -7087,7 +9255,7 @@
           <p:cNvPr id="10" name="point-2">
             <a:extLst xmlns:a="http://schemas.openxmlformats.org/drawingml/2006/main">
               <a:ext uri="{FF2B5EF4-FFF2-40B4-BE49-F238E27FC236}">
-                <a16:creationId xmlns:a16="http://schemas.microsoft.com/office/drawing/2014/main" id="{5BB482EB-0604-4B95-A740-0E519E1A6637}"/>
+                <a16:creationId xmlns:a16="http://schemas.microsoft.com/office/drawing/2014/main" id="{4B83B280-5F00-4F15-A857-8C5FFDD307E9}"/>
               </a:ext>
             </a:extLst>
           </p:cNvPr>
@@ -7145,7 +9313,7 @@
           <p:cNvPr id="11" name="point-band-3">
             <a:extLst xmlns:a="http://schemas.openxmlformats.org/drawingml/2006/main">
               <a:ext uri="{FF2B5EF4-FFF2-40B4-BE49-F238E27FC236}">
-                <a16:creationId xmlns:a16="http://schemas.microsoft.com/office/drawing/2014/main" id="{27649BA8-2378-4381-8FC8-E85E9BAD48B7}"/>
+                <a16:creationId xmlns:a16="http://schemas.microsoft.com/office/drawing/2014/main" id="{686E75A0-D771-475C-AAB2-E5D11A91E526}"/>
               </a:ext>
             </a:extLst>
           </p:cNvPr>
@@ -7178,7 +9346,7 @@
           <p:cNvPr id="12" name="point-3">
             <a:extLst xmlns:a="http://schemas.openxmlformats.org/drawingml/2006/main">
               <a:ext uri="{FF2B5EF4-FFF2-40B4-BE49-F238E27FC236}">
-                <a16:creationId xmlns:a16="http://schemas.microsoft.com/office/drawing/2014/main" id="{D825178C-23D4-41DD-84B6-279E44B2DA44}"/>
+                <a16:creationId xmlns:a16="http://schemas.microsoft.com/office/drawing/2014/main" id="{FDEDF016-D2C5-4B43-B8DB-D29EEB8DC3B9}"/>
               </a:ext>
             </a:extLst>
           </p:cNvPr>
@@ -7234,7 +9402,7 @@
     </p:spTree>
     <p:extLst>
       <p:ext uri="{BB962C8B-B14F-4D97-AF65-F5344CB8AC3E}">
-        <p14:creationId xmlns:p14="http://schemas.microsoft.com/office/powerpoint/2010/main" val="1726784002"/>
+        <p14:creationId xmlns:p14="http://schemas.microsoft.com/office/powerpoint/2010/main" val="1539481566"/>
       </p:ext>
     </p:extLst>
   </p:cSld>
@@ -7262,10 +9430,10 @@
       </p:grpSpPr>
       <p:sp>
         <p:nvSpPr>
-          <p:cNvPr id="18" name="accent-line">
-            <a:extLst xmlns:a="http://schemas.openxmlformats.org/drawingml/2006/main">
-              <a:ext uri="{FF2B5EF4-FFF2-40B4-BE49-F238E27FC236}">
-                <a16:creationId xmlns:a16="http://schemas.microsoft.com/office/drawing/2014/main" id="{DA6093BF-E932-4F21-9D65-A065F1F13398}"/>
+          <p:cNvPr id="9" name="accent-line">
+            <a:extLst xmlns:a="http://schemas.openxmlformats.org/drawingml/2006/main">
+              <a:ext uri="{FF2B5EF4-FFF2-40B4-BE49-F238E27FC236}">
+                <a16:creationId xmlns:a16="http://schemas.microsoft.com/office/drawing/2014/main" id="{D2672CB3-DDE5-4D1A-9D1F-0222CE373C9E}"/>
               </a:ext>
             </a:extLst>
           </p:cNvPr>
@@ -7298,7 +9466,7 @@
           <p:cNvPr id="2" name="chapter-label">
             <a:extLst xmlns:a="http://schemas.openxmlformats.org/drawingml/2006/main">
               <a:ext uri="{FF2B5EF4-FFF2-40B4-BE49-F238E27FC236}">
-                <a16:creationId xmlns:a16="http://schemas.microsoft.com/office/drawing/2014/main" id="{258E7CE9-C3CE-4F25-9412-1FAFF237A58F}"/>
+                <a16:creationId xmlns:a16="http://schemas.microsoft.com/office/drawing/2014/main" id="{41E7C06D-572E-48D8-8FFE-95D87CE3C67F}"/>
               </a:ext>
             </a:extLst>
           </p:cNvPr>
@@ -7346,7 +9514,7 @@
                 <a:ea typeface="Helvetica Neue"/>
                 <a:cs typeface="Helvetica Neue"/>
               </a:rPr>
-              <a:t>EXAM CHECK  /  01</a:t>
+              <a:t>CORE IDEA 07  /  01</a:t>
             </a:r>
           </a:p>
         </p:txBody>
@@ -7356,7 +9524,7 @@
           <p:cNvPr id="3" name="slide-number">
             <a:extLst xmlns:a="http://schemas.openxmlformats.org/drawingml/2006/main">
               <a:ext uri="{FF2B5EF4-FFF2-40B4-BE49-F238E27FC236}">
-                <a16:creationId xmlns:a16="http://schemas.microsoft.com/office/drawing/2014/main" id="{3ABD2B1F-B61D-46F9-BDB6-66040AA33F76}"/>
+                <a16:creationId xmlns:a16="http://schemas.microsoft.com/office/drawing/2014/main" id="{0F9BD22A-85A5-4ED5-B1D1-4B7414023195}"/>
               </a:ext>
             </a:extLst>
           </p:cNvPr>
@@ -7414,7 +9582,7 @@
           <p:cNvPr id="4" name="chapter-footer">
             <a:extLst xmlns:a="http://schemas.openxmlformats.org/drawingml/2006/main">
               <a:ext uri="{FF2B5EF4-FFF2-40B4-BE49-F238E27FC236}">
-                <a16:creationId xmlns:a16="http://schemas.microsoft.com/office/drawing/2014/main" id="{BA6238D1-D01B-42F8-8FDD-DD98DC301F3F}"/>
+                <a16:creationId xmlns:a16="http://schemas.microsoft.com/office/drawing/2014/main" id="{8C2DF01C-651E-4A1B-8049-3AAF546E0444}"/>
               </a:ext>
             </a:extLst>
           </p:cNvPr>
@@ -7469,138 +9637,22 @@
       </p:sp>
       <p:sp>
         <p:nvSpPr>
-          <p:cNvPr id="5" name="exam-title">
-            <a:extLst xmlns:a="http://schemas.openxmlformats.org/drawingml/2006/main">
-              <a:ext uri="{FF2B5EF4-FFF2-40B4-BE49-F238E27FC236}">
-                <a16:creationId xmlns:a16="http://schemas.microsoft.com/office/drawing/2014/main" id="{99AB2D39-6D31-4BFF-81A1-C3056A4F04D2}"/>
-              </a:ext>
-            </a:extLst>
-          </p:cNvPr>
-          <p:cNvSpPr>
-            <a:spLocks xmlns:a="http://schemas.openxmlformats.org/drawingml/2006/main" noGrp="1"/>
-          </p:cNvSpPr>
-          <p:nvPr/>
-        </p:nvSpPr>
-        <p:spPr>
-          <a:xfrm xmlns:a="http://schemas.openxmlformats.org/drawingml/2006/main">
-            <a:off x="390525" y="981075"/>
-            <a:ext cx="10668000" cy="781050"/>
-          </a:xfrm>
-          <a:prstGeom xmlns:a="http://schemas.openxmlformats.org/drawingml/2006/main" prst="rect">
-            <a:avLst/>
-          </a:prstGeom>
-          <a:noFill xmlns:a="http://schemas.openxmlformats.org/drawingml/2006/main"/>
-          <a:ln xmlns:a="http://schemas.openxmlformats.org/drawingml/2006/main" w="0">
-            <a:noFill/>
-            <a:prstDash val="solid"/>
-          </a:ln>
-        </p:spPr>
-        <p:txBody>
-          <a:bodyPr xmlns:a="http://schemas.openxmlformats.org/drawingml/2006/main" anchor="t">
-            <a:noAutofit/>
-          </a:bodyPr>
-          <a:lstStyle xmlns:a="http://schemas.openxmlformats.org/drawingml/2006/main"/>
-          <a:p xmlns:a="http://schemas.openxmlformats.org/drawingml/2006/main">
-            <a:pPr algn="l">
-              <a:defRPr sz="3150" b="1">
-                <a:solidFill>
-                  <a:srgbClr val="111111"/>
-                </a:solidFill>
-                <a:latin typeface="Helvetica Neue"/>
-                <a:ea typeface="Helvetica Neue"/>
-                <a:cs typeface="Helvetica Neue"/>
-              </a:defRPr>
-            </a:pPr>
-            <a:r>
-              <a:rPr sz="3150" b="1">
-                <a:solidFill>
-                  <a:srgbClr val="111111"/>
-                </a:solidFill>
-                <a:latin typeface="Helvetica Neue"/>
-                <a:ea typeface="Helvetica Neue"/>
-                <a:cs typeface="Helvetica Neue"/>
-              </a:rPr>
-              <a:t>Can you answer these without notes?</a:t>
-            </a:r>
-          </a:p>
-        </p:txBody>
-      </p:sp>
-      <p:sp>
-        <p:nvSpPr>
-          <p:cNvPr id="6" name="exam-number-1">
-            <a:extLst xmlns:a="http://schemas.openxmlformats.org/drawingml/2006/main">
-              <a:ext uri="{FF2B5EF4-FFF2-40B4-BE49-F238E27FC236}">
-                <a16:creationId xmlns:a16="http://schemas.microsoft.com/office/drawing/2014/main" id="{16535402-24BC-45EA-BD7D-2C842FAB4A5E}"/>
-              </a:ext>
-            </a:extLst>
-          </p:cNvPr>
-          <p:cNvSpPr>
-            <a:spLocks xmlns:a="http://schemas.openxmlformats.org/drawingml/2006/main" noGrp="1"/>
-          </p:cNvSpPr>
-          <p:nvPr/>
-        </p:nvSpPr>
-        <p:spPr>
-          <a:xfrm xmlns:a="http://schemas.openxmlformats.org/drawingml/2006/main">
-            <a:off x="390525" y="2238375"/>
-            <a:ext cx="590550" cy="400050"/>
-          </a:xfrm>
-          <a:prstGeom xmlns:a="http://schemas.openxmlformats.org/drawingml/2006/main" prst="rect">
-            <a:avLst/>
-          </a:prstGeom>
-          <a:noFill xmlns:a="http://schemas.openxmlformats.org/drawingml/2006/main"/>
-          <a:ln xmlns:a="http://schemas.openxmlformats.org/drawingml/2006/main" w="0">
-            <a:noFill/>
-            <a:prstDash val="solid"/>
-          </a:ln>
-        </p:spPr>
-        <p:txBody>
-          <a:bodyPr xmlns:a="http://schemas.openxmlformats.org/drawingml/2006/main" anchor="t">
-            <a:noAutofit/>
-          </a:bodyPr>
-          <a:lstStyle xmlns:a="http://schemas.openxmlformats.org/drawingml/2006/main"/>
-          <a:p xmlns:a="http://schemas.openxmlformats.org/drawingml/2006/main">
-            <a:pPr algn="l">
-              <a:defRPr sz="1725" b="1">
-                <a:solidFill>
-                  <a:srgbClr val="B9F15B"/>
-                </a:solidFill>
-                <a:latin typeface="Helvetica Neue"/>
-                <a:ea typeface="Helvetica Neue"/>
-                <a:cs typeface="Helvetica Neue"/>
-              </a:defRPr>
-            </a:pPr>
-            <a:r>
-              <a:rPr sz="1725" b="1">
-                <a:solidFill>
-                  <a:srgbClr val="B9F15B"/>
-                </a:solidFill>
-                <a:latin typeface="Helvetica Neue"/>
-                <a:ea typeface="Helvetica Neue"/>
-                <a:cs typeface="Helvetica Neue"/>
-              </a:rPr>
-              <a:t>01</a:t>
-            </a:r>
-          </a:p>
-        </p:txBody>
-      </p:sp>
-      <p:sp>
-        <p:nvSpPr>
-          <p:cNvPr id="7" name="exam-question-1">
-            <a:extLst xmlns:a="http://schemas.openxmlformats.org/drawingml/2006/main">
-              <a:ext uri="{FF2B5EF4-FFF2-40B4-BE49-F238E27FC236}">
-                <a16:creationId xmlns:a16="http://schemas.microsoft.com/office/drawing/2014/main" id="{4FDC8979-D5E9-4B86-B418-48196B52D11E}"/>
-              </a:ext>
-            </a:extLst>
-          </p:cNvPr>
-          <p:cNvSpPr>
-            <a:spLocks xmlns:a="http://schemas.openxmlformats.org/drawingml/2006/main" noGrp="1"/>
-          </p:cNvSpPr>
-          <p:nvPr/>
-        </p:nvSpPr>
-        <p:spPr>
-          <a:xfrm xmlns:a="http://schemas.openxmlformats.org/drawingml/2006/main">
-            <a:off x="1076325" y="2238375"/>
-            <a:ext cx="4762500" cy="895350"/>
+          <p:cNvPr id="5" name="section-title">
+            <a:extLst xmlns:a="http://schemas.openxmlformats.org/drawingml/2006/main">
+              <a:ext uri="{FF2B5EF4-FFF2-40B4-BE49-F238E27FC236}">
+                <a16:creationId xmlns:a16="http://schemas.microsoft.com/office/drawing/2014/main" id="{8831EDFC-6304-4BDE-B806-F1E32381E6EE}"/>
+              </a:ext>
+            </a:extLst>
+          </p:cNvPr>
+          <p:cNvSpPr>
+            <a:spLocks xmlns:a="http://schemas.openxmlformats.org/drawingml/2006/main" noGrp="1"/>
+          </p:cNvSpPr>
+          <p:nvPr/>
+        </p:nvSpPr>
+        <p:spPr>
+          <a:xfrm xmlns:a="http://schemas.openxmlformats.org/drawingml/2006/main">
+            <a:off x="390525" y="971550"/>
+            <a:ext cx="11144250" cy="971550"/>
           </a:xfrm>
           <a:prstGeom xmlns:a="http://schemas.openxmlformats.org/drawingml/2006/main" prst="rect">
             <a:avLst/>
@@ -7618,105 +9670,47 @@
           <a:lstStyle xmlns:a="http://schemas.openxmlformats.org/drawingml/2006/main"/>
           <a:p xmlns:a="http://schemas.openxmlformats.org/drawingml/2006/main">
             <a:pPr algn="l">
-              <a:defRPr sz="1575" b="1">
-                <a:solidFill>
-                  <a:srgbClr val="111111"/>
-                </a:solidFill>
-                <a:latin typeface="Helvetica Neue"/>
-                <a:ea typeface="Helvetica Neue"/>
-                <a:cs typeface="Helvetica Neue"/>
-              </a:defRPr>
-            </a:pPr>
-            <a:r>
-              <a:rPr sz="1575" b="1">
-                <a:solidFill>
-                  <a:srgbClr val="111111"/>
-                </a:solidFill>
-                <a:latin typeface="Helvetica Neue"/>
-                <a:ea typeface="Helvetica Neue"/>
-                <a:cs typeface="Helvetica Neue"/>
-              </a:rPr>
-              <a:t>Give the classical definition of an agent and reframe it for an LLM system.</a:t>
-            </a:r>
-          </a:p>
-        </p:txBody>
-      </p:sp>
-      <p:sp>
-        <p:nvSpPr>
-          <p:cNvPr id="8" name="exam-number-2">
-            <a:extLst xmlns:a="http://schemas.openxmlformats.org/drawingml/2006/main">
-              <a:ext uri="{FF2B5EF4-FFF2-40B4-BE49-F238E27FC236}">
-                <a16:creationId xmlns:a16="http://schemas.microsoft.com/office/drawing/2014/main" id="{0B7EBA06-C846-4279-A7CF-1590A2DE51A0}"/>
-              </a:ext>
-            </a:extLst>
-          </p:cNvPr>
-          <p:cNvSpPr>
-            <a:spLocks xmlns:a="http://schemas.openxmlformats.org/drawingml/2006/main" noGrp="1"/>
-          </p:cNvSpPr>
-          <p:nvPr/>
-        </p:nvSpPr>
-        <p:spPr>
-          <a:xfrm xmlns:a="http://schemas.openxmlformats.org/drawingml/2006/main">
-            <a:off x="6191250" y="2238375"/>
-            <a:ext cx="590550" cy="400050"/>
-          </a:xfrm>
-          <a:prstGeom xmlns:a="http://schemas.openxmlformats.org/drawingml/2006/main" prst="rect">
-            <a:avLst/>
-          </a:prstGeom>
-          <a:noFill xmlns:a="http://schemas.openxmlformats.org/drawingml/2006/main"/>
-          <a:ln xmlns:a="http://schemas.openxmlformats.org/drawingml/2006/main" w="0">
-            <a:noFill/>
-            <a:prstDash val="solid"/>
-          </a:ln>
-        </p:spPr>
-        <p:txBody>
-          <a:bodyPr xmlns:a="http://schemas.openxmlformats.org/drawingml/2006/main" anchor="t">
-            <a:noAutofit/>
-          </a:bodyPr>
-          <a:lstStyle xmlns:a="http://schemas.openxmlformats.org/drawingml/2006/main"/>
-          <a:p xmlns:a="http://schemas.openxmlformats.org/drawingml/2006/main">
-            <a:pPr algn="l">
-              <a:defRPr sz="1725" b="1">
-                <a:solidFill>
-                  <a:srgbClr val="B9F15B"/>
-                </a:solidFill>
-                <a:latin typeface="Helvetica Neue"/>
-                <a:ea typeface="Helvetica Neue"/>
-                <a:cs typeface="Helvetica Neue"/>
-              </a:defRPr>
-            </a:pPr>
-            <a:r>
-              <a:rPr sz="1725" b="1">
-                <a:solidFill>
-                  <a:srgbClr val="B9F15B"/>
-                </a:solidFill>
-                <a:latin typeface="Helvetica Neue"/>
-                <a:ea typeface="Helvetica Neue"/>
-                <a:cs typeface="Helvetica Neue"/>
-              </a:rPr>
-              <a:t>02</a:t>
-            </a:r>
-          </a:p>
-        </p:txBody>
-      </p:sp>
-      <p:sp>
-        <p:nvSpPr>
-          <p:cNvPr id="9" name="exam-question-2">
-            <a:extLst xmlns:a="http://schemas.openxmlformats.org/drawingml/2006/main">
-              <a:ext uri="{FF2B5EF4-FFF2-40B4-BE49-F238E27FC236}">
-                <a16:creationId xmlns:a16="http://schemas.microsoft.com/office/drawing/2014/main" id="{D0DD2FFB-03F5-4137-8E30-D47B3891B567}"/>
-              </a:ext>
-            </a:extLst>
-          </p:cNvPr>
-          <p:cNvSpPr>
-            <a:spLocks xmlns:a="http://schemas.openxmlformats.org/drawingml/2006/main" noGrp="1"/>
-          </p:cNvSpPr>
-          <p:nvPr/>
-        </p:nvSpPr>
-        <p:spPr>
-          <a:xfrm xmlns:a="http://schemas.openxmlformats.org/drawingml/2006/main">
-            <a:off x="6877050" y="2238375"/>
-            <a:ext cx="4762500" cy="895350"/>
+              <a:defRPr sz="3000" b="1">
+                <a:solidFill>
+                  <a:srgbClr val="111111"/>
+                </a:solidFill>
+                <a:latin typeface="Helvetica Neue"/>
+                <a:ea typeface="Helvetica Neue"/>
+                <a:cs typeface="Helvetica Neue"/>
+              </a:defRPr>
+            </a:pPr>
+            <a:r>
+              <a:rPr sz="3000" b="1">
+                <a:solidFill>
+                  <a:srgbClr val="111111"/>
+                </a:solidFill>
+                <a:latin typeface="Helvetica Neue"/>
+                <a:ea typeface="Helvetica Neue"/>
+                <a:cs typeface="Helvetica Neue"/>
+              </a:rPr>
+              <a:t>A baseline makes autonomy a testable choice</a:t>
+            </a:r>
+          </a:p>
+        </p:txBody>
+      </p:sp>
+      <p:sp>
+        <p:nvSpPr>
+          <p:cNvPr id="6" name="section-explanation">
+            <a:extLst xmlns:a="http://schemas.openxmlformats.org/drawingml/2006/main">
+              <a:ext uri="{FF2B5EF4-FFF2-40B4-BE49-F238E27FC236}">
+                <a16:creationId xmlns:a16="http://schemas.microsoft.com/office/drawing/2014/main" id="{7291E2AE-C486-40BC-B3EB-80978879B082}"/>
+              </a:ext>
+            </a:extLst>
+          </p:cNvPr>
+          <p:cNvSpPr>
+            <a:spLocks xmlns:a="http://schemas.openxmlformats.org/drawingml/2006/main" noGrp="1"/>
+          </p:cNvSpPr>
+          <p:nvPr/>
+        </p:nvSpPr>
+        <p:spPr>
+          <a:xfrm xmlns:a="http://schemas.openxmlformats.org/drawingml/2006/main">
+            <a:off x="390525" y="2381250"/>
+            <a:ext cx="4524375" cy="2905125"/>
           </a:xfrm>
           <a:prstGeom xmlns:a="http://schemas.openxmlformats.org/drawingml/2006/main" prst="rect">
             <a:avLst/>
@@ -7734,105 +9728,80 @@
           <a:lstStyle xmlns:a="http://schemas.openxmlformats.org/drawingml/2006/main"/>
           <a:p xmlns:a="http://schemas.openxmlformats.org/drawingml/2006/main">
             <a:pPr algn="l">
-              <a:defRPr sz="1575" b="1">
-                <a:solidFill>
-                  <a:srgbClr val="111111"/>
-                </a:solidFill>
-                <a:latin typeface="Helvetica Neue"/>
-                <a:ea typeface="Helvetica Neue"/>
-                <a:cs typeface="Helvetica Neue"/>
-              </a:defRPr>
-            </a:pPr>
-            <a:r>
-              <a:rPr sz="1575" b="1">
-                <a:solidFill>
-                  <a:srgbClr val="111111"/>
-                </a:solidFill>
-                <a:latin typeface="Helvetica Neue"/>
-                <a:ea typeface="Helvetica Neue"/>
-                <a:cs typeface="Helvetica Neue"/>
-              </a:rPr>
-              <a:t>Why is an agent a composition rather than a new model paradigm?</a:t>
-            </a:r>
-          </a:p>
-        </p:txBody>
-      </p:sp>
-      <p:sp>
-        <p:nvSpPr>
-          <p:cNvPr id="10" name="exam-number-3">
-            <a:extLst xmlns:a="http://schemas.openxmlformats.org/drawingml/2006/main">
-              <a:ext uri="{FF2B5EF4-FFF2-40B4-BE49-F238E27FC236}">
-                <a16:creationId xmlns:a16="http://schemas.microsoft.com/office/drawing/2014/main" id="{4B7E20D3-225F-408F-ABE1-F1449B12694E}"/>
-              </a:ext>
-            </a:extLst>
-          </p:cNvPr>
-          <p:cNvSpPr>
-            <a:spLocks xmlns:a="http://schemas.openxmlformats.org/drawingml/2006/main" noGrp="1"/>
-          </p:cNvSpPr>
-          <p:nvPr/>
-        </p:nvSpPr>
-        <p:spPr>
-          <a:xfrm xmlns:a="http://schemas.openxmlformats.org/drawingml/2006/main">
-            <a:off x="390525" y="3495675"/>
-            <a:ext cx="590550" cy="400050"/>
-          </a:xfrm>
-          <a:prstGeom xmlns:a="http://schemas.openxmlformats.org/drawingml/2006/main" prst="rect">
-            <a:avLst/>
-          </a:prstGeom>
-          <a:noFill xmlns:a="http://schemas.openxmlformats.org/drawingml/2006/main"/>
-          <a:ln xmlns:a="http://schemas.openxmlformats.org/drawingml/2006/main" w="0">
-            <a:noFill/>
-            <a:prstDash val="solid"/>
-          </a:ln>
-        </p:spPr>
-        <p:txBody>
-          <a:bodyPr xmlns:a="http://schemas.openxmlformats.org/drawingml/2006/main" anchor="t">
-            <a:noAutofit/>
-          </a:bodyPr>
-          <a:lstStyle xmlns:a="http://schemas.openxmlformats.org/drawingml/2006/main"/>
-          <a:p xmlns:a="http://schemas.openxmlformats.org/drawingml/2006/main">
-            <a:pPr algn="l">
-              <a:defRPr sz="1725" b="1">
-                <a:solidFill>
-                  <a:srgbClr val="B9F15B"/>
-                </a:solidFill>
-                <a:latin typeface="Helvetica Neue"/>
-                <a:ea typeface="Helvetica Neue"/>
-                <a:cs typeface="Helvetica Neue"/>
-              </a:defRPr>
-            </a:pPr>
-            <a:r>
-              <a:rPr sz="1725" b="1">
-                <a:solidFill>
-                  <a:srgbClr val="B9F15B"/>
-                </a:solidFill>
-                <a:latin typeface="Helvetica Neue"/>
-                <a:ea typeface="Helvetica Neue"/>
-                <a:cs typeface="Helvetica Neue"/>
-              </a:rPr>
-              <a:t>03</a:t>
-            </a:r>
-          </a:p>
-        </p:txBody>
-      </p:sp>
-      <p:sp>
-        <p:nvSpPr>
-          <p:cNvPr id="11" name="exam-question-3">
-            <a:extLst xmlns:a="http://schemas.openxmlformats.org/drawingml/2006/main">
-              <a:ext uri="{FF2B5EF4-FFF2-40B4-BE49-F238E27FC236}">
-                <a16:creationId xmlns:a16="http://schemas.microsoft.com/office/drawing/2014/main" id="{B9741B49-D12E-49AC-AF4A-CD578EA69897}"/>
-              </a:ext>
-            </a:extLst>
-          </p:cNvPr>
-          <p:cNvSpPr>
-            <a:spLocks xmlns:a="http://schemas.openxmlformats.org/drawingml/2006/main" noGrp="1"/>
-          </p:cNvSpPr>
-          <p:nvPr/>
-        </p:nvSpPr>
-        <p:spPr>
-          <a:xfrm xmlns:a="http://schemas.openxmlformats.org/drawingml/2006/main">
-            <a:off x="1076325" y="3495675"/>
-            <a:ext cx="4762500" cy="895350"/>
+              <a:defRPr sz="1875" b="0">
+                <a:solidFill>
+                  <a:srgbClr val="5B5B57"/>
+                </a:solidFill>
+                <a:latin typeface="Helvetica Neue"/>
+                <a:ea typeface="Helvetica Neue"/>
+                <a:cs typeface="Helvetica Neue"/>
+              </a:defRPr>
+            </a:pPr>
+            <a:r>
+              <a:rPr sz="1875" b="0">
+                <a:solidFill>
+                  <a:srgbClr val="5B5B57"/>
+                </a:solidFill>
+                <a:latin typeface="Helvetica Neue"/>
+                <a:ea typeface="Helvetica Neue"/>
+                <a:cs typeface="Helvetica Neue"/>
+              </a:rPr>
+              <a:t>Choose a small task with observable success before building an agent. Compare a fixed workflow with a model-directed loop on the same inputs. Treat the decision to add autonomy as an engineering hypothesis.</a:t>
+            </a:r>
+          </a:p>
+        </p:txBody>
+      </p:sp>
+      <p:sp>
+        <p:nvSpPr>
+          <p:cNvPr id="7" name="column-rule">
+            <a:extLst xmlns:a="http://schemas.openxmlformats.org/drawingml/2006/main">
+              <a:ext uri="{FF2B5EF4-FFF2-40B4-BE49-F238E27FC236}">
+                <a16:creationId xmlns:a16="http://schemas.microsoft.com/office/drawing/2014/main" id="{1E3C2A57-9912-4170-AD8B-C2340BCD687E}"/>
+              </a:ext>
+            </a:extLst>
+          </p:cNvPr>
+          <p:cNvSpPr>
+            <a:spLocks xmlns:a="http://schemas.openxmlformats.org/drawingml/2006/main" noGrp="1"/>
+          </p:cNvSpPr>
+          <p:nvPr/>
+        </p:nvSpPr>
+        <p:spPr>
+          <a:xfrm xmlns:a="http://schemas.openxmlformats.org/drawingml/2006/main">
+            <a:off x="5334000" y="2343150"/>
+            <a:ext cx="47625" cy="3257550"/>
+          </a:xfrm>
+          <a:prstGeom xmlns:a="http://schemas.openxmlformats.org/drawingml/2006/main" prst="rect">
+            <a:avLst/>
+          </a:prstGeom>
+          <a:solidFill xmlns:a="http://schemas.openxmlformats.org/drawingml/2006/main">
+            <a:srgbClr val="B9F15B"/>
+          </a:solidFill>
+          <a:ln xmlns:a="http://schemas.openxmlformats.org/drawingml/2006/main" w="0">
+            <a:solidFill>
+              <a:srgbClr val="B9F15B"/>
+            </a:solidFill>
+            <a:prstDash val="solid"/>
+          </a:ln>
+        </p:spPr>
+      </p:sp>
+      <p:sp>
+        <p:nvSpPr>
+          <p:cNvPr id="8" name="section-points">
+            <a:extLst xmlns:a="http://schemas.openxmlformats.org/drawingml/2006/main">
+              <a:ext uri="{FF2B5EF4-FFF2-40B4-BE49-F238E27FC236}">
+                <a16:creationId xmlns:a16="http://schemas.microsoft.com/office/drawing/2014/main" id="{03C2B0D0-3E66-4007-93A3-E916AEABDB11}"/>
+              </a:ext>
+            </a:extLst>
+          </p:cNvPr>
+          <p:cNvSpPr>
+            <a:spLocks xmlns:a="http://schemas.openxmlformats.org/drawingml/2006/main" noGrp="1"/>
+          </p:cNvSpPr>
+          <p:nvPr/>
+        </p:nvSpPr>
+        <p:spPr>
+          <a:xfrm xmlns:a="http://schemas.openxmlformats.org/drawingml/2006/main">
+            <a:off x="5857875" y="2343150"/>
+            <a:ext cx="5572125" cy="3429000"/>
           </a:xfrm>
           <a:prstGeom xmlns:a="http://schemas.openxmlformats.org/drawingml/2006/main" prst="rect">
             <a:avLst/>
@@ -7850,67 +9819,37 @@
           <a:lstStyle xmlns:a="http://schemas.openxmlformats.org/drawingml/2006/main"/>
           <a:p xmlns:a="http://schemas.openxmlformats.org/drawingml/2006/main">
             <a:pPr algn="l">
-              <a:defRPr sz="1575" b="1">
-                <a:solidFill>
-                  <a:srgbClr val="111111"/>
-                </a:solidFill>
-                <a:latin typeface="Helvetica Neue"/>
-                <a:ea typeface="Helvetica Neue"/>
-                <a:cs typeface="Helvetica Neue"/>
-              </a:defRPr>
-            </a:pPr>
-            <a:r>
-              <a:rPr sz="1575" b="1">
-                <a:solidFill>
-                  <a:srgbClr val="111111"/>
-                </a:solidFill>
-                <a:latin typeface="Helvetica Neue"/>
-                <a:ea typeface="Helvetica Neue"/>
-                <a:cs typeface="Helvetica Neue"/>
-              </a:rPr>
-              <a:t>Compare chatbot, workflow, and agent by control flow and tool use.</a:t>
-            </a:r>
-          </a:p>
-        </p:txBody>
-      </p:sp>
-      <p:sp>
-        <p:nvSpPr>
-          <p:cNvPr id="12" name="exam-number-4">
-            <a:extLst xmlns:a="http://schemas.openxmlformats.org/drawingml/2006/main">
-              <a:ext uri="{FF2B5EF4-FFF2-40B4-BE49-F238E27FC236}">
-                <a16:creationId xmlns:a16="http://schemas.microsoft.com/office/drawing/2014/main" id="{42D8FD84-7CAC-4D73-9965-0A696D209296}"/>
-              </a:ext>
-            </a:extLst>
-          </p:cNvPr>
-          <p:cNvSpPr>
-            <a:spLocks xmlns:a="http://schemas.openxmlformats.org/drawingml/2006/main" noGrp="1"/>
-          </p:cNvSpPr>
-          <p:nvPr/>
-        </p:nvSpPr>
-        <p:spPr>
-          <a:xfrm xmlns:a="http://schemas.openxmlformats.org/drawingml/2006/main">
-            <a:off x="6191250" y="3495675"/>
-            <a:ext cx="590550" cy="400050"/>
-          </a:xfrm>
-          <a:prstGeom xmlns:a="http://schemas.openxmlformats.org/drawingml/2006/main" prst="rect">
-            <a:avLst/>
-          </a:prstGeom>
-          <a:noFill xmlns:a="http://schemas.openxmlformats.org/drawingml/2006/main"/>
-          <a:ln xmlns:a="http://schemas.openxmlformats.org/drawingml/2006/main" w="0">
-            <a:noFill/>
-            <a:prstDash val="solid"/>
-          </a:ln>
-        </p:spPr>
-        <p:txBody>
-          <a:bodyPr xmlns:a="http://schemas.openxmlformats.org/drawingml/2006/main" anchor="t">
-            <a:noAutofit/>
-          </a:bodyPr>
-          <a:lstStyle xmlns:a="http://schemas.openxmlformats.org/drawingml/2006/main"/>
+              <a:defRPr sz="1725" b="1">
+                <a:solidFill>
+                  <a:srgbClr val="111111"/>
+                </a:solidFill>
+                <a:latin typeface="Helvetica Neue"/>
+                <a:ea typeface="Helvetica Neue"/>
+                <a:cs typeface="Helvetica Neue"/>
+              </a:defRPr>
+            </a:pPr>
+            <a:r>
+              <a:rPr sz="1725" b="1">
+                <a:solidFill>
+                  <a:srgbClr val="111111"/>
+                </a:solidFill>
+                <a:latin typeface="Helvetica Neue"/>
+                <a:ea typeface="Helvetica Neue"/>
+                <a:cs typeface="Helvetica Neue"/>
+              </a:rPr>
+              <a:t>01  Write expected outputs before implementation.</a:t>
+            </a:r>
+          </a:p>
+          <a:p xmlns:a="http://schemas.openxmlformats.org/drawingml/2006/main">
+            <a:r>
+              <a:t/>
+            </a:r>
+          </a:p>
           <a:p xmlns:a="http://schemas.openxmlformats.org/drawingml/2006/main">
             <a:pPr algn="l">
               <a:defRPr sz="1725" b="1">
                 <a:solidFill>
-                  <a:srgbClr val="B9F15B"/>
+                  <a:srgbClr val="111111"/>
                 </a:solidFill>
                 <a:latin typeface="Helvetica Neue"/>
                 <a:ea typeface="Helvetica Neue"/>
@@ -7920,113 +9859,25 @@
             <a:r>
               <a:rPr sz="1725" b="1">
                 <a:solidFill>
-                  <a:srgbClr val="B9F15B"/>
-                </a:solidFill>
-                <a:latin typeface="Helvetica Neue"/>
-                <a:ea typeface="Helvetica Neue"/>
-                <a:cs typeface="Helvetica Neue"/>
-              </a:rPr>
-              <a:t>04</a:t>
-            </a:r>
-          </a:p>
-        </p:txBody>
-      </p:sp>
-      <p:sp>
-        <p:nvSpPr>
-          <p:cNvPr id="13" name="exam-question-4">
-            <a:extLst xmlns:a="http://schemas.openxmlformats.org/drawingml/2006/main">
-              <a:ext uri="{FF2B5EF4-FFF2-40B4-BE49-F238E27FC236}">
-                <a16:creationId xmlns:a16="http://schemas.microsoft.com/office/drawing/2014/main" id="{33A57883-1AFB-40C8-8F78-CF73E1DE6ED3}"/>
-              </a:ext>
-            </a:extLst>
-          </p:cNvPr>
-          <p:cNvSpPr>
-            <a:spLocks xmlns:a="http://schemas.openxmlformats.org/drawingml/2006/main" noGrp="1"/>
-          </p:cNvSpPr>
-          <p:nvPr/>
-        </p:nvSpPr>
-        <p:spPr>
-          <a:xfrm xmlns:a="http://schemas.openxmlformats.org/drawingml/2006/main">
-            <a:off x="6877050" y="3495675"/>
-            <a:ext cx="4762500" cy="895350"/>
-          </a:xfrm>
-          <a:prstGeom xmlns:a="http://schemas.openxmlformats.org/drawingml/2006/main" prst="rect">
-            <a:avLst/>
-          </a:prstGeom>
-          <a:noFill xmlns:a="http://schemas.openxmlformats.org/drawingml/2006/main"/>
-          <a:ln xmlns:a="http://schemas.openxmlformats.org/drawingml/2006/main" w="0">
-            <a:noFill/>
-            <a:prstDash val="solid"/>
-          </a:ln>
-        </p:spPr>
-        <p:txBody>
-          <a:bodyPr xmlns:a="http://schemas.openxmlformats.org/drawingml/2006/main" anchor="t">
-            <a:normAutofit fontScale="100000"/>
-          </a:bodyPr>
-          <a:lstStyle xmlns:a="http://schemas.openxmlformats.org/drawingml/2006/main"/>
-          <a:p xmlns:a="http://schemas.openxmlformats.org/drawingml/2006/main">
-            <a:pPr algn="l">
-              <a:defRPr sz="1575" b="1">
-                <a:solidFill>
-                  <a:srgbClr val="111111"/>
-                </a:solidFill>
-                <a:latin typeface="Helvetica Neue"/>
-                <a:ea typeface="Helvetica Neue"/>
-                <a:cs typeface="Helvetica Neue"/>
-              </a:defRPr>
-            </a:pPr>
-            <a:r>
-              <a:rPr sz="1575" b="1">
-                <a:solidFill>
-                  <a:srgbClr val="111111"/>
-                </a:solidFill>
-                <a:latin typeface="Helvetica Neue"/>
-                <a:ea typeface="Helvetica Neue"/>
-                <a:cs typeface="Helvetica Neue"/>
-              </a:rPr>
-              <a:t>Name the four agent components and the responsibility of each.</a:t>
-            </a:r>
-          </a:p>
-        </p:txBody>
-      </p:sp>
-      <p:sp>
-        <p:nvSpPr>
-          <p:cNvPr id="14" name="exam-number-5">
-            <a:extLst xmlns:a="http://schemas.openxmlformats.org/drawingml/2006/main">
-              <a:ext uri="{FF2B5EF4-FFF2-40B4-BE49-F238E27FC236}">
-                <a16:creationId xmlns:a16="http://schemas.microsoft.com/office/drawing/2014/main" id="{4A19004B-E3AE-430D-A43C-7F55961FE4CB}"/>
-              </a:ext>
-            </a:extLst>
-          </p:cNvPr>
-          <p:cNvSpPr>
-            <a:spLocks xmlns:a="http://schemas.openxmlformats.org/drawingml/2006/main" noGrp="1"/>
-          </p:cNvSpPr>
-          <p:nvPr/>
-        </p:nvSpPr>
-        <p:spPr>
-          <a:xfrm xmlns:a="http://schemas.openxmlformats.org/drawingml/2006/main">
-            <a:off x="390525" y="4752975"/>
-            <a:ext cx="590550" cy="400050"/>
-          </a:xfrm>
-          <a:prstGeom xmlns:a="http://schemas.openxmlformats.org/drawingml/2006/main" prst="rect">
-            <a:avLst/>
-          </a:prstGeom>
-          <a:noFill xmlns:a="http://schemas.openxmlformats.org/drawingml/2006/main"/>
-          <a:ln xmlns:a="http://schemas.openxmlformats.org/drawingml/2006/main" w="0">
-            <a:noFill/>
-            <a:prstDash val="solid"/>
-          </a:ln>
-        </p:spPr>
-        <p:txBody>
-          <a:bodyPr xmlns:a="http://schemas.openxmlformats.org/drawingml/2006/main" anchor="t">
-            <a:noAutofit/>
-          </a:bodyPr>
-          <a:lstStyle xmlns:a="http://schemas.openxmlformats.org/drawingml/2006/main"/>
+                  <a:srgbClr val="111111"/>
+                </a:solidFill>
+                <a:latin typeface="Helvetica Neue"/>
+                <a:ea typeface="Helvetica Neue"/>
+                <a:cs typeface="Helvetica Neue"/>
+              </a:rPr>
+              <a:t>02  Keep task inputs and resource limits comparable.</a:t>
+            </a:r>
+          </a:p>
+          <a:p xmlns:a="http://schemas.openxmlformats.org/drawingml/2006/main">
+            <a:r>
+              <a:t/>
+            </a:r>
+          </a:p>
           <a:p xmlns:a="http://schemas.openxmlformats.org/drawingml/2006/main">
             <a:pPr algn="l">
               <a:defRPr sz="1725" b="1">
                 <a:solidFill>
-                  <a:srgbClr val="B9F15B"/>
+                  <a:srgbClr val="111111"/>
                 </a:solidFill>
                 <a:latin typeface="Helvetica Neue"/>
                 <a:ea typeface="Helvetica Neue"/>
@@ -8036,187 +9887,13 @@
             <a:r>
               <a:rPr sz="1725" b="1">
                 <a:solidFill>
-                  <a:srgbClr val="B9F15B"/>
-                </a:solidFill>
-                <a:latin typeface="Helvetica Neue"/>
-                <a:ea typeface="Helvetica Neue"/>
-                <a:cs typeface="Helvetica Neue"/>
-              </a:rPr>
-              <a:t>05</a:t>
-            </a:r>
-          </a:p>
-        </p:txBody>
-      </p:sp>
-      <p:sp>
-        <p:nvSpPr>
-          <p:cNvPr id="15" name="exam-question-5">
-            <a:extLst xmlns:a="http://schemas.openxmlformats.org/drawingml/2006/main">
-              <a:ext uri="{FF2B5EF4-FFF2-40B4-BE49-F238E27FC236}">
-                <a16:creationId xmlns:a16="http://schemas.microsoft.com/office/drawing/2014/main" id="{2F0F735C-DD32-47CD-803F-F6582E5AEBAA}"/>
-              </a:ext>
-            </a:extLst>
-          </p:cNvPr>
-          <p:cNvSpPr>
-            <a:spLocks xmlns:a="http://schemas.openxmlformats.org/drawingml/2006/main" noGrp="1"/>
-          </p:cNvSpPr>
-          <p:nvPr/>
-        </p:nvSpPr>
-        <p:spPr>
-          <a:xfrm xmlns:a="http://schemas.openxmlformats.org/drawingml/2006/main">
-            <a:off x="1076325" y="4752975"/>
-            <a:ext cx="4762500" cy="895350"/>
-          </a:xfrm>
-          <a:prstGeom xmlns:a="http://schemas.openxmlformats.org/drawingml/2006/main" prst="rect">
-            <a:avLst/>
-          </a:prstGeom>
-          <a:noFill xmlns:a="http://schemas.openxmlformats.org/drawingml/2006/main"/>
-          <a:ln xmlns:a="http://schemas.openxmlformats.org/drawingml/2006/main" w="0">
-            <a:noFill/>
-            <a:prstDash val="solid"/>
-          </a:ln>
-        </p:spPr>
-        <p:txBody>
-          <a:bodyPr xmlns:a="http://schemas.openxmlformats.org/drawingml/2006/main" anchor="t">
-            <a:normAutofit fontScale="100000"/>
-          </a:bodyPr>
-          <a:lstStyle xmlns:a="http://schemas.openxmlformats.org/drawingml/2006/main"/>
-          <a:p xmlns:a="http://schemas.openxmlformats.org/drawingml/2006/main">
-            <a:pPr algn="l">
-              <a:defRPr sz="1575" b="1">
-                <a:solidFill>
-                  <a:srgbClr val="111111"/>
-                </a:solidFill>
-                <a:latin typeface="Helvetica Neue"/>
-                <a:ea typeface="Helvetica Neue"/>
-                <a:cs typeface="Helvetica Neue"/>
-              </a:defRPr>
-            </a:pPr>
-            <a:r>
-              <a:rPr sz="1575" b="1">
-                <a:solidFill>
-                  <a:srgbClr val="111111"/>
-                </a:solidFill>
-                <a:latin typeface="Helvetica Neue"/>
-                <a:ea typeface="Helvetica Neue"/>
-                <a:cs typeface="Helvetica Neue"/>
-              </a:rPr>
-              <a:t>Why are typical LLM-agent environments difficult?</a:t>
-            </a:r>
-          </a:p>
-        </p:txBody>
-      </p:sp>
-      <p:sp>
-        <p:nvSpPr>
-          <p:cNvPr id="16" name="exam-number-6">
-            <a:extLst xmlns:a="http://schemas.openxmlformats.org/drawingml/2006/main">
-              <a:ext uri="{FF2B5EF4-FFF2-40B4-BE49-F238E27FC236}">
-                <a16:creationId xmlns:a16="http://schemas.microsoft.com/office/drawing/2014/main" id="{8E493865-8763-4E84-982F-583C16F22086}"/>
-              </a:ext>
-            </a:extLst>
-          </p:cNvPr>
-          <p:cNvSpPr>
-            <a:spLocks xmlns:a="http://schemas.openxmlformats.org/drawingml/2006/main" noGrp="1"/>
-          </p:cNvSpPr>
-          <p:nvPr/>
-        </p:nvSpPr>
-        <p:spPr>
-          <a:xfrm xmlns:a="http://schemas.openxmlformats.org/drawingml/2006/main">
-            <a:off x="6191250" y="4752975"/>
-            <a:ext cx="590550" cy="400050"/>
-          </a:xfrm>
-          <a:prstGeom xmlns:a="http://schemas.openxmlformats.org/drawingml/2006/main" prst="rect">
-            <a:avLst/>
-          </a:prstGeom>
-          <a:noFill xmlns:a="http://schemas.openxmlformats.org/drawingml/2006/main"/>
-          <a:ln xmlns:a="http://schemas.openxmlformats.org/drawingml/2006/main" w="0">
-            <a:noFill/>
-            <a:prstDash val="solid"/>
-          </a:ln>
-        </p:spPr>
-        <p:txBody>
-          <a:bodyPr xmlns:a="http://schemas.openxmlformats.org/drawingml/2006/main" anchor="t">
-            <a:noAutofit/>
-          </a:bodyPr>
-          <a:lstStyle xmlns:a="http://schemas.openxmlformats.org/drawingml/2006/main"/>
-          <a:p xmlns:a="http://schemas.openxmlformats.org/drawingml/2006/main">
-            <a:pPr algn="l">
-              <a:defRPr sz="1725" b="1">
-                <a:solidFill>
-                  <a:srgbClr val="B9F15B"/>
-                </a:solidFill>
-                <a:latin typeface="Helvetica Neue"/>
-                <a:ea typeface="Helvetica Neue"/>
-                <a:cs typeface="Helvetica Neue"/>
-              </a:defRPr>
-            </a:pPr>
-            <a:r>
-              <a:rPr sz="1725" b="1">
-                <a:solidFill>
-                  <a:srgbClr val="B9F15B"/>
-                </a:solidFill>
-                <a:latin typeface="Helvetica Neue"/>
-                <a:ea typeface="Helvetica Neue"/>
-                <a:cs typeface="Helvetica Neue"/>
-              </a:rPr>
-              <a:t>06</a:t>
-            </a:r>
-          </a:p>
-        </p:txBody>
-      </p:sp>
-      <p:sp>
-        <p:nvSpPr>
-          <p:cNvPr id="17" name="exam-question-6">
-            <a:extLst xmlns:a="http://schemas.openxmlformats.org/drawingml/2006/main">
-              <a:ext uri="{FF2B5EF4-FFF2-40B4-BE49-F238E27FC236}">
-                <a16:creationId xmlns:a16="http://schemas.microsoft.com/office/drawing/2014/main" id="{57FF8F4C-5EB2-4E6A-B668-A2D3AC66CA85}"/>
-              </a:ext>
-            </a:extLst>
-          </p:cNvPr>
-          <p:cNvSpPr>
-            <a:spLocks xmlns:a="http://schemas.openxmlformats.org/drawingml/2006/main" noGrp="1"/>
-          </p:cNvSpPr>
-          <p:nvPr/>
-        </p:nvSpPr>
-        <p:spPr>
-          <a:xfrm xmlns:a="http://schemas.openxmlformats.org/drawingml/2006/main">
-            <a:off x="6877050" y="4752975"/>
-            <a:ext cx="4762500" cy="895350"/>
-          </a:xfrm>
-          <a:prstGeom xmlns:a="http://schemas.openxmlformats.org/drawingml/2006/main" prst="rect">
-            <a:avLst/>
-          </a:prstGeom>
-          <a:noFill xmlns:a="http://schemas.openxmlformats.org/drawingml/2006/main"/>
-          <a:ln xmlns:a="http://schemas.openxmlformats.org/drawingml/2006/main" w="0">
-            <a:noFill/>
-            <a:prstDash val="solid"/>
-          </a:ln>
-        </p:spPr>
-        <p:txBody>
-          <a:bodyPr xmlns:a="http://schemas.openxmlformats.org/drawingml/2006/main" anchor="t">
-            <a:normAutofit fontScale="100000"/>
-          </a:bodyPr>
-          <a:lstStyle xmlns:a="http://schemas.openxmlformats.org/drawingml/2006/main"/>
-          <a:p xmlns:a="http://schemas.openxmlformats.org/drawingml/2006/main">
-            <a:pPr algn="l">
-              <a:defRPr sz="1575" b="1">
-                <a:solidFill>
-                  <a:srgbClr val="111111"/>
-                </a:solidFill>
-                <a:latin typeface="Helvetica Neue"/>
-                <a:ea typeface="Helvetica Neue"/>
-                <a:cs typeface="Helvetica Neue"/>
-              </a:defRPr>
-            </a:pPr>
-            <a:r>
-              <a:rPr sz="1575" b="1">
-                <a:solidFill>
-                  <a:srgbClr val="111111"/>
-                </a:solidFill>
-                <a:latin typeface="Helvetica Neue"/>
-                <a:ea typeface="Helvetica Neue"/>
-                <a:cs typeface="Helvetica Neue"/>
-              </a:rPr>
-              <a:t>Explain the principle of minimum sufficient autonomy.</a:t>
+                  <a:srgbClr val="111111"/>
+                </a:solidFill>
+                <a:latin typeface="Helvetica Neue"/>
+                <a:ea typeface="Helvetica Neue"/>
+                <a:cs typeface="Helvetica Neue"/>
+              </a:rPr>
+              <a:t>03  Retain the simpler design when it meets the requirements.</a:t>
             </a:r>
           </a:p>
         </p:txBody>
@@ -8224,7 +9901,7 @@
     </p:spTree>
     <p:extLst>
       <p:ext uri="{BB962C8B-B14F-4D97-AF65-F5344CB8AC3E}">
-        <p14:creationId xmlns:p14="http://schemas.microsoft.com/office/powerpoint/2010/main" val="844387902"/>
+        <p14:creationId xmlns:p14="http://schemas.microsoft.com/office/powerpoint/2010/main" val="1347769606"/>
       </p:ext>
     </p:extLst>
   </p:cSld>
@@ -8232,9 +9909,9 @@
 </file>
 
 <file path=ppt/theme/theme1.xml><?xml version="1.0" encoding="utf-8"?>
-<a:theme xmlns:a="http://schemas.openxmlformats.org/drawingml/2006/main" name="ChatGPT">
+<a:theme xmlns:a="http://schemas.openxmlformats.org/drawingml/2006/main" name="Course">
   <a:themeElements>
-    <a:clrScheme name="ChatGPT">
+    <a:clrScheme name="Course">
       <a:dk1>
         <a:srgbClr val="000000"/>
       </a:dk1>
@@ -8284,7 +9961,7 @@
         <a:cs typeface="Calibri"/>
       </a:minorFont>
     </a:fontScheme>
-    <a:fmtScheme name="ChatGPT">
+    <a:fmtScheme name="Course">
       <a:fillStyleLst>
         <a:solidFill>
           <a:schemeClr val="phClr"/>

</xml_diff>